<commit_message>
Add Tri-Fusion team and narrated Namma Civic demo
</commit_message>
<xml_diff>
--- a/submission/Namma-Civic-AI-Builder-Cup.pptx
+++ b/submission/Namma-Civic-AI-Builder-Cup.pptx
@@ -2,44 +2,44 @@
 <file path=ppt/presentation.xml><?xml version="1.0" encoding="utf-8"?>
 <p:presentation xmlns:p="http://schemas.openxmlformats.org/presentationml/2006/main" embedTrueTypeFonts="1" saveSubsetFonts="0">
   <p:sldMasterIdLst>
-    <p:sldMasterId xmlns:r="http://schemas.openxmlformats.org/officeDocument/2006/relationships" id="2147483648" r:id="Re45d64edd70b4aec"/>
+    <p:sldMasterId xmlns:r="http://schemas.openxmlformats.org/officeDocument/2006/relationships" id="2147483648" r:id="Rc011e0b6b73f40a0"/>
   </p:sldMasterIdLst>
   <p:notesMasterIdLst>
-    <p:notesMasterId xmlns:r="http://schemas.openxmlformats.org/officeDocument/2006/relationships" r:id="Rad0fb4d6e4b246b2"/>
+    <p:notesMasterId xmlns:r="http://schemas.openxmlformats.org/officeDocument/2006/relationships" r:id="R07af231e11ce4e8c"/>
   </p:notesMasterIdLst>
   <p:sldIdLst>
-    <p:sldId xmlns:r="http://schemas.openxmlformats.org/officeDocument/2006/relationships" id="256" r:id="R12cb54bb06a3476d"/>
-    <p:sldId xmlns:r="http://schemas.openxmlformats.org/officeDocument/2006/relationships" id="257" r:id="R241e629b06c04819"/>
-    <p:sldId xmlns:r="http://schemas.openxmlformats.org/officeDocument/2006/relationships" id="258" r:id="R287f81da12ce494b"/>
-    <p:sldId xmlns:r="http://schemas.openxmlformats.org/officeDocument/2006/relationships" id="259" r:id="R112926cfe3c0496b"/>
-    <p:sldId xmlns:r="http://schemas.openxmlformats.org/officeDocument/2006/relationships" id="260" r:id="Re521f75a617b44e7"/>
-    <p:sldId xmlns:r="http://schemas.openxmlformats.org/officeDocument/2006/relationships" id="261" r:id="R0b13b0c75df04e9b"/>
-    <p:sldId xmlns:r="http://schemas.openxmlformats.org/officeDocument/2006/relationships" id="262" r:id="R15bc9b20ab6d4c93"/>
-    <p:sldId xmlns:r="http://schemas.openxmlformats.org/officeDocument/2006/relationships" id="263" r:id="R35a757bd8d7f4dc8"/>
-    <p:sldId xmlns:r="http://schemas.openxmlformats.org/officeDocument/2006/relationships" id="264" r:id="Ref08c112bbaf4613"/>
-    <p:sldId xmlns:r="http://schemas.openxmlformats.org/officeDocument/2006/relationships" id="265" r:id="R529b3be82a30489f"/>
-    <p:sldId xmlns:r="http://schemas.openxmlformats.org/officeDocument/2006/relationships" id="266" r:id="R986b2208b0a247f1"/>
-    <p:sldId xmlns:r="http://schemas.openxmlformats.org/officeDocument/2006/relationships" id="267" r:id="R33411af5402a44e5"/>
-    <p:sldId xmlns:r="http://schemas.openxmlformats.org/officeDocument/2006/relationships" id="268" r:id="Rcdd9fd285de74625"/>
-    <p:sldId xmlns:r="http://schemas.openxmlformats.org/officeDocument/2006/relationships" id="269" r:id="Rb3872d72a97840aa"/>
+    <p:sldId xmlns:r="http://schemas.openxmlformats.org/officeDocument/2006/relationships" id="256" r:id="Rd0a24dab02c44610"/>
+    <p:sldId xmlns:r="http://schemas.openxmlformats.org/officeDocument/2006/relationships" id="257" r:id="R209499194ffd4a5b"/>
+    <p:sldId xmlns:r="http://schemas.openxmlformats.org/officeDocument/2006/relationships" id="258" r:id="Rfb3fca854b9c4177"/>
+    <p:sldId xmlns:r="http://schemas.openxmlformats.org/officeDocument/2006/relationships" id="259" r:id="R467473030e6c4c3f"/>
+    <p:sldId xmlns:r="http://schemas.openxmlformats.org/officeDocument/2006/relationships" id="260" r:id="Rab91cf2ee7da4eee"/>
+    <p:sldId xmlns:r="http://schemas.openxmlformats.org/officeDocument/2006/relationships" id="261" r:id="Rda1519cca36f4fe0"/>
+    <p:sldId xmlns:r="http://schemas.openxmlformats.org/officeDocument/2006/relationships" id="262" r:id="Rbe75213f7f67462f"/>
+    <p:sldId xmlns:r="http://schemas.openxmlformats.org/officeDocument/2006/relationships" id="263" r:id="R669555c86af847bf"/>
+    <p:sldId xmlns:r="http://schemas.openxmlformats.org/officeDocument/2006/relationships" id="264" r:id="Re5b8a23e155b4da3"/>
+    <p:sldId xmlns:r="http://schemas.openxmlformats.org/officeDocument/2006/relationships" id="265" r:id="R8b9d72901ff84192"/>
+    <p:sldId xmlns:r="http://schemas.openxmlformats.org/officeDocument/2006/relationships" id="266" r:id="Rb56ff92facac47c0"/>
+    <p:sldId xmlns:r="http://schemas.openxmlformats.org/officeDocument/2006/relationships" id="267" r:id="Rcb0800bb78ec4998"/>
+    <p:sldId xmlns:r="http://schemas.openxmlformats.org/officeDocument/2006/relationships" id="268" r:id="Rb25ee825a0994cf3"/>
+    <p:sldId xmlns:r="http://schemas.openxmlformats.org/officeDocument/2006/relationships" id="269" r:id="R08c460ae66ce4d2f"/>
   </p:sldIdLst>
   <p:sldSz cx="9144000" cy="5143500"/>
   <p:notesSz cx="6858000" cy="9144000"/>
   <p:embeddedFontLst>
     <p:embeddedFont>
       <p:font typeface="Google Sans Flex Medium"/>
-      <p:regular xmlns:r="http://schemas.openxmlformats.org/officeDocument/2006/relationships" r:id="R734ffb1bf4134b81"/>
-      <p:bold xmlns:r="http://schemas.openxmlformats.org/officeDocument/2006/relationships" r:id="Ra747da55e1754d64"/>
+      <p:regular xmlns:r="http://schemas.openxmlformats.org/officeDocument/2006/relationships" r:id="Reb1350d0d11f4480"/>
+      <p:bold xmlns:r="http://schemas.openxmlformats.org/officeDocument/2006/relationships" r:id="Rb0273e45ed354cb9"/>
     </p:embeddedFont>
     <p:embeddedFont>
       <p:font typeface="Google Sans Flex"/>
-      <p:regular xmlns:r="http://schemas.openxmlformats.org/officeDocument/2006/relationships" r:id="R5306b5cb0a004547"/>
-      <p:bold xmlns:r="http://schemas.openxmlformats.org/officeDocument/2006/relationships" r:id="R0efc53359f3a418a"/>
+      <p:regular xmlns:r="http://schemas.openxmlformats.org/officeDocument/2006/relationships" r:id="Rde79d3a2dd444fb5"/>
+      <p:bold xmlns:r="http://schemas.openxmlformats.org/officeDocument/2006/relationships" r:id="Rc0b930606565496c"/>
     </p:embeddedFont>
     <p:embeddedFont>
       <p:font typeface="Google Sans Flex SemiBold"/>
-      <p:regular xmlns:r="http://schemas.openxmlformats.org/officeDocument/2006/relationships" r:id="R6b4e8f65dc3a4064"/>
-      <p:bold xmlns:r="http://schemas.openxmlformats.org/officeDocument/2006/relationships" r:id="Racc6758ffc1c4ff9"/>
+      <p:regular xmlns:r="http://schemas.openxmlformats.org/officeDocument/2006/relationships" r:id="R618564091630474b"/>
+      <p:bold xmlns:r="http://schemas.openxmlformats.org/officeDocument/2006/relationships" r:id="R38afff60abbe4a67"/>
     </p:embeddedFont>
   </p:embeddedFontLst>
   <p:defaultTextStyle>
@@ -734,7 +734,7 @@
               <a:buNone/>
             </a:pPr>
             <a:r>
-              <a:t>Team details remain placeholders at the owner's explicit request. Product: Namma Civic. Proposed challenge: Sustainability &amp; Social Impact. Confirm registered team roster before submission.</a:t>
+              <a:t>Registered team: Tri-Fusion. Product: Namma Civic. Vudumula Naga sai Rahul (Leader); Mohammed Mudasser (Member); Abubakr Siddique M (Member). Names match the owner-supplied portal screenshot exactly; email addresses are omitted. Proposed challenge: Sustainability &amp; Social Impact. The exact problem-statement selection remains the owner's placeholder.</a:t>
             </a:r>
             <a:endParaRPr/>
           </a:p>
@@ -764,7 +764,7 @@
               <a:buNone/>
             </a:pPr>
             <a:r>
-              <a:t>Source: explicit owner approval in the recovered session, 17 October 2026.</a:t>
+              <a:t>Source: owner-supplied Hack2Skill portal roster screenshot and owner confirmation of the registered team name, 18 October 2026; submission/team.json.</a:t>
             </a:r>
             <a:endParaRPr/>
           </a:p>
@@ -844,7 +844,7 @@
               <a:buNone/>
             </a:pPr>
             <a:r>
-              <a:t>This template section remains an explicit readiness gap. Managed browser access was blocked in the current authoring environment. No fake screenshot was substituted. Add genuine product captures and rerender this deck before submitting.</a:t>
+              <a:t>This template section remains an explicit readiness gap. Genuine product screenshots are not included in this revision. No fake screenshot was substituted. Add verified product captures from the public prototype and rerender this deck before submitting.</a:t>
             </a:r>
             <a:endParaRPr/>
           </a:p>
@@ -954,7 +954,7 @@
               <a:buNone/>
             </a:pPr>
             <a:r>
-              <a:t>The figures on this slide are local integrity checks, not live model benchmarks. Cloud deployment and live model evaluation are deferred by owner. No Gemini category accuracy, duplicate precision/recall, evidence detection rate or latency is fabricated. A future live evaluation requires owner-directed resumption.</a:t>
+              <a:t>The figures on this slide are local integrity checks, not live model benchmarks. The owner plans Google Cloud deployment separately; current live cloud services and model evaluation are unverified. No Gemini category accuracy, duplicate precision/recall, evidence detection rate or latency is fabricated.</a:t>
             </a:r>
             <a:endParaRPr/>
           </a:p>
@@ -1219,7 +1219,7 @@
               <a:buNone/>
             </a:pPr>
             <a:r>
-              <a:t>Links remain explicit placeholders until published and checked. No repository push/publication, video upload, contest submission or live deployment is implied by this deck.</a:t>
+              <a:t>The public repository link is retained. The Vercel product URL https://lead-net-6639-eta.vercel.app/ was opened successfully in the managed browser and showed Namma Civic in local device-only demo mode. This access check does not establish connected Google Cloud integration. Only the public video URL remains pending. The owner-supplied current submission requirement is a 3-4 minute video. No video upload or contest submission is implied by this deck.</a:t>
             </a:r>
             <a:endParaRPr/>
           </a:p>
@@ -1249,7 +1249,7 @@
               <a:buNone/>
             </a:pPr>
             <a:r>
-              <a:t>Source: prescribed template; current status in submission/status.json.</a:t>
+              <a:t>Source: prescribed template; owner-supplied prototype URL, managed-browser access check and current video requirement, 18 October 2026; current status in submission/status.json.</a:t>
             </a:r>
             <a:endParaRPr/>
           </a:p>
@@ -1674,7 +1674,7 @@
               <a:buNone/>
             </a:pPr>
             <a:r>
-              <a:t>Local source implemented and checked; cloud work deferred by owner. Browser review pending.</a:t>
+              <a:t>Public Vercel device-only demonstration is accessible. Connected source is implemented; live Google Cloud integration remains unverified.</a:t>
             </a:r>
             <a:endParaRPr/>
           </a:p>
@@ -2034,7 +2034,7 @@
               <a:buNone/>
             </a:pPr>
             <a:r>
-              <a:t>This is the implemented target architecture. Firebase Hosting would serve the SPA; /api would route to Cloud Run. Admin SDK owns mutations. Vertex uses a service account, not browser API keys. Cloud deployment and live model evaluation are deferred by owner; the current review continues locally.</a:t>
+              <a:t>This is the implemented target architecture. Firebase Hosting would serve the SPA; /api would route to Cloud Run. Admin SDK owns mutations. Vertex uses a service account, not browser API keys. The public Vercel prototype is accessible in device-only demo mode. The owner plans Google Cloud deployment separately; live cloud services and model evaluation remain unverified.</a:t>
             </a:r>
             <a:endParaRPr/>
           </a:p>
@@ -2269,7 +2269,7 @@
               <a:buNone/>
             </a:pPr>
             <a:r>
-              <a:t>No cloud invoice, capacity benchmark or pricing estimate is claimed. The owner chose to continue locally, deferring cloud spending and alert configuration. Cost drivers are architecture facts, not quoted prices.</a:t>
+              <a:t>No cloud invoice, capacity benchmark or pricing estimate is claimed. The owner plans Google Cloud deployment separately; cloud spending and alert configuration are unverified. Cost drivers are architecture facts, not quoted prices.</a:t>
             </a:r>
             <a:endParaRPr/>
           </a:p>
@@ -2347,7 +2347,7 @@
           <p:cNvPr id="10" name="Google Shape;10;p2">
             <a:extLst xmlns:a="http://schemas.openxmlformats.org/drawingml/2006/main">
               <a:ext uri="{FF2B5EF4-FFF2-40B4-BE49-F238E27FC236}">
-                <a16:creationId xmlns:a16="http://schemas.microsoft.com/office/drawing/2014/main" id="{A71398D6-1304-4400-B47B-2B0E3F905359}"/>
+                <a16:creationId xmlns:a16="http://schemas.microsoft.com/office/drawing/2014/main" id="{FC63CC0D-8BF3-480C-B3C7-15970D497487}"/>
               </a:ext>
             </a:extLst>
           </p:cNvPr>
@@ -2480,7 +2480,7 @@
           <p:cNvPr id="11" name="Google Shape;11;p2">
             <a:extLst xmlns:a="http://schemas.openxmlformats.org/drawingml/2006/main">
               <a:ext uri="{FF2B5EF4-FFF2-40B4-BE49-F238E27FC236}">
-                <a16:creationId xmlns:a16="http://schemas.microsoft.com/office/drawing/2014/main" id="{CD46B470-D962-46E5-B592-086A0F8480C3}"/>
+                <a16:creationId xmlns:a16="http://schemas.microsoft.com/office/drawing/2014/main" id="{20552A75-45F6-4E86-B4E6-1B78BABA5AC6}"/>
               </a:ext>
             </a:extLst>
           </p:cNvPr>
@@ -2640,7 +2640,7 @@
           <p:cNvPr id="12" name="Google Shape;12;p2">
             <a:extLst xmlns:a="http://schemas.openxmlformats.org/drawingml/2006/main">
               <a:ext uri="{FF2B5EF4-FFF2-40B4-BE49-F238E27FC236}">
-                <a16:creationId xmlns:a16="http://schemas.microsoft.com/office/drawing/2014/main" id="{7C3F9521-BF73-48BF-BCAB-F0DEA6D479A0}"/>
+                <a16:creationId xmlns:a16="http://schemas.microsoft.com/office/drawing/2014/main" id="{254B5555-EB3C-4696-8D81-CC83CD440587}"/>
               </a:ext>
             </a:extLst>
           </p:cNvPr>
@@ -2741,7 +2741,7 @@
           <p:cNvPr id="45" name="Google Shape;45;p11">
             <a:extLst xmlns:a="http://schemas.openxmlformats.org/drawingml/2006/main">
               <a:ext uri="{FF2B5EF4-FFF2-40B4-BE49-F238E27FC236}">
-                <a16:creationId xmlns:a16="http://schemas.microsoft.com/office/drawing/2014/main" id="{074F8B01-E846-4775-9649-F0E272B70642}"/>
+                <a16:creationId xmlns:a16="http://schemas.microsoft.com/office/drawing/2014/main" id="{0A037AF8-C665-4144-883D-682A1678E806}"/>
               </a:ext>
             </a:extLst>
           </p:cNvPr>
@@ -2878,7 +2878,7 @@
           <p:cNvPr id="46" name="Google Shape;46;p11">
             <a:extLst xmlns:a="http://schemas.openxmlformats.org/drawingml/2006/main">
               <a:ext uri="{FF2B5EF4-FFF2-40B4-BE49-F238E27FC236}">
-                <a16:creationId xmlns:a16="http://schemas.microsoft.com/office/drawing/2014/main" id="{ECFB736B-D2E4-4DD0-B112-F2EA101B96BA}"/>
+                <a16:creationId xmlns:a16="http://schemas.microsoft.com/office/drawing/2014/main" id="{24766C3E-5866-4556-BE90-A2B1DB8A65F1}"/>
               </a:ext>
             </a:extLst>
           </p:cNvPr>
@@ -3011,7 +3011,7 @@
           <p:cNvPr id="47" name="Google Shape;47;p11">
             <a:extLst xmlns:a="http://schemas.openxmlformats.org/drawingml/2006/main">
               <a:ext uri="{FF2B5EF4-FFF2-40B4-BE49-F238E27FC236}">
-                <a16:creationId xmlns:a16="http://schemas.microsoft.com/office/drawing/2014/main" id="{C6E7D4A6-E649-4BDA-BAFE-3F06DC1FDCA0}"/>
+                <a16:creationId xmlns:a16="http://schemas.microsoft.com/office/drawing/2014/main" id="{B9658567-D3FE-4D67-8587-4F7BF3823605}"/>
               </a:ext>
             </a:extLst>
           </p:cNvPr>
@@ -3112,7 +3112,7 @@
           <p:cNvPr id="49" name="Google Shape;49;p12">
             <a:extLst xmlns:a="http://schemas.openxmlformats.org/drawingml/2006/main">
               <a:ext uri="{FF2B5EF4-FFF2-40B4-BE49-F238E27FC236}">
-                <a16:creationId xmlns:a16="http://schemas.microsoft.com/office/drawing/2014/main" id="{EB6CBF45-8F5E-4CF5-8B32-95AEBA01DE1F}"/>
+                <a16:creationId xmlns:a16="http://schemas.microsoft.com/office/drawing/2014/main" id="{C5E7F43D-CC0C-4FCF-9FC5-91613E7449E3}"/>
               </a:ext>
             </a:extLst>
           </p:cNvPr>
@@ -3213,7 +3213,7 @@
           <p:cNvPr id="14" name="Google Shape;14;p3">
             <a:extLst xmlns:a="http://schemas.openxmlformats.org/drawingml/2006/main">
               <a:ext uri="{FF2B5EF4-FFF2-40B4-BE49-F238E27FC236}">
-                <a16:creationId xmlns:a16="http://schemas.microsoft.com/office/drawing/2014/main" id="{1ECAFBE5-FA3E-4E32-A909-71E35027FD79}"/>
+                <a16:creationId xmlns:a16="http://schemas.microsoft.com/office/drawing/2014/main" id="{82C95F71-33BE-459E-9CBA-6120B3556F70}"/>
               </a:ext>
             </a:extLst>
           </p:cNvPr>
@@ -3346,7 +3346,7 @@
           <p:cNvPr id="15" name="Google Shape;15;p3">
             <a:extLst xmlns:a="http://schemas.openxmlformats.org/drawingml/2006/main">
               <a:ext uri="{FF2B5EF4-FFF2-40B4-BE49-F238E27FC236}">
-                <a16:creationId xmlns:a16="http://schemas.microsoft.com/office/drawing/2014/main" id="{737B37EA-62AE-4274-9C77-CDBE0BE32E91}"/>
+                <a16:creationId xmlns:a16="http://schemas.microsoft.com/office/drawing/2014/main" id="{861BF302-3E47-466E-9583-28FA615018CC}"/>
               </a:ext>
             </a:extLst>
           </p:cNvPr>
@@ -3447,7 +3447,7 @@
           <p:cNvPr id="17" name="Google Shape;17;p4">
             <a:extLst xmlns:a="http://schemas.openxmlformats.org/drawingml/2006/main">
               <a:ext uri="{FF2B5EF4-FFF2-40B4-BE49-F238E27FC236}">
-                <a16:creationId xmlns:a16="http://schemas.microsoft.com/office/drawing/2014/main" id="{D9CD99E2-8BFE-460C-84AA-FA4AE4DC4A7D}"/>
+                <a16:creationId xmlns:a16="http://schemas.microsoft.com/office/drawing/2014/main" id="{B871BC1E-A5F9-4DFF-B3B0-B5C703D24ABF}"/>
               </a:ext>
             </a:extLst>
           </p:cNvPr>
@@ -3580,7 +3580,7 @@
           <p:cNvPr id="18" name="Google Shape;18;p4">
             <a:extLst xmlns:a="http://schemas.openxmlformats.org/drawingml/2006/main">
               <a:ext uri="{FF2B5EF4-FFF2-40B4-BE49-F238E27FC236}">
-                <a16:creationId xmlns:a16="http://schemas.microsoft.com/office/drawing/2014/main" id="{4CF384F9-CEA5-4B1E-81EA-8560EFB75DB5}"/>
+                <a16:creationId xmlns:a16="http://schemas.microsoft.com/office/drawing/2014/main" id="{A9D15C40-F3F7-40D0-A3EA-F41D9C8BC139}"/>
               </a:ext>
             </a:extLst>
           </p:cNvPr>
@@ -3713,7 +3713,7 @@
           <p:cNvPr id="19" name="Google Shape;19;p4">
             <a:extLst xmlns:a="http://schemas.openxmlformats.org/drawingml/2006/main">
               <a:ext uri="{FF2B5EF4-FFF2-40B4-BE49-F238E27FC236}">
-                <a16:creationId xmlns:a16="http://schemas.microsoft.com/office/drawing/2014/main" id="{ED05AC5E-962D-4611-AF02-C07036399CCA}"/>
+                <a16:creationId xmlns:a16="http://schemas.microsoft.com/office/drawing/2014/main" id="{5AD0A6A1-5B5C-4F1C-84DB-B4C106B3FAA5}"/>
               </a:ext>
             </a:extLst>
           </p:cNvPr>
@@ -3814,7 +3814,7 @@
           <p:cNvPr id="21" name="Google Shape;21;p5">
             <a:extLst xmlns:a="http://schemas.openxmlformats.org/drawingml/2006/main">
               <a:ext uri="{FF2B5EF4-FFF2-40B4-BE49-F238E27FC236}">
-                <a16:creationId xmlns:a16="http://schemas.microsoft.com/office/drawing/2014/main" id="{C95570EB-5FAE-4625-945C-19DD32E39E3B}"/>
+                <a16:creationId xmlns:a16="http://schemas.microsoft.com/office/drawing/2014/main" id="{072EF783-C187-4CE5-97E9-D27C5D6966AD}"/>
               </a:ext>
             </a:extLst>
           </p:cNvPr>
@@ -3947,7 +3947,7 @@
           <p:cNvPr id="22" name="Google Shape;22;p5">
             <a:extLst xmlns:a="http://schemas.openxmlformats.org/drawingml/2006/main">
               <a:ext uri="{FF2B5EF4-FFF2-40B4-BE49-F238E27FC236}">
-                <a16:creationId xmlns:a16="http://schemas.microsoft.com/office/drawing/2014/main" id="{060691D3-9F09-40F7-8999-A1E2298A66C2}"/>
+                <a16:creationId xmlns:a16="http://schemas.microsoft.com/office/drawing/2014/main" id="{CF60E169-72BC-4BB8-9B84-24272721058A}"/>
               </a:ext>
             </a:extLst>
           </p:cNvPr>
@@ -4080,7 +4080,7 @@
           <p:cNvPr id="23" name="Google Shape;23;p5">
             <a:extLst xmlns:a="http://schemas.openxmlformats.org/drawingml/2006/main">
               <a:ext uri="{FF2B5EF4-FFF2-40B4-BE49-F238E27FC236}">
-                <a16:creationId xmlns:a16="http://schemas.microsoft.com/office/drawing/2014/main" id="{9AC61B51-50C1-4D8A-825B-6280E6EC29DD}"/>
+                <a16:creationId xmlns:a16="http://schemas.microsoft.com/office/drawing/2014/main" id="{32C8EA15-F16E-46F6-BB0A-81F19B891A93}"/>
               </a:ext>
             </a:extLst>
           </p:cNvPr>
@@ -4213,7 +4213,7 @@
           <p:cNvPr id="24" name="Google Shape;24;p5">
             <a:extLst xmlns:a="http://schemas.openxmlformats.org/drawingml/2006/main">
               <a:ext uri="{FF2B5EF4-FFF2-40B4-BE49-F238E27FC236}">
-                <a16:creationId xmlns:a16="http://schemas.microsoft.com/office/drawing/2014/main" id="{16B0B590-A7CB-4BA0-AFB4-227876573DF7}"/>
+                <a16:creationId xmlns:a16="http://schemas.microsoft.com/office/drawing/2014/main" id="{05126E43-5434-4F2E-B963-3CDF13F71CB5}"/>
               </a:ext>
             </a:extLst>
           </p:cNvPr>
@@ -4314,7 +4314,7 @@
           <p:cNvPr id="26" name="Google Shape;26;p6">
             <a:extLst xmlns:a="http://schemas.openxmlformats.org/drawingml/2006/main">
               <a:ext uri="{FF2B5EF4-FFF2-40B4-BE49-F238E27FC236}">
-                <a16:creationId xmlns:a16="http://schemas.microsoft.com/office/drawing/2014/main" id="{0C085159-B4F4-460B-838B-6BA76E36797D}"/>
+                <a16:creationId xmlns:a16="http://schemas.microsoft.com/office/drawing/2014/main" id="{7A6F0FEC-7B99-46D2-9806-2AFD984B31F6}"/>
               </a:ext>
             </a:extLst>
           </p:cNvPr>
@@ -4447,7 +4447,7 @@
           <p:cNvPr id="27" name="Google Shape;27;p6">
             <a:extLst xmlns:a="http://schemas.openxmlformats.org/drawingml/2006/main">
               <a:ext uri="{FF2B5EF4-FFF2-40B4-BE49-F238E27FC236}">
-                <a16:creationId xmlns:a16="http://schemas.microsoft.com/office/drawing/2014/main" id="{BD9582D2-C6F7-4E1E-AA3E-C8662A4CA959}"/>
+                <a16:creationId xmlns:a16="http://schemas.microsoft.com/office/drawing/2014/main" id="{678D2542-81CA-422C-8FC6-BB9675251086}"/>
               </a:ext>
             </a:extLst>
           </p:cNvPr>
@@ -4548,7 +4548,7 @@
           <p:cNvPr id="29" name="Google Shape;29;p7">
             <a:extLst xmlns:a="http://schemas.openxmlformats.org/drawingml/2006/main">
               <a:ext uri="{FF2B5EF4-FFF2-40B4-BE49-F238E27FC236}">
-                <a16:creationId xmlns:a16="http://schemas.microsoft.com/office/drawing/2014/main" id="{CDC71216-1177-4F74-B8AA-B14816EE7F4E}"/>
+                <a16:creationId xmlns:a16="http://schemas.microsoft.com/office/drawing/2014/main" id="{56CAF7AC-C96D-44B5-BF0E-8315DF861A2F}"/>
               </a:ext>
             </a:extLst>
           </p:cNvPr>
@@ -4681,7 +4681,7 @@
           <p:cNvPr id="30" name="Google Shape;30;p7">
             <a:extLst xmlns:a="http://schemas.openxmlformats.org/drawingml/2006/main">
               <a:ext uri="{FF2B5EF4-FFF2-40B4-BE49-F238E27FC236}">
-                <a16:creationId xmlns:a16="http://schemas.microsoft.com/office/drawing/2014/main" id="{F2B21C99-D183-4E55-9812-9617EC695952}"/>
+                <a16:creationId xmlns:a16="http://schemas.microsoft.com/office/drawing/2014/main" id="{710CAFE8-0458-47DB-AE38-5E430C7F86F4}"/>
               </a:ext>
             </a:extLst>
           </p:cNvPr>
@@ -4814,7 +4814,7 @@
           <p:cNvPr id="31" name="Google Shape;31;p7">
             <a:extLst xmlns:a="http://schemas.openxmlformats.org/drawingml/2006/main">
               <a:ext uri="{FF2B5EF4-FFF2-40B4-BE49-F238E27FC236}">
-                <a16:creationId xmlns:a16="http://schemas.microsoft.com/office/drawing/2014/main" id="{B1654048-14CB-49E8-A288-844DEF85D2C5}"/>
+                <a16:creationId xmlns:a16="http://schemas.microsoft.com/office/drawing/2014/main" id="{99F3579B-DFDF-48EC-B9ED-38E6043F46D9}"/>
               </a:ext>
             </a:extLst>
           </p:cNvPr>
@@ -4915,7 +4915,7 @@
           <p:cNvPr id="33" name="Google Shape;33;p8">
             <a:extLst xmlns:a="http://schemas.openxmlformats.org/drawingml/2006/main">
               <a:ext uri="{FF2B5EF4-FFF2-40B4-BE49-F238E27FC236}">
-                <a16:creationId xmlns:a16="http://schemas.microsoft.com/office/drawing/2014/main" id="{81ECCCFF-1021-4734-84C3-E5A21D626DFA}"/>
+                <a16:creationId xmlns:a16="http://schemas.microsoft.com/office/drawing/2014/main" id="{CC6D971F-636E-46F5-BAD3-14ACAE2ECBE1}"/>
               </a:ext>
             </a:extLst>
           </p:cNvPr>
@@ -5048,7 +5048,7 @@
           <p:cNvPr id="34" name="Google Shape;34;p8">
             <a:extLst xmlns:a="http://schemas.openxmlformats.org/drawingml/2006/main">
               <a:ext uri="{FF2B5EF4-FFF2-40B4-BE49-F238E27FC236}">
-                <a16:creationId xmlns:a16="http://schemas.microsoft.com/office/drawing/2014/main" id="{A690BE11-8DAA-46CC-AE5C-6A26662A1D13}"/>
+                <a16:creationId xmlns:a16="http://schemas.microsoft.com/office/drawing/2014/main" id="{B88E8F40-3990-44A3-976F-8D649A184C01}"/>
               </a:ext>
             </a:extLst>
           </p:cNvPr>
@@ -5149,7 +5149,7 @@
           <p:cNvPr id="36" name="Google Shape;36;p9">
             <a:extLst xmlns:a="http://schemas.openxmlformats.org/drawingml/2006/main">
               <a:ext uri="{FF2B5EF4-FFF2-40B4-BE49-F238E27FC236}">
-                <a16:creationId xmlns:a16="http://schemas.microsoft.com/office/drawing/2014/main" id="{C24D93B8-BEAA-4C5F-9EA2-181FD8E0C44E}"/>
+                <a16:creationId xmlns:a16="http://schemas.microsoft.com/office/drawing/2014/main" id="{4CA146A4-9C87-4D1E-BB4F-90F908CB100B}"/>
               </a:ext>
             </a:extLst>
           </p:cNvPr>
@@ -5200,7 +5200,7 @@
           <p:cNvPr id="37" name="Google Shape;37;p9">
             <a:extLst xmlns:a="http://schemas.openxmlformats.org/drawingml/2006/main">
               <a:ext uri="{FF2B5EF4-FFF2-40B4-BE49-F238E27FC236}">
-                <a16:creationId xmlns:a16="http://schemas.microsoft.com/office/drawing/2014/main" id="{1018CAF4-7EDF-4CB6-97A3-15E7B88E846C}"/>
+                <a16:creationId xmlns:a16="http://schemas.microsoft.com/office/drawing/2014/main" id="{D00D3371-C164-4600-A85B-7ED4FCEE1B7F}"/>
               </a:ext>
             </a:extLst>
           </p:cNvPr>
@@ -5333,7 +5333,7 @@
           <p:cNvPr id="38" name="Google Shape;38;p9">
             <a:extLst xmlns:a="http://schemas.openxmlformats.org/drawingml/2006/main">
               <a:ext uri="{FF2B5EF4-FFF2-40B4-BE49-F238E27FC236}">
-                <a16:creationId xmlns:a16="http://schemas.microsoft.com/office/drawing/2014/main" id="{DEA1547E-976C-49EA-9067-03EC57CA41E6}"/>
+                <a16:creationId xmlns:a16="http://schemas.microsoft.com/office/drawing/2014/main" id="{B13CEE89-2B84-47ED-875B-5416BE8ABA4D}"/>
               </a:ext>
             </a:extLst>
           </p:cNvPr>
@@ -5493,7 +5493,7 @@
           <p:cNvPr id="39" name="Google Shape;39;p9">
             <a:extLst xmlns:a="http://schemas.openxmlformats.org/drawingml/2006/main">
               <a:ext uri="{FF2B5EF4-FFF2-40B4-BE49-F238E27FC236}">
-                <a16:creationId xmlns:a16="http://schemas.microsoft.com/office/drawing/2014/main" id="{B49C9D2A-1B7D-40E1-9FEE-3A6B5C8E652C}"/>
+                <a16:creationId xmlns:a16="http://schemas.microsoft.com/office/drawing/2014/main" id="{7F2DB453-4952-49F4-8794-A068073D8E42}"/>
               </a:ext>
             </a:extLst>
           </p:cNvPr>
@@ -5626,7 +5626,7 @@
           <p:cNvPr id="40" name="Google Shape;40;p9">
             <a:extLst xmlns:a="http://schemas.openxmlformats.org/drawingml/2006/main">
               <a:ext uri="{FF2B5EF4-FFF2-40B4-BE49-F238E27FC236}">
-                <a16:creationId xmlns:a16="http://schemas.microsoft.com/office/drawing/2014/main" id="{D61F17A0-137D-4DCA-A85F-A4BE769C01A5}"/>
+                <a16:creationId xmlns:a16="http://schemas.microsoft.com/office/drawing/2014/main" id="{DFD65436-CB83-42EF-8AD2-05B28CF13082}"/>
               </a:ext>
             </a:extLst>
           </p:cNvPr>
@@ -5727,7 +5727,7 @@
           <p:cNvPr id="42" name="Google Shape;42;p10">
             <a:extLst xmlns:a="http://schemas.openxmlformats.org/drawingml/2006/main">
               <a:ext uri="{FF2B5EF4-FFF2-40B4-BE49-F238E27FC236}">
-                <a16:creationId xmlns:a16="http://schemas.microsoft.com/office/drawing/2014/main" id="{5B4A2263-00B1-44CC-B9B9-7675B19D890B}"/>
+                <a16:creationId xmlns:a16="http://schemas.microsoft.com/office/drawing/2014/main" id="{F61BB834-8F0E-4334-A571-D5AB56E4C27E}"/>
               </a:ext>
             </a:extLst>
           </p:cNvPr>
@@ -5775,7 +5775,7 @@
           <p:cNvPr id="43" name="Google Shape;43;p10">
             <a:extLst xmlns:a="http://schemas.openxmlformats.org/drawingml/2006/main">
               <a:ext uri="{FF2B5EF4-FFF2-40B4-BE49-F238E27FC236}">
-                <a16:creationId xmlns:a16="http://schemas.microsoft.com/office/drawing/2014/main" id="{692ADFBF-E336-489F-8FDA-64AFA556A375}"/>
+                <a16:creationId xmlns:a16="http://schemas.microsoft.com/office/drawing/2014/main" id="{CCDD6BCB-32C3-48CA-ACEC-536D156F590C}"/>
               </a:ext>
             </a:extLst>
           </p:cNvPr>
@@ -5883,7 +5883,7 @@
           <p:cNvPr id="6" name="Google Shape;6;p1">
             <a:extLst xmlns:a="http://schemas.openxmlformats.org/drawingml/2006/main">
               <a:ext uri="{FF2B5EF4-FFF2-40B4-BE49-F238E27FC236}">
-                <a16:creationId xmlns:a16="http://schemas.microsoft.com/office/drawing/2014/main" id="{80E71AC4-D059-4F55-A99F-8EF2E0539033}"/>
+                <a16:creationId xmlns:a16="http://schemas.microsoft.com/office/drawing/2014/main" id="{AB170146-5848-41F5-8E55-BE72F969577C}"/>
               </a:ext>
             </a:extLst>
           </p:cNvPr>
@@ -6083,7 +6083,7 @@
           <p:cNvPr id="7" name="Google Shape;7;p1">
             <a:extLst xmlns:a="http://schemas.openxmlformats.org/drawingml/2006/main">
               <a:ext uri="{FF2B5EF4-FFF2-40B4-BE49-F238E27FC236}">
-                <a16:creationId xmlns:a16="http://schemas.microsoft.com/office/drawing/2014/main" id="{E7588916-B83C-418B-A543-DDAE6C13F0BF}"/>
+                <a16:creationId xmlns:a16="http://schemas.microsoft.com/office/drawing/2014/main" id="{EFDD2927-5763-4BCF-8875-65EC036C1B4C}"/>
               </a:ext>
             </a:extLst>
           </p:cNvPr>
@@ -6310,7 +6310,7 @@
           <p:cNvPr id="8" name="Google Shape;8;p1">
             <a:extLst xmlns:a="http://schemas.openxmlformats.org/drawingml/2006/main">
               <a:ext uri="{FF2B5EF4-FFF2-40B4-BE49-F238E27FC236}">
-                <a16:creationId xmlns:a16="http://schemas.microsoft.com/office/drawing/2014/main" id="{F189EFFA-ECE9-46B2-B15C-18838E96B875}"/>
+                <a16:creationId xmlns:a16="http://schemas.microsoft.com/office/drawing/2014/main" id="{CD2CF0C7-F729-4593-9D33-E8287142AF6D}"/>
               </a:ext>
             </a:extLst>
           </p:cNvPr>
@@ -6433,17 +6433,17 @@
   </p:cSld>
   <p:clrMap bg1="lt1" tx1="dk1" bg2="dk2" tx2="lt2" accent1="accent1" accent2="accent2" accent3="accent3" accent4="accent4" accent5="accent5" accent6="accent6" hlink="hlink" folHlink="folHlink"/>
   <p:sldLayoutIdLst>
-    <p:sldLayoutId xmlns:r="http://schemas.openxmlformats.org/officeDocument/2006/relationships" id="2147483649" r:id="R667ea8c4aa754bb2"/>
-    <p:sldLayoutId xmlns:r="http://schemas.openxmlformats.org/officeDocument/2006/relationships" id="2147483650" r:id="R1be2f6b5c723424e"/>
-    <p:sldLayoutId xmlns:r="http://schemas.openxmlformats.org/officeDocument/2006/relationships" id="2147483651" r:id="R1e49f3c13c494095"/>
-    <p:sldLayoutId xmlns:r="http://schemas.openxmlformats.org/officeDocument/2006/relationships" id="2147483652" r:id="R025e479c7f7e40fc"/>
-    <p:sldLayoutId xmlns:r="http://schemas.openxmlformats.org/officeDocument/2006/relationships" id="2147483653" r:id="Rdbf7206e7959424f"/>
-    <p:sldLayoutId xmlns:r="http://schemas.openxmlformats.org/officeDocument/2006/relationships" id="2147483654" r:id="R66c26b30ef38456c"/>
-    <p:sldLayoutId xmlns:r="http://schemas.openxmlformats.org/officeDocument/2006/relationships" id="2147483655" r:id="R03488ce59530433d"/>
-    <p:sldLayoutId xmlns:r="http://schemas.openxmlformats.org/officeDocument/2006/relationships" id="2147483656" r:id="Rbdb4af68db5f493a"/>
-    <p:sldLayoutId xmlns:r="http://schemas.openxmlformats.org/officeDocument/2006/relationships" id="2147483657" r:id="R415cf580349247ac"/>
-    <p:sldLayoutId xmlns:r="http://schemas.openxmlformats.org/officeDocument/2006/relationships" id="2147483658" r:id="Rde0f96b03a1f4a07"/>
-    <p:sldLayoutId xmlns:r="http://schemas.openxmlformats.org/officeDocument/2006/relationships" id="2147483659" r:id="Rc421b731c8bd4339"/>
+    <p:sldLayoutId xmlns:r="http://schemas.openxmlformats.org/officeDocument/2006/relationships" id="2147483649" r:id="Red3c20cc2ee34b7f"/>
+    <p:sldLayoutId xmlns:r="http://schemas.openxmlformats.org/officeDocument/2006/relationships" id="2147483650" r:id="R9b69aaf5c62045b0"/>
+    <p:sldLayoutId xmlns:r="http://schemas.openxmlformats.org/officeDocument/2006/relationships" id="2147483651" r:id="R37a814646d1e4b1f"/>
+    <p:sldLayoutId xmlns:r="http://schemas.openxmlformats.org/officeDocument/2006/relationships" id="2147483652" r:id="R977d35b0f59e4eda"/>
+    <p:sldLayoutId xmlns:r="http://schemas.openxmlformats.org/officeDocument/2006/relationships" id="2147483653" r:id="Rc148dd8cd7244cea"/>
+    <p:sldLayoutId xmlns:r="http://schemas.openxmlformats.org/officeDocument/2006/relationships" id="2147483654" r:id="R76617868e49844f0"/>
+    <p:sldLayoutId xmlns:r="http://schemas.openxmlformats.org/officeDocument/2006/relationships" id="2147483655" r:id="R7e0876dc21d34ca5"/>
+    <p:sldLayoutId xmlns:r="http://schemas.openxmlformats.org/officeDocument/2006/relationships" id="2147483656" r:id="R4244e041c6f94e23"/>
+    <p:sldLayoutId xmlns:r="http://schemas.openxmlformats.org/officeDocument/2006/relationships" id="2147483657" r:id="Rae8aebf5ee5c4477"/>
+    <p:sldLayoutId xmlns:r="http://schemas.openxmlformats.org/officeDocument/2006/relationships" id="2147483658" r:id="R8939b7be3183438b"/>
+    <p:sldLayoutId xmlns:r="http://schemas.openxmlformats.org/officeDocument/2006/relationships" id="2147483659" r:id="R8cfe09635de24a84"/>
   </p:sldLayoutIdLst>
   <p:hf sldNum="0" hdr="0" ftr="0" dt="0"/>
   <p:txStyles>
@@ -7390,7 +7390,7 @@
           <p:cNvPr id="54" name="Google Shape;54;p13">
             <a:extLst xmlns:a="http://schemas.openxmlformats.org/drawingml/2006/main">
               <a:ext uri="{FF2B5EF4-FFF2-40B4-BE49-F238E27FC236}">
-                <a16:creationId xmlns:a16="http://schemas.microsoft.com/office/drawing/2014/main" id="{51FA16BB-43D1-4DB4-89B9-6D496A7D7AE4}"/>
+                <a16:creationId xmlns:a16="http://schemas.microsoft.com/office/drawing/2014/main" id="{BF27E4E9-D71C-4722-8C32-90847AEBEBD2}"/>
               </a:ext>
             </a:extLst>
           </p:cNvPr>
@@ -7478,7 +7478,7 @@
                 <a:ea typeface="Google Sans Flex"/>
                 <a:cs typeface="Google Sans Flex"/>
               </a:rPr>
-              <a:t>Team name: [Owner to fill]</a:t>
+              <a:t>Team name: Tri-Fusion</a:t>
             </a:r>
             <a:endParaRPr sz="1800">
               <a:latin typeface="Google Sans Flex"/>
@@ -7504,7 +7504,7 @@
                 <a:ea typeface="Google Sans Flex"/>
                 <a:cs typeface="Google Sans Flex"/>
               </a:rPr>
-              <a:t>Team leader name: [Owner to fill]</a:t>
+              <a:t>Team leader name: Vudumula Naga sai Rahul</a:t>
             </a:r>
             <a:endParaRPr sz="1800">
               <a:latin typeface="Google Sans Flex"/>
@@ -7564,7 +7564,7 @@
           <p:cNvPr id="55" name="Google Shape;55;p13">
             <a:extLst xmlns:a="http://schemas.openxmlformats.org/drawingml/2006/main">
               <a:ext uri="{FF2B5EF4-FFF2-40B4-BE49-F238E27FC236}">
-                <a16:creationId xmlns:a16="http://schemas.microsoft.com/office/drawing/2014/main" id="{402A26AF-3915-4489-8573-AE0031A72EFF}"/>
+                <a16:creationId xmlns:a16="http://schemas.microsoft.com/office/drawing/2014/main" id="{AAD4EADD-5BC8-4CD1-8D5B-B839F19A0645}"/>
               </a:ext>
             </a:extLst>
           </p:cNvPr>
@@ -7574,7 +7574,7 @@
           <p:nvPr/>
         </p:nvPicPr>
         <p:blipFill>
-          <a:blip xmlns:r="http://schemas.openxmlformats.org/officeDocument/2006/relationships" xmlns:a="http://schemas.openxmlformats.org/drawingml/2006/main" r:embed="R7c54e2beb3e64791">
+          <a:blip xmlns:r="http://schemas.openxmlformats.org/officeDocument/2006/relationships" xmlns:a="http://schemas.openxmlformats.org/drawingml/2006/main" r:embed="R760aae347bcf4004">
             <a:alphaModFix/>
           </a:blip>
           <a:stretch xmlns:a="http://schemas.openxmlformats.org/drawingml/2006/main">
@@ -7599,7 +7599,7 @@
           <p:cNvPr id="56" name="Google Shape;56;p13">
             <a:extLst xmlns:a="http://schemas.openxmlformats.org/drawingml/2006/main">
               <a:ext uri="{FF2B5EF4-FFF2-40B4-BE49-F238E27FC236}">
-                <a16:creationId xmlns:a16="http://schemas.microsoft.com/office/drawing/2014/main" id="{D55BE748-7EE2-4534-92F8-921E60127CA6}"/>
+                <a16:creationId xmlns:a16="http://schemas.microsoft.com/office/drawing/2014/main" id="{5199E191-58F3-4C14-A294-FCF498B14458}"/>
               </a:ext>
             </a:extLst>
           </p:cNvPr>
@@ -7609,7 +7609,7 @@
           <p:nvPr/>
         </p:nvPicPr>
         <p:blipFill rotWithShape="1">
-          <a:blip xmlns:r="http://schemas.openxmlformats.org/officeDocument/2006/relationships" xmlns:a="http://schemas.openxmlformats.org/drawingml/2006/main" r:embed="R2aa93bb118044241">
+          <a:blip xmlns:r="http://schemas.openxmlformats.org/officeDocument/2006/relationships" xmlns:a="http://schemas.openxmlformats.org/drawingml/2006/main" r:embed="R44b529bbc70b4243">
             <a:alphaModFix/>
           </a:blip>
           <a:srcRect xmlns:a="http://schemas.openxmlformats.org/drawingml/2006/main" l="0" t="0" r="0" b="98001"/>
@@ -7628,10 +7628,168 @@
           </a:ln>
         </p:spPr>
       </p:pic>
+      <p:sp>
+        <p:nvSpPr>
+          <p:cNvPr id="57" name="registered-team-members">
+            <a:extLst xmlns:a="http://schemas.openxmlformats.org/drawingml/2006/main">
+              <a:ext uri="{FF2B5EF4-FFF2-40B4-BE49-F238E27FC236}">
+                <a16:creationId xmlns:a16="http://schemas.microsoft.com/office/drawing/2014/main" id="{B532ABDC-7E87-4973-80EE-B2EE441602BA}"/>
+              </a:ext>
+            </a:extLst>
+          </p:cNvPr>
+          <p:cNvSpPr>
+            <a:spLocks xmlns:a="http://schemas.openxmlformats.org/drawingml/2006/main" noGrp="1"/>
+          </p:cNvSpPr>
+          <p:nvPr/>
+        </p:nvSpPr>
+        <p:spPr>
+          <a:xfrm xmlns:a="http://schemas.openxmlformats.org/drawingml/2006/main">
+            <a:off x="1152525" y="4552950"/>
+            <a:ext cx="7524750" cy="285750"/>
+          </a:xfrm>
+          <a:prstGeom xmlns:a="http://schemas.openxmlformats.org/drawingml/2006/main" prst="rect">
+            <a:avLst/>
+          </a:prstGeom>
+          <a:noFill xmlns:a="http://schemas.openxmlformats.org/drawingml/2006/main"/>
+          <a:ln xmlns:a="http://schemas.openxmlformats.org/drawingml/2006/main" w="0">
+            <a:noFill/>
+          </a:ln>
+        </p:spPr>
+        <p:txBody>
+          <a:bodyPr xmlns:a="http://schemas.openxmlformats.org/drawingml/2006/main" lIns="0" tIns="0" rIns="0" bIns="0" anchor="t">
+            <a:noAutofit/>
+          </a:bodyPr>
+          <a:lstStyle xmlns:a="http://schemas.openxmlformats.org/drawingml/2006/main">
+            <a:defPPr>
+              <a:defRPr sz="1500">
+                <a:solidFill>
+                  <a:srgbClr val="111111"/>
+                </a:solidFill>
+                <a:latin typeface="Google Sans Flex"/>
+                <a:ea typeface="Google Sans Flex"/>
+                <a:cs typeface="Google Sans Flex"/>
+              </a:defRPr>
+            </a:defPPr>
+            <a:lvl1pPr>
+              <a:defRPr sz="1500">
+                <a:solidFill>
+                  <a:srgbClr val="111111"/>
+                </a:solidFill>
+                <a:latin typeface="Google Sans Flex"/>
+                <a:ea typeface="Google Sans Flex"/>
+                <a:cs typeface="Google Sans Flex"/>
+              </a:defRPr>
+            </a:lvl1pPr>
+            <a:lvl2pPr>
+              <a:defRPr sz="1500">
+                <a:solidFill>
+                  <a:srgbClr val="111111"/>
+                </a:solidFill>
+                <a:latin typeface="Google Sans Flex"/>
+                <a:ea typeface="Google Sans Flex"/>
+                <a:cs typeface="Google Sans Flex"/>
+              </a:defRPr>
+            </a:lvl2pPr>
+            <a:lvl3pPr>
+              <a:defRPr sz="1500">
+                <a:solidFill>
+                  <a:srgbClr val="111111"/>
+                </a:solidFill>
+                <a:latin typeface="Google Sans Flex"/>
+                <a:ea typeface="Google Sans Flex"/>
+                <a:cs typeface="Google Sans Flex"/>
+              </a:defRPr>
+            </a:lvl3pPr>
+            <a:lvl4pPr>
+              <a:defRPr sz="1500">
+                <a:solidFill>
+                  <a:srgbClr val="111111"/>
+                </a:solidFill>
+                <a:latin typeface="Google Sans Flex"/>
+                <a:ea typeface="Google Sans Flex"/>
+                <a:cs typeface="Google Sans Flex"/>
+              </a:defRPr>
+            </a:lvl4pPr>
+            <a:lvl5pPr>
+              <a:defRPr sz="1500">
+                <a:solidFill>
+                  <a:srgbClr val="111111"/>
+                </a:solidFill>
+                <a:latin typeface="Google Sans Flex"/>
+                <a:ea typeface="Google Sans Flex"/>
+                <a:cs typeface="Google Sans Flex"/>
+              </a:defRPr>
+            </a:lvl5pPr>
+            <a:lvl6pPr>
+              <a:defRPr sz="1500">
+                <a:solidFill>
+                  <a:srgbClr val="111111"/>
+                </a:solidFill>
+                <a:latin typeface="Google Sans Flex"/>
+                <a:ea typeface="Google Sans Flex"/>
+                <a:cs typeface="Google Sans Flex"/>
+              </a:defRPr>
+            </a:lvl6pPr>
+            <a:lvl7pPr>
+              <a:defRPr sz="1500">
+                <a:solidFill>
+                  <a:srgbClr val="111111"/>
+                </a:solidFill>
+                <a:latin typeface="Google Sans Flex"/>
+                <a:ea typeface="Google Sans Flex"/>
+                <a:cs typeface="Google Sans Flex"/>
+              </a:defRPr>
+            </a:lvl7pPr>
+            <a:lvl8pPr>
+              <a:defRPr sz="1500">
+                <a:solidFill>
+                  <a:srgbClr val="111111"/>
+                </a:solidFill>
+                <a:latin typeface="Google Sans Flex"/>
+                <a:ea typeface="Google Sans Flex"/>
+                <a:cs typeface="Google Sans Flex"/>
+              </a:defRPr>
+            </a:lvl8pPr>
+            <a:lvl9pPr>
+              <a:defRPr sz="1500">
+                <a:solidFill>
+                  <a:srgbClr val="111111"/>
+                </a:solidFill>
+                <a:latin typeface="Google Sans Flex"/>
+                <a:ea typeface="Google Sans Flex"/>
+                <a:cs typeface="Google Sans Flex"/>
+              </a:defRPr>
+            </a:lvl9pPr>
+          </a:lstStyle>
+          <a:p xmlns:a="http://schemas.openxmlformats.org/drawingml/2006/main">
+            <a:pPr>
+              <a:defRPr sz="1500">
+                <a:solidFill>
+                  <a:srgbClr val="111111"/>
+                </a:solidFill>
+                <a:latin typeface="Google Sans Flex"/>
+                <a:ea typeface="Google Sans Flex"/>
+                <a:cs typeface="Google Sans Flex"/>
+              </a:defRPr>
+            </a:pPr>
+            <a:r>
+              <a:rPr sz="1500">
+                <a:solidFill>
+                  <a:srgbClr val="111111"/>
+                </a:solidFill>
+                <a:latin typeface="Google Sans Flex"/>
+                <a:ea typeface="Google Sans Flex"/>
+                <a:cs typeface="Google Sans Flex"/>
+              </a:rPr>
+              <a:t>Team members: Mohammed Mudasser; Abubakr Siddique M</a:t>
+            </a:r>
+          </a:p>
+        </p:txBody>
+      </p:sp>
     </p:spTree>
     <p:extLst>
       <p:ext uri="{BB962C8B-B14F-4D97-AF65-F5344CB8AC3E}">
-        <p14:creationId xmlns:p14="http://schemas.microsoft.com/office/powerpoint/2010/main" val="1430420286"/>
+        <p14:creationId xmlns:p14="http://schemas.microsoft.com/office/powerpoint/2010/main" val="1207240301"/>
       </p:ext>
     </p:extLst>
   </p:cSld>
@@ -7655,7 +7813,7 @@
           <p:cNvPr id="132" name="Google Shape;132;p23">
             <a:extLst xmlns:a="http://schemas.openxmlformats.org/drawingml/2006/main">
               <a:ext uri="{FF2B5EF4-FFF2-40B4-BE49-F238E27FC236}">
-                <a16:creationId xmlns:a16="http://schemas.microsoft.com/office/drawing/2014/main" id="{564EA5F1-FE45-4168-BC69-F9BE77DDC433}"/>
+                <a16:creationId xmlns:a16="http://schemas.microsoft.com/office/drawing/2014/main" id="{1F334AA6-FDB3-4D95-9250-5B72C4D27DFE}"/>
               </a:ext>
             </a:extLst>
           </p:cNvPr>
@@ -7665,7 +7823,7 @@
           <p:nvPr/>
         </p:nvPicPr>
         <p:blipFill rotWithShape="1">
-          <a:blip xmlns:r="http://schemas.openxmlformats.org/officeDocument/2006/relationships" xmlns:a="http://schemas.openxmlformats.org/drawingml/2006/main" r:embed="Re67e0b6d4f0c47f3">
+          <a:blip xmlns:r="http://schemas.openxmlformats.org/officeDocument/2006/relationships" xmlns:a="http://schemas.openxmlformats.org/drawingml/2006/main" r:embed="Re6b292ef7c884ccd">
             <a:alphaModFix/>
           </a:blip>
           <a:srcRect xmlns:a="http://schemas.openxmlformats.org/drawingml/2006/main" l="0" t="0" r="0" b="98001"/>
@@ -7689,7 +7847,7 @@
           <p:cNvPr id="133" name="Google Shape;133;p23">
             <a:extLst xmlns:a="http://schemas.openxmlformats.org/drawingml/2006/main">
               <a:ext uri="{FF2B5EF4-FFF2-40B4-BE49-F238E27FC236}">
-                <a16:creationId xmlns:a16="http://schemas.microsoft.com/office/drawing/2014/main" id="{A5DDC740-1FF8-4E83-B1DB-17C8B54466A1}"/>
+                <a16:creationId xmlns:a16="http://schemas.microsoft.com/office/drawing/2014/main" id="{AC683C62-290A-4658-9D4D-ABD06DC44529}"/>
               </a:ext>
             </a:extLst>
           </p:cNvPr>
@@ -7699,7 +7857,7 @@
           <p:nvPr/>
         </p:nvPicPr>
         <p:blipFill>
-          <a:blip xmlns:r="http://schemas.openxmlformats.org/officeDocument/2006/relationships" xmlns:a="http://schemas.openxmlformats.org/drawingml/2006/main" r:embed="R24eb3f6e6ac042e8">
+          <a:blip xmlns:r="http://schemas.openxmlformats.org/officeDocument/2006/relationships" xmlns:a="http://schemas.openxmlformats.org/drawingml/2006/main" r:embed="R0134ccb645fe4103">
             <a:alphaModFix/>
           </a:blip>
           <a:stretch xmlns:a="http://schemas.openxmlformats.org/drawingml/2006/main">
@@ -7724,7 +7882,7 @@
           <p:cNvPr id="134" name="Google Shape;134;p23">
             <a:extLst xmlns:a="http://schemas.openxmlformats.org/drawingml/2006/main">
               <a:ext uri="{FF2B5EF4-FFF2-40B4-BE49-F238E27FC236}">
-                <a16:creationId xmlns:a16="http://schemas.microsoft.com/office/drawing/2014/main" id="{EEFE65A2-B2B1-4B7E-B458-BE3EC3E56832}"/>
+                <a16:creationId xmlns:a16="http://schemas.microsoft.com/office/drawing/2014/main" id="{699F1F48-3921-486C-B728-F7BE168626EF}"/>
               </a:ext>
             </a:extLst>
           </p:cNvPr>
@@ -7775,7 +7933,7 @@
           <p:cNvPr id="135" name="Google Shape;135;p23">
             <a:extLst xmlns:a="http://schemas.openxmlformats.org/drawingml/2006/main">
               <a:ext uri="{FF2B5EF4-FFF2-40B4-BE49-F238E27FC236}">
-                <a16:creationId xmlns:a16="http://schemas.microsoft.com/office/drawing/2014/main" id="{8F72D3B9-9239-48A4-AFD8-E6FCECDE274E}"/>
+                <a16:creationId xmlns:a16="http://schemas.microsoft.com/office/drawing/2014/main" id="{2841BC2D-4463-4DC1-93E3-991B821E842D}"/>
               </a:ext>
             </a:extLst>
           </p:cNvPr>
@@ -7833,7 +7991,7 @@
           <p:cNvPr id="136" name="snapshot-status">
             <a:extLst xmlns:a="http://schemas.openxmlformats.org/drawingml/2006/main">
               <a:ext uri="{FF2B5EF4-FFF2-40B4-BE49-F238E27FC236}">
-                <a16:creationId xmlns:a16="http://schemas.microsoft.com/office/drawing/2014/main" id="{CCEAF44B-7A8C-44E8-9D64-831D6807C280}"/>
+                <a16:creationId xmlns:a16="http://schemas.microsoft.com/office/drawing/2014/main" id="{F5EA9E4D-3C1A-414B-B9D9-7513C083AF0B}"/>
               </a:ext>
             </a:extLst>
           </p:cNvPr>
@@ -7991,7 +8149,7 @@
           <p:cNvPr id="137" name="snapshot-truth">
             <a:extLst xmlns:a="http://schemas.openxmlformats.org/drawingml/2006/main">
               <a:ext uri="{FF2B5EF4-FFF2-40B4-BE49-F238E27FC236}">
-                <a16:creationId xmlns:a16="http://schemas.microsoft.com/office/drawing/2014/main" id="{FA25CC6F-7C74-4C83-8D6D-3631A4796EDE}"/>
+                <a16:creationId xmlns:a16="http://schemas.microsoft.com/office/drawing/2014/main" id="{E6BDEC69-76A2-443E-9461-D39D1B4CC762}"/>
               </a:ext>
             </a:extLst>
           </p:cNvPr>
@@ -8149,7 +8307,7 @@
           <p:cNvPr id="138" name="separator">
             <a:extLst xmlns:a="http://schemas.openxmlformats.org/drawingml/2006/main">
               <a:ext uri="{FF2B5EF4-FFF2-40B4-BE49-F238E27FC236}">
-                <a16:creationId xmlns:a16="http://schemas.microsoft.com/office/drawing/2014/main" id="{B30D2C95-585B-444A-8168-1135FB32B733}"/>
+                <a16:creationId xmlns:a16="http://schemas.microsoft.com/office/drawing/2014/main" id="{6B6EF0AE-ADE8-4C6D-9F7E-632697C5B7B2}"/>
               </a:ext>
             </a:extLst>
           </p:cNvPr>
@@ -8181,7 +8339,7 @@
           <p:cNvPr id="139" name="capture-a">
             <a:extLst xmlns:a="http://schemas.openxmlformats.org/drawingml/2006/main">
               <a:ext uri="{FF2B5EF4-FFF2-40B4-BE49-F238E27FC236}">
-                <a16:creationId xmlns:a16="http://schemas.microsoft.com/office/drawing/2014/main" id="{FEA56A56-3A2A-4CF6-9BE4-7964416F89B3}"/>
+                <a16:creationId xmlns:a16="http://schemas.microsoft.com/office/drawing/2014/main" id="{D93B43E1-DF9D-463C-BA9D-876A0C7CB198}"/>
               </a:ext>
             </a:extLst>
           </p:cNvPr>
@@ -8339,7 +8497,7 @@
           <p:cNvPr id="140" name="capture-a-copy">
             <a:extLst xmlns:a="http://schemas.openxmlformats.org/drawingml/2006/main">
               <a:ext uri="{FF2B5EF4-FFF2-40B4-BE49-F238E27FC236}">
-                <a16:creationId xmlns:a16="http://schemas.microsoft.com/office/drawing/2014/main" id="{84939E6A-9811-4827-9E77-39B14106E181}"/>
+                <a16:creationId xmlns:a16="http://schemas.microsoft.com/office/drawing/2014/main" id="{83BB3CAE-9C6B-43D3-B9D9-E879081BD74F}"/>
               </a:ext>
             </a:extLst>
           </p:cNvPr>
@@ -8520,7 +8678,7 @@
           <p:cNvPr id="141" name="capture-b">
             <a:extLst xmlns:a="http://schemas.openxmlformats.org/drawingml/2006/main">
               <a:ext uri="{FF2B5EF4-FFF2-40B4-BE49-F238E27FC236}">
-                <a16:creationId xmlns:a16="http://schemas.microsoft.com/office/drawing/2014/main" id="{6FCBF3CE-A2AF-4716-94A1-26F51E81203D}"/>
+                <a16:creationId xmlns:a16="http://schemas.microsoft.com/office/drawing/2014/main" id="{3876735A-CDCF-4DE1-865B-4E64C901E475}"/>
               </a:ext>
             </a:extLst>
           </p:cNvPr>
@@ -8678,7 +8836,7 @@
           <p:cNvPr id="142" name="capture-b-copy">
             <a:extLst xmlns:a="http://schemas.openxmlformats.org/drawingml/2006/main">
               <a:ext uri="{FF2B5EF4-FFF2-40B4-BE49-F238E27FC236}">
-                <a16:creationId xmlns:a16="http://schemas.microsoft.com/office/drawing/2014/main" id="{5A827683-9371-4186-A3C5-F29CB39915F4}"/>
+                <a16:creationId xmlns:a16="http://schemas.microsoft.com/office/drawing/2014/main" id="{4A664BC4-DEC7-4CC6-A518-4B68E2918E57}"/>
               </a:ext>
             </a:extLst>
           </p:cNvPr>
@@ -8857,7 +9015,7 @@
     </p:spTree>
     <p:extLst>
       <p:ext uri="{BB962C8B-B14F-4D97-AF65-F5344CB8AC3E}">
-        <p14:creationId xmlns:p14="http://schemas.microsoft.com/office/powerpoint/2010/main" val="1649641466"/>
+        <p14:creationId xmlns:p14="http://schemas.microsoft.com/office/powerpoint/2010/main" val="1551303525"/>
       </p:ext>
     </p:extLst>
   </p:cSld>
@@ -8881,7 +9039,7 @@
           <p:cNvPr id="140" name="Google Shape;140;p24">
             <a:extLst xmlns:a="http://schemas.openxmlformats.org/drawingml/2006/main">
               <a:ext uri="{FF2B5EF4-FFF2-40B4-BE49-F238E27FC236}">
-                <a16:creationId xmlns:a16="http://schemas.microsoft.com/office/drawing/2014/main" id="{81F74950-6C35-422B-992C-089F1990008A}"/>
+                <a16:creationId xmlns:a16="http://schemas.microsoft.com/office/drawing/2014/main" id="{892AEE7E-12DE-438F-88F1-7B1C7F9C74D1}"/>
               </a:ext>
             </a:extLst>
           </p:cNvPr>
@@ -8891,7 +9049,7 @@
           <p:nvPr/>
         </p:nvPicPr>
         <p:blipFill rotWithShape="1">
-          <a:blip xmlns:r="http://schemas.openxmlformats.org/officeDocument/2006/relationships" xmlns:a="http://schemas.openxmlformats.org/drawingml/2006/main" r:embed="R3f2a051d50e445c4">
+          <a:blip xmlns:r="http://schemas.openxmlformats.org/officeDocument/2006/relationships" xmlns:a="http://schemas.openxmlformats.org/drawingml/2006/main" r:embed="R00322f565a5e4cd1">
             <a:alphaModFix/>
           </a:blip>
           <a:srcRect xmlns:a="http://schemas.openxmlformats.org/drawingml/2006/main" l="0" t="0" r="0" b="98001"/>
@@ -8915,7 +9073,7 @@
           <p:cNvPr id="141" name="Google Shape;141;p24">
             <a:extLst xmlns:a="http://schemas.openxmlformats.org/drawingml/2006/main">
               <a:ext uri="{FF2B5EF4-FFF2-40B4-BE49-F238E27FC236}">
-                <a16:creationId xmlns:a16="http://schemas.microsoft.com/office/drawing/2014/main" id="{72FFC89C-B7D1-468B-B1FD-C031A420AA24}"/>
+                <a16:creationId xmlns:a16="http://schemas.microsoft.com/office/drawing/2014/main" id="{CD9565D4-D705-4865-8B1E-6C0FA5000BA3}"/>
               </a:ext>
             </a:extLst>
           </p:cNvPr>
@@ -8925,7 +9083,7 @@
           <p:nvPr/>
         </p:nvPicPr>
         <p:blipFill>
-          <a:blip xmlns:r="http://schemas.openxmlformats.org/officeDocument/2006/relationships" xmlns:a="http://schemas.openxmlformats.org/drawingml/2006/main" r:embed="R598c73e0b4ce4a30">
+          <a:blip xmlns:r="http://schemas.openxmlformats.org/officeDocument/2006/relationships" xmlns:a="http://schemas.openxmlformats.org/drawingml/2006/main" r:embed="Rce2acac53f0f48f8">
             <a:alphaModFix/>
           </a:blip>
           <a:stretch xmlns:a="http://schemas.openxmlformats.org/drawingml/2006/main">
@@ -8950,7 +9108,7 @@
           <p:cNvPr id="142" name="Google Shape;142;p24">
             <a:extLst xmlns:a="http://schemas.openxmlformats.org/drawingml/2006/main">
               <a:ext uri="{FF2B5EF4-FFF2-40B4-BE49-F238E27FC236}">
-                <a16:creationId xmlns:a16="http://schemas.microsoft.com/office/drawing/2014/main" id="{0320B354-A486-42BA-8741-D1B4F8EA5543}"/>
+                <a16:creationId xmlns:a16="http://schemas.microsoft.com/office/drawing/2014/main" id="{FC5911BC-C44A-443B-B7DA-0F22514615BE}"/>
               </a:ext>
             </a:extLst>
           </p:cNvPr>
@@ -9001,7 +9159,7 @@
           <p:cNvPr id="143" name="Google Shape;143;p24">
             <a:extLst xmlns:a="http://schemas.openxmlformats.org/drawingml/2006/main">
               <a:ext uri="{FF2B5EF4-FFF2-40B4-BE49-F238E27FC236}">
-                <a16:creationId xmlns:a16="http://schemas.microsoft.com/office/drawing/2014/main" id="{784B22F1-1C83-4117-BCD4-284494000297}"/>
+                <a16:creationId xmlns:a16="http://schemas.microsoft.com/office/drawing/2014/main" id="{532728AC-5AFC-4086-AA95-C018466D4FCF}"/>
               </a:ext>
             </a:extLst>
           </p:cNvPr>
@@ -9059,7 +9217,7 @@
           <p:cNvPr id="144" name="test-label-0">
             <a:extLst xmlns:a="http://schemas.openxmlformats.org/drawingml/2006/main">
               <a:ext uri="{FF2B5EF4-FFF2-40B4-BE49-F238E27FC236}">
-                <a16:creationId xmlns:a16="http://schemas.microsoft.com/office/drawing/2014/main" id="{7280CEE6-AF60-4DB2-A28A-7F34D42B1514}"/>
+                <a16:creationId xmlns:a16="http://schemas.microsoft.com/office/drawing/2014/main" id="{2AAD18AF-1409-466F-8ECC-C4D25A6D6B34}"/>
               </a:ext>
             </a:extLst>
           </p:cNvPr>
@@ -9217,7 +9375,7 @@
           <p:cNvPr id="145" name="test-value-0">
             <a:extLst xmlns:a="http://schemas.openxmlformats.org/drawingml/2006/main">
               <a:ext uri="{FF2B5EF4-FFF2-40B4-BE49-F238E27FC236}">
-                <a16:creationId xmlns:a16="http://schemas.microsoft.com/office/drawing/2014/main" id="{3005AB9A-7EFB-4EB5-BB90-43EEE38D75A0}"/>
+                <a16:creationId xmlns:a16="http://schemas.microsoft.com/office/drawing/2014/main" id="{1DC22472-6479-4C34-9F39-DF0745EEE434}"/>
               </a:ext>
             </a:extLst>
           </p:cNvPr>
@@ -9375,7 +9533,7 @@
           <p:cNvPr id="146" name="test-label-1">
             <a:extLst xmlns:a="http://schemas.openxmlformats.org/drawingml/2006/main">
               <a:ext uri="{FF2B5EF4-FFF2-40B4-BE49-F238E27FC236}">
-                <a16:creationId xmlns:a16="http://schemas.microsoft.com/office/drawing/2014/main" id="{970D72C3-944C-4233-B7E0-99330EA96AFE}"/>
+                <a16:creationId xmlns:a16="http://schemas.microsoft.com/office/drawing/2014/main" id="{6789B630-A3E2-4348-851B-18F4447F7390}"/>
               </a:ext>
             </a:extLst>
           </p:cNvPr>
@@ -9533,7 +9691,7 @@
           <p:cNvPr id="147" name="test-value-1">
             <a:extLst xmlns:a="http://schemas.openxmlformats.org/drawingml/2006/main">
               <a:ext uri="{FF2B5EF4-FFF2-40B4-BE49-F238E27FC236}">
-                <a16:creationId xmlns:a16="http://schemas.microsoft.com/office/drawing/2014/main" id="{7336853D-2255-4C77-BF94-06293165F696}"/>
+                <a16:creationId xmlns:a16="http://schemas.microsoft.com/office/drawing/2014/main" id="{2C10DCC1-F220-4A4D-AFCF-407F2C223DA7}"/>
               </a:ext>
             </a:extLst>
           </p:cNvPr>
@@ -9691,7 +9849,7 @@
           <p:cNvPr id="148" name="test-label-2">
             <a:extLst xmlns:a="http://schemas.openxmlformats.org/drawingml/2006/main">
               <a:ext uri="{FF2B5EF4-FFF2-40B4-BE49-F238E27FC236}">
-                <a16:creationId xmlns:a16="http://schemas.microsoft.com/office/drawing/2014/main" id="{3014107D-A1CA-4546-8BAC-463ED6391553}"/>
+                <a16:creationId xmlns:a16="http://schemas.microsoft.com/office/drawing/2014/main" id="{B34F932A-802F-4F17-A30A-471F505A6726}"/>
               </a:ext>
             </a:extLst>
           </p:cNvPr>
@@ -9849,7 +10007,7 @@
           <p:cNvPr id="149" name="test-value-2">
             <a:extLst xmlns:a="http://schemas.openxmlformats.org/drawingml/2006/main">
               <a:ext uri="{FF2B5EF4-FFF2-40B4-BE49-F238E27FC236}">
-                <a16:creationId xmlns:a16="http://schemas.microsoft.com/office/drawing/2014/main" id="{C86A205D-7E0B-4C1F-AAF6-F62AAB34F617}"/>
+                <a16:creationId xmlns:a16="http://schemas.microsoft.com/office/drawing/2014/main" id="{DC6B5378-0BB1-4A87-A004-79672B1A2C69}"/>
               </a:ext>
             </a:extLst>
           </p:cNvPr>
@@ -10007,7 +10165,7 @@
           <p:cNvPr id="150" name="test-label-3">
             <a:extLst xmlns:a="http://schemas.openxmlformats.org/drawingml/2006/main">
               <a:ext uri="{FF2B5EF4-FFF2-40B4-BE49-F238E27FC236}">
-                <a16:creationId xmlns:a16="http://schemas.microsoft.com/office/drawing/2014/main" id="{F8B44755-BD54-4074-BD72-D7723035EE59}"/>
+                <a16:creationId xmlns:a16="http://schemas.microsoft.com/office/drawing/2014/main" id="{1EE30307-302F-4430-948A-DD9DA65A5F42}"/>
               </a:ext>
             </a:extLst>
           </p:cNvPr>
@@ -10165,7 +10323,7 @@
           <p:cNvPr id="151" name="test-value-3">
             <a:extLst xmlns:a="http://schemas.openxmlformats.org/drawingml/2006/main">
               <a:ext uri="{FF2B5EF4-FFF2-40B4-BE49-F238E27FC236}">
-                <a16:creationId xmlns:a16="http://schemas.microsoft.com/office/drawing/2014/main" id="{52FFBD96-CDDF-4B84-AF0C-34DDBEC263E8}"/>
+                <a16:creationId xmlns:a16="http://schemas.microsoft.com/office/drawing/2014/main" id="{9550AEA2-58E9-4F5A-A71E-6DD952F1B3F5}"/>
               </a:ext>
             </a:extLst>
           </p:cNvPr>
@@ -10323,7 +10481,7 @@
           <p:cNvPr id="152" name="separator">
             <a:extLst xmlns:a="http://schemas.openxmlformats.org/drawingml/2006/main">
               <a:ext uri="{FF2B5EF4-FFF2-40B4-BE49-F238E27FC236}">
-                <a16:creationId xmlns:a16="http://schemas.microsoft.com/office/drawing/2014/main" id="{0BCC2DC0-B8F3-458B-808C-DC72621D3C20}"/>
+                <a16:creationId xmlns:a16="http://schemas.microsoft.com/office/drawing/2014/main" id="{23E42D79-6C3C-4818-ACA2-6EA0BD6CD6B0}"/>
               </a:ext>
             </a:extLst>
           </p:cNvPr>
@@ -10355,7 +10513,7 @@
           <p:cNvPr id="153" name="benchmark-pending">
             <a:extLst xmlns:a="http://schemas.openxmlformats.org/drawingml/2006/main">
               <a:ext uri="{FF2B5EF4-FFF2-40B4-BE49-F238E27FC236}">
-                <a16:creationId xmlns:a16="http://schemas.microsoft.com/office/drawing/2014/main" id="{9BAC84E9-B060-4A15-8FAF-55B7873CF79A}"/>
+                <a16:creationId xmlns:a16="http://schemas.microsoft.com/office/drawing/2014/main" id="{4BF96C4E-8DFA-4635-BCDD-F1A0B0DE34E5}"/>
               </a:ext>
             </a:extLst>
           </p:cNvPr>
@@ -10366,8 +10524,8 @@
         </p:nvSpPr>
         <p:spPr>
           <a:xfrm xmlns:a="http://schemas.openxmlformats.org/drawingml/2006/main">
-            <a:off x="495300" y="3810000"/>
-            <a:ext cx="8153400" cy="742950"/>
+            <a:off x="495300" y="3752850"/>
+            <a:ext cx="8153400" cy="1028700"/>
           </a:xfrm>
           <a:prstGeom xmlns:a="http://schemas.openxmlformats.org/drawingml/2006/main" prst="rect">
             <a:avLst/>
@@ -10383,7 +10541,7 @@
           </a:bodyPr>
           <a:lstStyle xmlns:a="http://schemas.openxmlformats.org/drawingml/2006/main">
             <a:defPPr>
-              <a:defRPr sz="1725" b="1">
+              <a:defRPr sz="1575" b="1">
                 <a:solidFill>
                   <a:srgbClr val="A52722"/>
                 </a:solidFill>
@@ -10393,7 +10551,7 @@
               </a:defRPr>
             </a:defPPr>
             <a:lvl1pPr>
-              <a:defRPr sz="1725" b="1">
+              <a:defRPr sz="1575" b="1">
                 <a:solidFill>
                   <a:srgbClr val="A52722"/>
                 </a:solidFill>
@@ -10403,7 +10561,7 @@
               </a:defRPr>
             </a:lvl1pPr>
             <a:lvl2pPr>
-              <a:defRPr sz="1725" b="1">
+              <a:defRPr sz="1575" b="1">
                 <a:solidFill>
                   <a:srgbClr val="A52722"/>
                 </a:solidFill>
@@ -10413,7 +10571,7 @@
               </a:defRPr>
             </a:lvl2pPr>
             <a:lvl3pPr>
-              <a:defRPr sz="1725" b="1">
+              <a:defRPr sz="1575" b="1">
                 <a:solidFill>
                   <a:srgbClr val="A52722"/>
                 </a:solidFill>
@@ -10423,7 +10581,7 @@
               </a:defRPr>
             </a:lvl3pPr>
             <a:lvl4pPr>
-              <a:defRPr sz="1725" b="1">
+              <a:defRPr sz="1575" b="1">
                 <a:solidFill>
                   <a:srgbClr val="A52722"/>
                 </a:solidFill>
@@ -10433,7 +10591,7 @@
               </a:defRPr>
             </a:lvl4pPr>
             <a:lvl5pPr>
-              <a:defRPr sz="1725" b="1">
+              <a:defRPr sz="1575" b="1">
                 <a:solidFill>
                   <a:srgbClr val="A52722"/>
                 </a:solidFill>
@@ -10443,7 +10601,7 @@
               </a:defRPr>
             </a:lvl5pPr>
             <a:lvl6pPr>
-              <a:defRPr sz="1725" b="1">
+              <a:defRPr sz="1575" b="1">
                 <a:solidFill>
                   <a:srgbClr val="A52722"/>
                 </a:solidFill>
@@ -10453,7 +10611,7 @@
               </a:defRPr>
             </a:lvl6pPr>
             <a:lvl7pPr>
-              <a:defRPr sz="1725" b="1">
+              <a:defRPr sz="1575" b="1">
                 <a:solidFill>
                   <a:srgbClr val="A52722"/>
                 </a:solidFill>
@@ -10463,7 +10621,7 @@
               </a:defRPr>
             </a:lvl7pPr>
             <a:lvl8pPr>
-              <a:defRPr sz="1725" b="1">
+              <a:defRPr sz="1575" b="1">
                 <a:solidFill>
                   <a:srgbClr val="A52722"/>
                 </a:solidFill>
@@ -10473,7 +10631,7 @@
               </a:defRPr>
             </a:lvl8pPr>
             <a:lvl9pPr>
-              <a:defRPr sz="1725" b="1">
+              <a:defRPr sz="1575" b="1">
                 <a:solidFill>
                   <a:srgbClr val="A52722"/>
                 </a:solidFill>
@@ -10485,7 +10643,7 @@
           </a:lstStyle>
           <a:p xmlns:a="http://schemas.openxmlformats.org/drawingml/2006/main">
             <a:pPr>
-              <a:defRPr sz="1725" b="1">
+              <a:defRPr sz="1575" b="1">
                 <a:solidFill>
                   <a:srgbClr val="A52722"/>
                 </a:solidFill>
@@ -10495,7 +10653,7 @@
               </a:defRPr>
             </a:pPr>
             <a:r>
-              <a:rPr sz="1725" b="1">
+              <a:rPr sz="1575" b="1">
                 <a:solidFill>
                   <a:srgbClr val="A52722"/>
                 </a:solidFill>
@@ -10503,12 +10661,12 @@
                 <a:ea typeface="Google Sans Flex"/>
                 <a:cs typeface="Google Sans Flex"/>
               </a:rPr>
-              <a:t>Cloud deployment and live model evaluation deferred by owner</a:t>
+              <a:t>Owner plans Google Cloud deployment separately; current live cloud services and model evaluation are unverified.</a:t>
             </a:r>
           </a:p>
           <a:p xmlns:a="http://schemas.openxmlformats.org/drawingml/2006/main">
             <a:pPr>
-              <a:defRPr sz="1725" b="1">
+              <a:defRPr sz="1575" b="1">
                 <a:solidFill>
                   <a:srgbClr val="A52722"/>
                 </a:solidFill>
@@ -10518,7 +10676,7 @@
               </a:defRPr>
             </a:pPr>
             <a:r>
-              <a:rPr sz="1725" b="1">
+              <a:rPr sz="1575" b="1">
                 <a:solidFill>
                   <a:srgbClr val="A52722"/>
                 </a:solidFill>
@@ -10534,7 +10692,7 @@
     </p:spTree>
     <p:extLst>
       <p:ext uri="{BB962C8B-B14F-4D97-AF65-F5344CB8AC3E}">
-        <p14:creationId xmlns:p14="http://schemas.microsoft.com/office/powerpoint/2010/main" val="166489384"/>
+        <p14:creationId xmlns:p14="http://schemas.microsoft.com/office/powerpoint/2010/main" val="655012737"/>
       </p:ext>
     </p:extLst>
   </p:cSld>
@@ -10558,7 +10716,7 @@
           <p:cNvPr id="148" name="Google Shape;148;p25">
             <a:extLst xmlns:a="http://schemas.openxmlformats.org/drawingml/2006/main">
               <a:ext uri="{FF2B5EF4-FFF2-40B4-BE49-F238E27FC236}">
-                <a16:creationId xmlns:a16="http://schemas.microsoft.com/office/drawing/2014/main" id="{FFFBAF9F-0582-4A8F-BCEA-0770D4DC5126}"/>
+                <a16:creationId xmlns:a16="http://schemas.microsoft.com/office/drawing/2014/main" id="{C6B12010-27F0-44B8-BD20-0A60D900DB6D}"/>
               </a:ext>
             </a:extLst>
           </p:cNvPr>
@@ -10568,7 +10726,7 @@
           <p:nvPr/>
         </p:nvPicPr>
         <p:blipFill rotWithShape="1">
-          <a:blip xmlns:r="http://schemas.openxmlformats.org/officeDocument/2006/relationships" xmlns:a="http://schemas.openxmlformats.org/drawingml/2006/main" r:embed="Recd47371578b426d">
+          <a:blip xmlns:r="http://schemas.openxmlformats.org/officeDocument/2006/relationships" xmlns:a="http://schemas.openxmlformats.org/drawingml/2006/main" r:embed="Rda2383b5870d4a58">
             <a:alphaModFix/>
           </a:blip>
           <a:srcRect xmlns:a="http://schemas.openxmlformats.org/drawingml/2006/main" l="0" t="0" r="0" b="98001"/>
@@ -10592,7 +10750,7 @@
           <p:cNvPr id="149" name="Google Shape;149;p25">
             <a:extLst xmlns:a="http://schemas.openxmlformats.org/drawingml/2006/main">
               <a:ext uri="{FF2B5EF4-FFF2-40B4-BE49-F238E27FC236}">
-                <a16:creationId xmlns:a16="http://schemas.microsoft.com/office/drawing/2014/main" id="{EA29D559-105E-4275-8050-67518B5E46B6}"/>
+                <a16:creationId xmlns:a16="http://schemas.microsoft.com/office/drawing/2014/main" id="{6714B803-E240-4979-A9AE-8CF762A62F9A}"/>
               </a:ext>
             </a:extLst>
           </p:cNvPr>
@@ -10602,7 +10760,7 @@
           <p:nvPr/>
         </p:nvPicPr>
         <p:blipFill>
-          <a:blip xmlns:r="http://schemas.openxmlformats.org/officeDocument/2006/relationships" xmlns:a="http://schemas.openxmlformats.org/drawingml/2006/main" r:embed="Rb9d0f778f0774808">
+          <a:blip xmlns:r="http://schemas.openxmlformats.org/officeDocument/2006/relationships" xmlns:a="http://schemas.openxmlformats.org/drawingml/2006/main" r:embed="R32a31a2732fa47b3">
             <a:alphaModFix/>
           </a:blip>
           <a:stretch xmlns:a="http://schemas.openxmlformats.org/drawingml/2006/main">
@@ -10627,7 +10785,7 @@
           <p:cNvPr id="150" name="Google Shape;150;p25">
             <a:extLst xmlns:a="http://schemas.openxmlformats.org/drawingml/2006/main">
               <a:ext uri="{FF2B5EF4-FFF2-40B4-BE49-F238E27FC236}">
-                <a16:creationId xmlns:a16="http://schemas.microsoft.com/office/drawing/2014/main" id="{A4F5EFFE-E30C-4BE7-A1E0-BFB4F1754A56}"/>
+                <a16:creationId xmlns:a16="http://schemas.microsoft.com/office/drawing/2014/main" id="{4BA44AEE-E472-49C7-BDBF-282CAF670DA4}"/>
               </a:ext>
             </a:extLst>
           </p:cNvPr>
@@ -10678,7 +10836,7 @@
           <p:cNvPr id="151" name="Google Shape;151;p25">
             <a:extLst xmlns:a="http://schemas.openxmlformats.org/drawingml/2006/main">
               <a:ext uri="{FF2B5EF4-FFF2-40B4-BE49-F238E27FC236}">
-                <a16:creationId xmlns:a16="http://schemas.microsoft.com/office/drawing/2014/main" id="{60AB9646-9D38-4FB1-B7F0-42C6DEEA3D38}"/>
+                <a16:creationId xmlns:a16="http://schemas.microsoft.com/office/drawing/2014/main" id="{C7AE3D20-322D-45A1-94BF-2AB2D6A530EA}"/>
               </a:ext>
             </a:extLst>
           </p:cNvPr>
@@ -10736,7 +10894,7 @@
           <p:cNvPr id="152" name="future-head-0">
             <a:extLst xmlns:a="http://schemas.openxmlformats.org/drawingml/2006/main">
               <a:ext uri="{FF2B5EF4-FFF2-40B4-BE49-F238E27FC236}">
-                <a16:creationId xmlns:a16="http://schemas.microsoft.com/office/drawing/2014/main" id="{5CB4258A-42D2-44DB-9085-E4023FFA013F}"/>
+                <a16:creationId xmlns:a16="http://schemas.microsoft.com/office/drawing/2014/main" id="{0BE9173C-69DB-4066-9564-9D193EBBF6EE}"/>
               </a:ext>
             </a:extLst>
           </p:cNvPr>
@@ -10884,7 +11042,7 @@
                 <a:ea typeface="Google Sans Flex"/>
                 <a:cs typeface="Google Sans Flex"/>
               </a:rPr>
-              <a:t>Deferred cloud work</a:t>
+              <a:t>Google Cloud deployment</a:t>
             </a:r>
           </a:p>
         </p:txBody>
@@ -10894,7 +11052,7 @@
           <p:cNvPr id="153" name="future-body-0">
             <a:extLst xmlns:a="http://schemas.openxmlformats.org/drawingml/2006/main">
               <a:ext uri="{FF2B5EF4-FFF2-40B4-BE49-F238E27FC236}">
-                <a16:creationId xmlns:a16="http://schemas.microsoft.com/office/drawing/2014/main" id="{1709939B-970F-4EF0-99E3-77F903299C5F}"/>
+                <a16:creationId xmlns:a16="http://schemas.microsoft.com/office/drawing/2014/main" id="{E7626F20-C34C-45AA-A7D1-05B0DFF1BD3C}"/>
               </a:ext>
             </a:extLst>
           </p:cNvPr>
@@ -11042,7 +11200,7 @@
                 <a:ea typeface="Google Sans Flex"/>
                 <a:cs typeface="Google Sans Flex"/>
               </a:rPr>
-              <a:t>Owner chose to continue locally. Deployment, live model evaluation and public-link checks resume only when requested.</a:t>
+              <a:t>Deploy Google Cloud separately, then verify connected services and live model behavior. The public Vercel build currently runs in device-only demo mode.</a:t>
             </a:r>
           </a:p>
         </p:txBody>
@@ -11052,7 +11210,7 @@
           <p:cNvPr id="154" name="future-head-1">
             <a:extLst xmlns:a="http://schemas.openxmlformats.org/drawingml/2006/main">
               <a:ext uri="{FF2B5EF4-FFF2-40B4-BE49-F238E27FC236}">
-                <a16:creationId xmlns:a16="http://schemas.microsoft.com/office/drawing/2014/main" id="{BEB37C5E-0467-4A37-B0C6-9C813237B1BE}"/>
+                <a16:creationId xmlns:a16="http://schemas.microsoft.com/office/drawing/2014/main" id="{0B7059AA-3D64-4510-9D1B-DC667502995A}"/>
               </a:ext>
             </a:extLst>
           </p:cNvPr>
@@ -11210,7 +11368,7 @@
           <p:cNvPr id="155" name="future-body-1">
             <a:extLst xmlns:a="http://schemas.openxmlformats.org/drawingml/2006/main">
               <a:ext uri="{FF2B5EF4-FFF2-40B4-BE49-F238E27FC236}">
-                <a16:creationId xmlns:a16="http://schemas.microsoft.com/office/drawing/2014/main" id="{2DDEA821-0DE2-46DF-94AE-C6F9F0B513B5}"/>
+                <a16:creationId xmlns:a16="http://schemas.microsoft.com/office/drawing/2014/main" id="{0661BA31-1D53-4C05-9B47-5840C06C3C2A}"/>
               </a:ext>
             </a:extLst>
           </p:cNvPr>
@@ -11368,7 +11526,7 @@
           <p:cNvPr id="156" name="future-head-2">
             <a:extLst xmlns:a="http://schemas.openxmlformats.org/drawingml/2006/main">
               <a:ext uri="{FF2B5EF4-FFF2-40B4-BE49-F238E27FC236}">
-                <a16:creationId xmlns:a16="http://schemas.microsoft.com/office/drawing/2014/main" id="{2B15C042-3ED2-4AEB-A4CD-58CE615AAE6D}"/>
+                <a16:creationId xmlns:a16="http://schemas.microsoft.com/office/drawing/2014/main" id="{7E27482C-442C-4322-B804-CA10F2547E8D}"/>
               </a:ext>
             </a:extLst>
           </p:cNvPr>
@@ -11526,7 +11684,7 @@
           <p:cNvPr id="157" name="future-body-2">
             <a:extLst xmlns:a="http://schemas.openxmlformats.org/drawingml/2006/main">
               <a:ext uri="{FF2B5EF4-FFF2-40B4-BE49-F238E27FC236}">
-                <a16:creationId xmlns:a16="http://schemas.microsoft.com/office/drawing/2014/main" id="{54EE92FE-4798-4E29-B638-CB1AE4BD7CE2}"/>
+                <a16:creationId xmlns:a16="http://schemas.microsoft.com/office/drawing/2014/main" id="{2133E051-9DEB-4799-A674-584841493599}"/>
               </a:ext>
             </a:extLst>
           </p:cNvPr>
@@ -11682,7 +11840,7 @@
     </p:spTree>
     <p:extLst>
       <p:ext uri="{BB962C8B-B14F-4D97-AF65-F5344CB8AC3E}">
-        <p14:creationId xmlns:p14="http://schemas.microsoft.com/office/powerpoint/2010/main" val="148313542"/>
+        <p14:creationId xmlns:p14="http://schemas.microsoft.com/office/powerpoint/2010/main" val="1527359296"/>
       </p:ext>
     </p:extLst>
   </p:cSld>
@@ -11706,7 +11864,7 @@
           <p:cNvPr id="156" name="Google Shape;156;p26">
             <a:extLst xmlns:a="http://schemas.openxmlformats.org/drawingml/2006/main">
               <a:ext uri="{FF2B5EF4-FFF2-40B4-BE49-F238E27FC236}">
-                <a16:creationId xmlns:a16="http://schemas.microsoft.com/office/drawing/2014/main" id="{3D41C9E4-2299-48BF-935A-21B9E94E94D6}"/>
+                <a16:creationId xmlns:a16="http://schemas.microsoft.com/office/drawing/2014/main" id="{C4FC2F64-18DD-46C5-B0B4-14E17458F5AE}"/>
               </a:ext>
             </a:extLst>
           </p:cNvPr>
@@ -11716,7 +11874,7 @@
           <p:nvPr/>
         </p:nvPicPr>
         <p:blipFill rotWithShape="1">
-          <a:blip xmlns:r="http://schemas.openxmlformats.org/officeDocument/2006/relationships" xmlns:a="http://schemas.openxmlformats.org/drawingml/2006/main" r:embed="Rd892cef37bfb4b8d">
+          <a:blip xmlns:r="http://schemas.openxmlformats.org/officeDocument/2006/relationships" xmlns:a="http://schemas.openxmlformats.org/drawingml/2006/main" r:embed="Re2e1af8855b34d3b">
             <a:alphaModFix/>
           </a:blip>
           <a:srcRect xmlns:a="http://schemas.openxmlformats.org/drawingml/2006/main" l="0" t="0" r="0" b="98001"/>
@@ -11740,7 +11898,7 @@
           <p:cNvPr id="157" name="Google Shape;157;p26">
             <a:extLst xmlns:a="http://schemas.openxmlformats.org/drawingml/2006/main">
               <a:ext uri="{FF2B5EF4-FFF2-40B4-BE49-F238E27FC236}">
-                <a16:creationId xmlns:a16="http://schemas.microsoft.com/office/drawing/2014/main" id="{7FC5B557-1E74-4ED1-88E7-DC07FBE4DA4F}"/>
+                <a16:creationId xmlns:a16="http://schemas.microsoft.com/office/drawing/2014/main" id="{5052C72E-DF2F-4A02-A97E-34BD75899D39}"/>
               </a:ext>
             </a:extLst>
           </p:cNvPr>
@@ -11750,7 +11908,7 @@
           <p:nvPr/>
         </p:nvPicPr>
         <p:blipFill>
-          <a:blip xmlns:r="http://schemas.openxmlformats.org/officeDocument/2006/relationships" xmlns:a="http://schemas.openxmlformats.org/drawingml/2006/main" r:embed="R8ebf1aeb592c485c">
+          <a:blip xmlns:r="http://schemas.openxmlformats.org/officeDocument/2006/relationships" xmlns:a="http://schemas.openxmlformats.org/drawingml/2006/main" r:embed="Reee5ce8d08cb4cb3">
             <a:alphaModFix/>
           </a:blip>
           <a:stretch xmlns:a="http://schemas.openxmlformats.org/drawingml/2006/main">
@@ -11775,7 +11933,7 @@
           <p:cNvPr id="158" name="Google Shape;158;p26">
             <a:extLst xmlns:a="http://schemas.openxmlformats.org/drawingml/2006/main">
               <a:ext uri="{FF2B5EF4-FFF2-40B4-BE49-F238E27FC236}">
-                <a16:creationId xmlns:a16="http://schemas.microsoft.com/office/drawing/2014/main" id="{0CB33BD1-8FF6-412F-A200-119DF97B3D67}"/>
+                <a16:creationId xmlns:a16="http://schemas.microsoft.com/office/drawing/2014/main" id="{403021E1-219E-4E98-B774-04032E5406EC}"/>
               </a:ext>
             </a:extLst>
           </p:cNvPr>
@@ -11826,7 +11984,7 @@
           <p:cNvPr id="159" name="Google Shape;159;p26">
             <a:extLst xmlns:a="http://schemas.openxmlformats.org/drawingml/2006/main">
               <a:ext uri="{FF2B5EF4-FFF2-40B4-BE49-F238E27FC236}">
-                <a16:creationId xmlns:a16="http://schemas.microsoft.com/office/drawing/2014/main" id="{894CCAC0-4DC5-46F6-8579-688F3981CB5A}"/>
+                <a16:creationId xmlns:a16="http://schemas.microsoft.com/office/drawing/2014/main" id="{8C6E4C93-1690-4BEE-9929-DBC1A7912B56}"/>
               </a:ext>
             </a:extLst>
           </p:cNvPr>
@@ -11996,7 +12154,7 @@
           <p:cNvPr id="160" name="link-label-0">
             <a:extLst xmlns:a="http://schemas.openxmlformats.org/drawingml/2006/main">
               <a:ext uri="{FF2B5EF4-FFF2-40B4-BE49-F238E27FC236}">
-                <a16:creationId xmlns:a16="http://schemas.microsoft.com/office/drawing/2014/main" id="{684D7DB6-799A-4C98-964B-22EA24A768F8}"/>
+                <a16:creationId xmlns:a16="http://schemas.microsoft.com/office/drawing/2014/main" id="{4CF077A2-840A-4972-B672-55183FE56A66}"/>
               </a:ext>
             </a:extLst>
           </p:cNvPr>
@@ -12154,7 +12312,7 @@
           <p:cNvPr id="161" name="link-value-0">
             <a:extLst xmlns:a="http://schemas.openxmlformats.org/drawingml/2006/main">
               <a:ext uri="{FF2B5EF4-FFF2-40B4-BE49-F238E27FC236}">
-                <a16:creationId xmlns:a16="http://schemas.microsoft.com/office/drawing/2014/main" id="{FCED442F-89C8-4B77-B3A5-30AAF2AE0734}"/>
+                <a16:creationId xmlns:a16="http://schemas.microsoft.com/office/drawing/2014/main" id="{4FCB9FE5-1637-42B2-BA74-E6197B98A871}"/>
               </a:ext>
             </a:extLst>
           </p:cNvPr>
@@ -12312,7 +12470,7 @@
           <p:cNvPr id="162" name="link-label-1">
             <a:extLst xmlns:a="http://schemas.openxmlformats.org/drawingml/2006/main">
               <a:ext uri="{FF2B5EF4-FFF2-40B4-BE49-F238E27FC236}">
-                <a16:creationId xmlns:a16="http://schemas.microsoft.com/office/drawing/2014/main" id="{B813A879-122B-45A0-B512-01D6239C2793}"/>
+                <a16:creationId xmlns:a16="http://schemas.microsoft.com/office/drawing/2014/main" id="{20D75D63-0D21-40DC-AF06-5D8260ADE3BA}"/>
               </a:ext>
             </a:extLst>
           </p:cNvPr>
@@ -12460,7 +12618,7 @@
                 <a:ea typeface="Google Sans Flex"/>
                 <a:cs typeface="Google Sans Flex"/>
               </a:rPr>
-              <a:t>Demo video (under 3 minutes)</a:t>
+              <a:t>Demo video (3-4 minutes)</a:t>
             </a:r>
           </a:p>
         </p:txBody>
@@ -12470,7 +12628,7 @@
           <p:cNvPr id="163" name="link-value-1">
             <a:extLst xmlns:a="http://schemas.openxmlformats.org/drawingml/2006/main">
               <a:ext uri="{FF2B5EF4-FFF2-40B4-BE49-F238E27FC236}">
-                <a16:creationId xmlns:a16="http://schemas.microsoft.com/office/drawing/2014/main" id="{0FE2C97C-E4D9-4272-A7FE-4571ED0D3DDD}"/>
+                <a16:creationId xmlns:a16="http://schemas.microsoft.com/office/drawing/2014/main" id="{C14206C6-3186-4298-A715-67F0B26C2C4D}"/>
               </a:ext>
             </a:extLst>
           </p:cNvPr>
@@ -12628,7 +12786,7 @@
           <p:cNvPr id="164" name="link-label-2">
             <a:extLst xmlns:a="http://schemas.openxmlformats.org/drawingml/2006/main">
               <a:ext uri="{FF2B5EF4-FFF2-40B4-BE49-F238E27FC236}">
-                <a16:creationId xmlns:a16="http://schemas.microsoft.com/office/drawing/2014/main" id="{1FFCDF67-A2E1-43F6-AC62-2F1ED2CBA0B8}"/>
+                <a16:creationId xmlns:a16="http://schemas.microsoft.com/office/drawing/2014/main" id="{FFC92DB6-0706-43EB-A208-2419EA55C450}"/>
               </a:ext>
             </a:extLst>
           </p:cNvPr>
@@ -12776,7 +12934,7 @@
                 <a:ea typeface="Google Sans Flex"/>
                 <a:cs typeface="Google Sans Flex"/>
               </a:rPr>
-              <a:t>Final product</a:t>
+              <a:t>Public prototype (device-only demo)</a:t>
             </a:r>
           </a:p>
         </p:txBody>
@@ -12786,7 +12944,7 @@
           <p:cNvPr id="165" name="link-value-2">
             <a:extLst xmlns:a="http://schemas.openxmlformats.org/drawingml/2006/main">
               <a:ext uri="{FF2B5EF4-FFF2-40B4-BE49-F238E27FC236}">
-                <a16:creationId xmlns:a16="http://schemas.microsoft.com/office/drawing/2014/main" id="{AD7DD670-B895-4FA5-856F-588A67A52ED9}"/>
+                <a16:creationId xmlns:a16="http://schemas.microsoft.com/office/drawing/2014/main" id="{AFE23D74-5766-4563-AE38-6D0A5FD6CD13}"/>
               </a:ext>
             </a:extLst>
           </p:cNvPr>
@@ -12934,7 +13092,7 @@
                 <a:ea typeface="Google Sans Flex"/>
                 <a:cs typeface="Google Sans Flex"/>
               </a:rPr>
-              <a:t>[Cloud deployment deferred by owner; public URL pending]</a:t>
+              <a:t>https://lead-net-6639-eta.vercel.app/</a:t>
             </a:r>
           </a:p>
         </p:txBody>
@@ -12944,7 +13102,7 @@
           <p:cNvPr id="166" name="link-check">
             <a:extLst xmlns:a="http://schemas.openxmlformats.org/drawingml/2006/main">
               <a:ext uri="{FF2B5EF4-FFF2-40B4-BE49-F238E27FC236}">
-                <a16:creationId xmlns:a16="http://schemas.microsoft.com/office/drawing/2014/main" id="{885D1CAC-5184-4551-A274-63EC8AB124C0}"/>
+                <a16:creationId xmlns:a16="http://schemas.microsoft.com/office/drawing/2014/main" id="{957FBA5C-0C31-47B0-A169-E34770C8EFDE}"/>
               </a:ext>
             </a:extLst>
           </p:cNvPr>
@@ -13100,7 +13258,7 @@
     </p:spTree>
     <p:extLst>
       <p:ext uri="{BB962C8B-B14F-4D97-AF65-F5344CB8AC3E}">
-        <p14:creationId xmlns:p14="http://schemas.microsoft.com/office/powerpoint/2010/main" val="1303090072"/>
+        <p14:creationId xmlns:p14="http://schemas.microsoft.com/office/powerpoint/2010/main" val="1995056148"/>
       </p:ext>
     </p:extLst>
   </p:cSld>
@@ -13124,7 +13282,7 @@
           <p:cNvPr id="171" name="Google Shape;171;p28">
             <a:extLst xmlns:a="http://schemas.openxmlformats.org/drawingml/2006/main">
               <a:ext uri="{FF2B5EF4-FFF2-40B4-BE49-F238E27FC236}">
-                <a16:creationId xmlns:a16="http://schemas.microsoft.com/office/drawing/2014/main" id="{99EF13FE-BC7D-4E67-816C-F10AA570B409}"/>
+                <a16:creationId xmlns:a16="http://schemas.microsoft.com/office/drawing/2014/main" id="{25E33D10-27A8-4EBD-AD92-F605ACF5C911}"/>
               </a:ext>
             </a:extLst>
           </p:cNvPr>
@@ -13134,7 +13292,7 @@
           <p:nvPr/>
         </p:nvPicPr>
         <p:blipFill rotWithShape="1">
-          <a:blip xmlns:r="http://schemas.openxmlformats.org/officeDocument/2006/relationships" xmlns:a="http://schemas.openxmlformats.org/drawingml/2006/main" r:embed="Rc1670850b0004c33">
+          <a:blip xmlns:r="http://schemas.openxmlformats.org/officeDocument/2006/relationships" xmlns:a="http://schemas.openxmlformats.org/drawingml/2006/main" r:embed="R6858500f46a541a2">
             <a:alphaModFix/>
           </a:blip>
           <a:srcRect xmlns:a="http://schemas.openxmlformats.org/drawingml/2006/main" l="0" t="0" r="0" b="98001"/>
@@ -13158,7 +13316,7 @@
           <p:cNvPr id="172" name="Google Shape;172;p28">
             <a:extLst xmlns:a="http://schemas.openxmlformats.org/drawingml/2006/main">
               <a:ext uri="{FF2B5EF4-FFF2-40B4-BE49-F238E27FC236}">
-                <a16:creationId xmlns:a16="http://schemas.microsoft.com/office/drawing/2014/main" id="{8A67B487-CB32-49BF-9C54-F0C09451A140}"/>
+                <a16:creationId xmlns:a16="http://schemas.microsoft.com/office/drawing/2014/main" id="{50213E0E-A5E7-4BCE-9E06-76CE6C7D1BCE}"/>
               </a:ext>
             </a:extLst>
           </p:cNvPr>
@@ -13168,7 +13326,7 @@
           <p:nvPr/>
         </p:nvPicPr>
         <p:blipFill>
-          <a:blip xmlns:r="http://schemas.openxmlformats.org/officeDocument/2006/relationships" xmlns:a="http://schemas.openxmlformats.org/drawingml/2006/main" r:embed="R4c769ecf6c8d4624">
+          <a:blip xmlns:r="http://schemas.openxmlformats.org/officeDocument/2006/relationships" xmlns:a="http://schemas.openxmlformats.org/drawingml/2006/main" r:embed="R26c7ef12d6374f30">
             <a:alphaModFix/>
           </a:blip>
           <a:stretch xmlns:a="http://schemas.openxmlformats.org/drawingml/2006/main">
@@ -13191,7 +13349,7 @@
     </p:spTree>
     <p:extLst>
       <p:ext uri="{BB962C8B-B14F-4D97-AF65-F5344CB8AC3E}">
-        <p14:creationId xmlns:p14="http://schemas.microsoft.com/office/powerpoint/2010/main" val="931459039"/>
+        <p14:creationId xmlns:p14="http://schemas.microsoft.com/office/powerpoint/2010/main" val="693466454"/>
       </p:ext>
     </p:extLst>
   </p:cSld>
@@ -13215,7 +13373,7 @@
           <p:cNvPr id="69" name="Google Shape;69;p15">
             <a:extLst xmlns:a="http://schemas.openxmlformats.org/drawingml/2006/main">
               <a:ext uri="{FF2B5EF4-FFF2-40B4-BE49-F238E27FC236}">
-                <a16:creationId xmlns:a16="http://schemas.microsoft.com/office/drawing/2014/main" id="{E7C1D86B-1A49-4099-B861-8300A1C6BB24}"/>
+                <a16:creationId xmlns:a16="http://schemas.microsoft.com/office/drawing/2014/main" id="{51844D39-5D3E-4B3F-AE94-7D1BA1549588}"/>
               </a:ext>
             </a:extLst>
           </p:cNvPr>
@@ -13225,7 +13383,7 @@
           <p:nvPr/>
         </p:nvPicPr>
         <p:blipFill>
-          <a:blip xmlns:r="http://schemas.openxmlformats.org/officeDocument/2006/relationships" xmlns:a="http://schemas.openxmlformats.org/drawingml/2006/main" r:embed="R0d9c9f882fc74c3d">
+          <a:blip xmlns:r="http://schemas.openxmlformats.org/officeDocument/2006/relationships" xmlns:a="http://schemas.openxmlformats.org/drawingml/2006/main" r:embed="R421ffe11102e4063">
             <a:alphaModFix/>
           </a:blip>
           <a:stretch xmlns:a="http://schemas.openxmlformats.org/drawingml/2006/main">
@@ -13250,7 +13408,7 @@
           <p:cNvPr id="70" name="Google Shape;70;p15">
             <a:extLst xmlns:a="http://schemas.openxmlformats.org/drawingml/2006/main">
               <a:ext uri="{FF2B5EF4-FFF2-40B4-BE49-F238E27FC236}">
-                <a16:creationId xmlns:a16="http://schemas.microsoft.com/office/drawing/2014/main" id="{F34121B1-9007-4516-87AA-BBD6E0D03113}"/>
+                <a16:creationId xmlns:a16="http://schemas.microsoft.com/office/drawing/2014/main" id="{5A21898D-F4ED-4BF0-94EC-6A44C3581DCD}"/>
               </a:ext>
             </a:extLst>
           </p:cNvPr>
@@ -13301,7 +13459,7 @@
           <p:cNvPr id="71" name="Google Shape;71;p15">
             <a:extLst xmlns:a="http://schemas.openxmlformats.org/drawingml/2006/main">
               <a:ext uri="{FF2B5EF4-FFF2-40B4-BE49-F238E27FC236}">
-                <a16:creationId xmlns:a16="http://schemas.microsoft.com/office/drawing/2014/main" id="{517CE85B-C5EA-4FDD-999B-C00B7F433465}"/>
+                <a16:creationId xmlns:a16="http://schemas.microsoft.com/office/drawing/2014/main" id="{2CC36E29-9968-4D33-A131-96D9972CAE34}"/>
               </a:ext>
             </a:extLst>
           </p:cNvPr>
@@ -13359,7 +13517,7 @@
           <p:cNvPr id="72" name="product-name">
             <a:extLst xmlns:a="http://schemas.openxmlformats.org/drawingml/2006/main">
               <a:ext uri="{FF2B5EF4-FFF2-40B4-BE49-F238E27FC236}">
-                <a16:creationId xmlns:a16="http://schemas.microsoft.com/office/drawing/2014/main" id="{A541F6C6-DBA4-4CAC-A0D7-529104ECDE0A}"/>
+                <a16:creationId xmlns:a16="http://schemas.microsoft.com/office/drawing/2014/main" id="{87CC284D-61E6-411F-BAF1-D1A06D4DE209}"/>
               </a:ext>
             </a:extLst>
           </p:cNvPr>
@@ -13517,7 +13675,7 @@
           <p:cNvPr id="73" name="idea">
             <a:extLst xmlns:a="http://schemas.openxmlformats.org/drawingml/2006/main">
               <a:ext uri="{FF2B5EF4-FFF2-40B4-BE49-F238E27FC236}">
-                <a16:creationId xmlns:a16="http://schemas.microsoft.com/office/drawing/2014/main" id="{201A3884-4676-4BD7-BCF0-95733204B185}"/>
+                <a16:creationId xmlns:a16="http://schemas.microsoft.com/office/drawing/2014/main" id="{465BA753-2DEC-43DB-8E09-6FB4F87F8BEC}"/>
               </a:ext>
             </a:extLst>
           </p:cNvPr>
@@ -13675,7 +13833,7 @@
           <p:cNvPr id="74" name="problem">
             <a:extLst xmlns:a="http://schemas.openxmlformats.org/drawingml/2006/main">
               <a:ext uri="{FF2B5EF4-FFF2-40B4-BE49-F238E27FC236}">
-                <a16:creationId xmlns:a16="http://schemas.microsoft.com/office/drawing/2014/main" id="{327F000C-83D1-4E8A-897E-EBE961D93802}"/>
+                <a16:creationId xmlns:a16="http://schemas.microsoft.com/office/drawing/2014/main" id="{F0D6E6CD-8628-41AE-8352-E04182C14A4D}"/>
               </a:ext>
             </a:extLst>
           </p:cNvPr>
@@ -13833,7 +13991,7 @@
           <p:cNvPr id="75" name="separator">
             <a:extLst xmlns:a="http://schemas.openxmlformats.org/drawingml/2006/main">
               <a:ext uri="{FF2B5EF4-FFF2-40B4-BE49-F238E27FC236}">
-                <a16:creationId xmlns:a16="http://schemas.microsoft.com/office/drawing/2014/main" id="{1480CA37-1486-4241-BB27-F51C995200D0}"/>
+                <a16:creationId xmlns:a16="http://schemas.microsoft.com/office/drawing/2014/main" id="{69C04DA4-D7B3-44AF-A3EF-5B57C75A7BA6}"/>
               </a:ext>
             </a:extLst>
           </p:cNvPr>
@@ -13865,7 +14023,7 @@
           <p:cNvPr id="76" name="three-facts">
             <a:extLst xmlns:a="http://schemas.openxmlformats.org/drawingml/2006/main">
               <a:ext uri="{FF2B5EF4-FFF2-40B4-BE49-F238E27FC236}">
-                <a16:creationId xmlns:a16="http://schemas.microsoft.com/office/drawing/2014/main" id="{D82DD9FE-7A09-4296-B6B6-9206EEFE74F1}"/>
+                <a16:creationId xmlns:a16="http://schemas.microsoft.com/office/drawing/2014/main" id="{F3AA75A8-FD05-4B3F-94EA-0308299C23E0}"/>
               </a:ext>
             </a:extLst>
           </p:cNvPr>
@@ -14023,7 +14181,7 @@
           <p:cNvPr id="77" name="scope">
             <a:extLst xmlns:a="http://schemas.openxmlformats.org/drawingml/2006/main">
               <a:ext uri="{FF2B5EF4-FFF2-40B4-BE49-F238E27FC236}">
-                <a16:creationId xmlns:a16="http://schemas.microsoft.com/office/drawing/2014/main" id="{C5A356AC-6B1F-447C-9A45-034A0BEB78C5}"/>
+                <a16:creationId xmlns:a16="http://schemas.microsoft.com/office/drawing/2014/main" id="{688C6C5B-E09E-41D2-B393-E26EDB39F0E6}"/>
               </a:ext>
             </a:extLst>
           </p:cNvPr>
@@ -14179,7 +14337,7 @@
     </p:spTree>
     <p:extLst>
       <p:ext uri="{BB962C8B-B14F-4D97-AF65-F5344CB8AC3E}">
-        <p14:creationId xmlns:p14="http://schemas.microsoft.com/office/powerpoint/2010/main" val="1026359479"/>
+        <p14:creationId xmlns:p14="http://schemas.microsoft.com/office/powerpoint/2010/main" val="910487163"/>
       </p:ext>
     </p:extLst>
   </p:cSld>
@@ -14203,7 +14361,7 @@
           <p:cNvPr id="76" name="Google Shape;76;p16">
             <a:extLst xmlns:a="http://schemas.openxmlformats.org/drawingml/2006/main">
               <a:ext uri="{FF2B5EF4-FFF2-40B4-BE49-F238E27FC236}">
-                <a16:creationId xmlns:a16="http://schemas.microsoft.com/office/drawing/2014/main" id="{01E9576E-EB29-498C-B702-9DC391D25B52}"/>
+                <a16:creationId xmlns:a16="http://schemas.microsoft.com/office/drawing/2014/main" id="{A1CA04C1-00A3-4FE7-8106-375FD08070A9}"/>
               </a:ext>
             </a:extLst>
           </p:cNvPr>
@@ -14213,7 +14371,7 @@
           <p:nvPr/>
         </p:nvPicPr>
         <p:blipFill rotWithShape="1">
-          <a:blip xmlns:r="http://schemas.openxmlformats.org/officeDocument/2006/relationships" xmlns:a="http://schemas.openxmlformats.org/drawingml/2006/main" r:embed="R1e13777e292b4c13">
+          <a:blip xmlns:r="http://schemas.openxmlformats.org/officeDocument/2006/relationships" xmlns:a="http://schemas.openxmlformats.org/drawingml/2006/main" r:embed="R5bc55108620944e9">
             <a:alphaModFix/>
           </a:blip>
           <a:srcRect xmlns:a="http://schemas.openxmlformats.org/drawingml/2006/main" l="0" t="0" r="0" b="98001"/>
@@ -14237,7 +14395,7 @@
           <p:cNvPr id="77" name="Google Shape;77;p16">
             <a:extLst xmlns:a="http://schemas.openxmlformats.org/drawingml/2006/main">
               <a:ext uri="{FF2B5EF4-FFF2-40B4-BE49-F238E27FC236}">
-                <a16:creationId xmlns:a16="http://schemas.microsoft.com/office/drawing/2014/main" id="{76722605-07AC-4281-8DF1-82FC08CF2A3C}"/>
+                <a16:creationId xmlns:a16="http://schemas.microsoft.com/office/drawing/2014/main" id="{95B593D3-C7F9-4A68-833B-B50B82ADE60B}"/>
               </a:ext>
             </a:extLst>
           </p:cNvPr>
@@ -14247,7 +14405,7 @@
           <p:nvPr/>
         </p:nvPicPr>
         <p:blipFill>
-          <a:blip xmlns:r="http://schemas.openxmlformats.org/officeDocument/2006/relationships" xmlns:a="http://schemas.openxmlformats.org/drawingml/2006/main" r:embed="R6ecc7af08cda411a">
+          <a:blip xmlns:r="http://schemas.openxmlformats.org/officeDocument/2006/relationships" xmlns:a="http://schemas.openxmlformats.org/drawingml/2006/main" r:embed="R23316d9bab0b4cad">
             <a:alphaModFix/>
           </a:blip>
           <a:stretch xmlns:a="http://schemas.openxmlformats.org/drawingml/2006/main">
@@ -14272,7 +14430,7 @@
           <p:cNvPr id="78" name="Google Shape;78;p16">
             <a:extLst xmlns:a="http://schemas.openxmlformats.org/drawingml/2006/main">
               <a:ext uri="{FF2B5EF4-FFF2-40B4-BE49-F238E27FC236}">
-                <a16:creationId xmlns:a16="http://schemas.microsoft.com/office/drawing/2014/main" id="{43D95034-62F9-47E4-9594-DDCDDD161C75}"/>
+                <a16:creationId xmlns:a16="http://schemas.microsoft.com/office/drawing/2014/main" id="{EA432C36-F7FC-4F24-968C-030A836CFD08}"/>
               </a:ext>
             </a:extLst>
           </p:cNvPr>
@@ -14323,7 +14481,7 @@
           <p:cNvPr id="79" name="Google Shape;79;p16">
             <a:extLst xmlns:a="http://schemas.openxmlformats.org/drawingml/2006/main">
               <a:ext uri="{FF2B5EF4-FFF2-40B4-BE49-F238E27FC236}">
-                <a16:creationId xmlns:a16="http://schemas.microsoft.com/office/drawing/2014/main" id="{66D359ED-7D15-4AC1-82B7-4737DE995FD7}"/>
+                <a16:creationId xmlns:a16="http://schemas.microsoft.com/office/drawing/2014/main" id="{F353DCF4-88F0-48E1-A474-1B6585915F24}"/>
               </a:ext>
             </a:extLst>
           </p:cNvPr>
@@ -14493,7 +14651,7 @@
           <p:cNvPr id="80" name="op-label-0">
             <a:extLst xmlns:a="http://schemas.openxmlformats.org/drawingml/2006/main">
               <a:ext uri="{FF2B5EF4-FFF2-40B4-BE49-F238E27FC236}">
-                <a16:creationId xmlns:a16="http://schemas.microsoft.com/office/drawing/2014/main" id="{BA76C794-D924-4707-82E3-63EAAF9FC5C1}"/>
+                <a16:creationId xmlns:a16="http://schemas.microsoft.com/office/drawing/2014/main" id="{90448803-58A6-42EB-BF67-B662CCBB414E}"/>
               </a:ext>
             </a:extLst>
           </p:cNvPr>
@@ -14651,7 +14809,7 @@
           <p:cNvPr id="81" name="op-heading-0">
             <a:extLst xmlns:a="http://schemas.openxmlformats.org/drawingml/2006/main">
               <a:ext uri="{FF2B5EF4-FFF2-40B4-BE49-F238E27FC236}">
-                <a16:creationId xmlns:a16="http://schemas.microsoft.com/office/drawing/2014/main" id="{841CEE8D-D18F-487C-97FE-2D3F0EF84B16}"/>
+                <a16:creationId xmlns:a16="http://schemas.microsoft.com/office/drawing/2014/main" id="{226C1707-3569-4B73-A443-3519CCD76CDE}"/>
               </a:ext>
             </a:extLst>
           </p:cNvPr>
@@ -14809,7 +14967,7 @@
           <p:cNvPr id="82" name="op-body-0">
             <a:extLst xmlns:a="http://schemas.openxmlformats.org/drawingml/2006/main">
               <a:ext uri="{FF2B5EF4-FFF2-40B4-BE49-F238E27FC236}">
-                <a16:creationId xmlns:a16="http://schemas.microsoft.com/office/drawing/2014/main" id="{0C4B3279-3DFE-4691-9552-08420902C337}"/>
+                <a16:creationId xmlns:a16="http://schemas.microsoft.com/office/drawing/2014/main" id="{C89C7088-0D44-4EA7-B76D-5475BD8B95DB}"/>
               </a:ext>
             </a:extLst>
           </p:cNvPr>
@@ -14967,7 +15125,7 @@
           <p:cNvPr id="83" name="op-label-1">
             <a:extLst xmlns:a="http://schemas.openxmlformats.org/drawingml/2006/main">
               <a:ext uri="{FF2B5EF4-FFF2-40B4-BE49-F238E27FC236}">
-                <a16:creationId xmlns:a16="http://schemas.microsoft.com/office/drawing/2014/main" id="{98B56F55-857C-447E-BD5F-EB1F92E9F695}"/>
+                <a16:creationId xmlns:a16="http://schemas.microsoft.com/office/drawing/2014/main" id="{D61A2418-5583-4D0C-9DAA-8678C20E960F}"/>
               </a:ext>
             </a:extLst>
           </p:cNvPr>
@@ -15125,7 +15283,7 @@
           <p:cNvPr id="84" name="op-heading-1">
             <a:extLst xmlns:a="http://schemas.openxmlformats.org/drawingml/2006/main">
               <a:ext uri="{FF2B5EF4-FFF2-40B4-BE49-F238E27FC236}">
-                <a16:creationId xmlns:a16="http://schemas.microsoft.com/office/drawing/2014/main" id="{AD9EDA63-6F40-4E2C-9D13-9155EC443D30}"/>
+                <a16:creationId xmlns:a16="http://schemas.microsoft.com/office/drawing/2014/main" id="{EB8749EF-5112-493B-B329-6939DD716B5E}"/>
               </a:ext>
             </a:extLst>
           </p:cNvPr>
@@ -15283,7 +15441,7 @@
           <p:cNvPr id="85" name="op-body-1">
             <a:extLst xmlns:a="http://schemas.openxmlformats.org/drawingml/2006/main">
               <a:ext uri="{FF2B5EF4-FFF2-40B4-BE49-F238E27FC236}">
-                <a16:creationId xmlns:a16="http://schemas.microsoft.com/office/drawing/2014/main" id="{01654E3E-84D8-4353-8E0F-A6B2AB5651AD}"/>
+                <a16:creationId xmlns:a16="http://schemas.microsoft.com/office/drawing/2014/main" id="{0422BF60-AF10-4264-8438-651A77FB26A5}"/>
               </a:ext>
             </a:extLst>
           </p:cNvPr>
@@ -15441,7 +15599,7 @@
           <p:cNvPr id="86" name="op-label-2">
             <a:extLst xmlns:a="http://schemas.openxmlformats.org/drawingml/2006/main">
               <a:ext uri="{FF2B5EF4-FFF2-40B4-BE49-F238E27FC236}">
-                <a16:creationId xmlns:a16="http://schemas.microsoft.com/office/drawing/2014/main" id="{AE820FAA-34DB-41B7-AE97-23CA86F094B0}"/>
+                <a16:creationId xmlns:a16="http://schemas.microsoft.com/office/drawing/2014/main" id="{F3404CFF-AFF2-4C09-9753-23DB0D9B02EB}"/>
               </a:ext>
             </a:extLst>
           </p:cNvPr>
@@ -15599,7 +15757,7 @@
           <p:cNvPr id="87" name="op-heading-2">
             <a:extLst xmlns:a="http://schemas.openxmlformats.org/drawingml/2006/main">
               <a:ext uri="{FF2B5EF4-FFF2-40B4-BE49-F238E27FC236}">
-                <a16:creationId xmlns:a16="http://schemas.microsoft.com/office/drawing/2014/main" id="{EA97DD0C-FA0A-4FD8-BFD2-8854A339D07E}"/>
+                <a16:creationId xmlns:a16="http://schemas.microsoft.com/office/drawing/2014/main" id="{42B86143-D601-4B61-AC30-9B3DFDACA8EE}"/>
               </a:ext>
             </a:extLst>
           </p:cNvPr>
@@ -15757,7 +15915,7 @@
           <p:cNvPr id="88" name="op-body-2">
             <a:extLst xmlns:a="http://schemas.openxmlformats.org/drawingml/2006/main">
               <a:ext uri="{FF2B5EF4-FFF2-40B4-BE49-F238E27FC236}">
-                <a16:creationId xmlns:a16="http://schemas.microsoft.com/office/drawing/2014/main" id="{5EFA7E3D-A6CC-423D-B659-55EDE0BA4C1B}"/>
+                <a16:creationId xmlns:a16="http://schemas.microsoft.com/office/drawing/2014/main" id="{F10978A8-02E3-4FBD-99B2-18ED5FE41135}"/>
               </a:ext>
             </a:extLst>
           </p:cNvPr>
@@ -15913,7 +16071,7 @@
     </p:spTree>
     <p:extLst>
       <p:ext uri="{BB962C8B-B14F-4D97-AF65-F5344CB8AC3E}">
-        <p14:creationId xmlns:p14="http://schemas.microsoft.com/office/powerpoint/2010/main" val="1332645250"/>
+        <p14:creationId xmlns:p14="http://schemas.microsoft.com/office/powerpoint/2010/main" val="2019454723"/>
       </p:ext>
     </p:extLst>
   </p:cSld>
@@ -15937,7 +16095,7 @@
           <p:cNvPr id="84" name="Google Shape;84;p17">
             <a:extLst xmlns:a="http://schemas.openxmlformats.org/drawingml/2006/main">
               <a:ext uri="{FF2B5EF4-FFF2-40B4-BE49-F238E27FC236}">
-                <a16:creationId xmlns:a16="http://schemas.microsoft.com/office/drawing/2014/main" id="{E4F5F63A-70ED-4B2D-B7F5-2629AEDDC900}"/>
+                <a16:creationId xmlns:a16="http://schemas.microsoft.com/office/drawing/2014/main" id="{1422B55A-CE70-4F81-94BE-3B29FA99361E}"/>
               </a:ext>
             </a:extLst>
           </p:cNvPr>
@@ -15947,7 +16105,7 @@
           <p:nvPr/>
         </p:nvPicPr>
         <p:blipFill rotWithShape="1">
-          <a:blip xmlns:r="http://schemas.openxmlformats.org/officeDocument/2006/relationships" xmlns:a="http://schemas.openxmlformats.org/drawingml/2006/main" r:embed="R9d2eeac8d6fe42c8">
+          <a:blip xmlns:r="http://schemas.openxmlformats.org/officeDocument/2006/relationships" xmlns:a="http://schemas.openxmlformats.org/drawingml/2006/main" r:embed="R540817c5ec594ec3">
             <a:alphaModFix/>
           </a:blip>
           <a:srcRect xmlns:a="http://schemas.openxmlformats.org/drawingml/2006/main" l="0" t="0" r="0" b="98001"/>
@@ -15971,7 +16129,7 @@
           <p:cNvPr id="85" name="Google Shape;85;p17">
             <a:extLst xmlns:a="http://schemas.openxmlformats.org/drawingml/2006/main">
               <a:ext uri="{FF2B5EF4-FFF2-40B4-BE49-F238E27FC236}">
-                <a16:creationId xmlns:a16="http://schemas.microsoft.com/office/drawing/2014/main" id="{32E42D3E-12D8-46EE-8765-1F6390CC3677}"/>
+                <a16:creationId xmlns:a16="http://schemas.microsoft.com/office/drawing/2014/main" id="{6A7EACFB-2ABA-4769-9F7D-AAEBAB48105C}"/>
               </a:ext>
             </a:extLst>
           </p:cNvPr>
@@ -15981,7 +16139,7 @@
           <p:nvPr/>
         </p:nvPicPr>
         <p:blipFill>
-          <a:blip xmlns:r="http://schemas.openxmlformats.org/officeDocument/2006/relationships" xmlns:a="http://schemas.openxmlformats.org/drawingml/2006/main" r:embed="R2505d71f50a04569">
+          <a:blip xmlns:r="http://schemas.openxmlformats.org/officeDocument/2006/relationships" xmlns:a="http://schemas.openxmlformats.org/drawingml/2006/main" r:embed="Ra7c0d210ab024415">
             <a:alphaModFix/>
           </a:blip>
           <a:stretch xmlns:a="http://schemas.openxmlformats.org/drawingml/2006/main">
@@ -16006,7 +16164,7 @@
           <p:cNvPr id="86" name="Google Shape;86;p17">
             <a:extLst xmlns:a="http://schemas.openxmlformats.org/drawingml/2006/main">
               <a:ext uri="{FF2B5EF4-FFF2-40B4-BE49-F238E27FC236}">
-                <a16:creationId xmlns:a16="http://schemas.microsoft.com/office/drawing/2014/main" id="{A658A4C1-710A-4435-B2F4-946AF0396A24}"/>
+                <a16:creationId xmlns:a16="http://schemas.microsoft.com/office/drawing/2014/main" id="{ECDD57C6-6060-48F5-8B30-77299261F98B}"/>
               </a:ext>
             </a:extLst>
           </p:cNvPr>
@@ -16057,7 +16215,7 @@
           <p:cNvPr id="87" name="Google Shape;87;p17">
             <a:extLst xmlns:a="http://schemas.openxmlformats.org/drawingml/2006/main">
               <a:ext uri="{FF2B5EF4-FFF2-40B4-BE49-F238E27FC236}">
-                <a16:creationId xmlns:a16="http://schemas.microsoft.com/office/drawing/2014/main" id="{8C7271FB-A7CA-4F40-B130-F5390BF1E621}"/>
+                <a16:creationId xmlns:a16="http://schemas.microsoft.com/office/drawing/2014/main" id="{0D151BA9-0B94-4520-A257-501230719DA2}"/>
               </a:ext>
             </a:extLst>
           </p:cNvPr>
@@ -16115,7 +16273,7 @@
           <p:cNvPr id="88" name="feature-0">
             <a:extLst xmlns:a="http://schemas.openxmlformats.org/drawingml/2006/main">
               <a:ext uri="{FF2B5EF4-FFF2-40B4-BE49-F238E27FC236}">
-                <a16:creationId xmlns:a16="http://schemas.microsoft.com/office/drawing/2014/main" id="{9CA0B394-A545-423E-9E76-B094A1A5F2E9}"/>
+                <a16:creationId xmlns:a16="http://schemas.microsoft.com/office/drawing/2014/main" id="{D5728C74-BBF4-4DFC-9D2B-183913BFC4E8}"/>
               </a:ext>
             </a:extLst>
           </p:cNvPr>
@@ -16273,7 +16431,7 @@
           <p:cNvPr id="89" name="feature-body-0">
             <a:extLst xmlns:a="http://schemas.openxmlformats.org/drawingml/2006/main">
               <a:ext uri="{FF2B5EF4-FFF2-40B4-BE49-F238E27FC236}">
-                <a16:creationId xmlns:a16="http://schemas.microsoft.com/office/drawing/2014/main" id="{52A96629-8AA0-409E-8AD2-A31846E88CCC}"/>
+                <a16:creationId xmlns:a16="http://schemas.microsoft.com/office/drawing/2014/main" id="{FC4733B9-42E0-4C57-B96A-E73EEDB5A00B}"/>
               </a:ext>
             </a:extLst>
           </p:cNvPr>
@@ -16431,7 +16589,7 @@
           <p:cNvPr id="90" name="feature-1">
             <a:extLst xmlns:a="http://schemas.openxmlformats.org/drawingml/2006/main">
               <a:ext uri="{FF2B5EF4-FFF2-40B4-BE49-F238E27FC236}">
-                <a16:creationId xmlns:a16="http://schemas.microsoft.com/office/drawing/2014/main" id="{64D4C29A-25C7-44B3-86D9-2FEE6BD36A39}"/>
+                <a16:creationId xmlns:a16="http://schemas.microsoft.com/office/drawing/2014/main" id="{7694A19B-0127-419F-975E-9F736E1EC5FA}"/>
               </a:ext>
             </a:extLst>
           </p:cNvPr>
@@ -16589,7 +16747,7 @@
           <p:cNvPr id="91" name="feature-body-1">
             <a:extLst xmlns:a="http://schemas.openxmlformats.org/drawingml/2006/main">
               <a:ext uri="{FF2B5EF4-FFF2-40B4-BE49-F238E27FC236}">
-                <a16:creationId xmlns:a16="http://schemas.microsoft.com/office/drawing/2014/main" id="{E33CED3D-C0D9-4CE7-8374-1A456B8F4879}"/>
+                <a16:creationId xmlns:a16="http://schemas.microsoft.com/office/drawing/2014/main" id="{65937D94-F1AB-406C-B084-25734CAAAC95}"/>
               </a:ext>
             </a:extLst>
           </p:cNvPr>
@@ -16747,7 +16905,7 @@
           <p:cNvPr id="92" name="feature-2">
             <a:extLst xmlns:a="http://schemas.openxmlformats.org/drawingml/2006/main">
               <a:ext uri="{FF2B5EF4-FFF2-40B4-BE49-F238E27FC236}">
-                <a16:creationId xmlns:a16="http://schemas.microsoft.com/office/drawing/2014/main" id="{263B6782-366A-4040-A4F0-126B42C40A69}"/>
+                <a16:creationId xmlns:a16="http://schemas.microsoft.com/office/drawing/2014/main" id="{68A761E1-832E-4CD1-912A-72BDA4B9D70D}"/>
               </a:ext>
             </a:extLst>
           </p:cNvPr>
@@ -16905,7 +17063,7 @@
           <p:cNvPr id="93" name="feature-body-2">
             <a:extLst xmlns:a="http://schemas.openxmlformats.org/drawingml/2006/main">
               <a:ext uri="{FF2B5EF4-FFF2-40B4-BE49-F238E27FC236}">
-                <a16:creationId xmlns:a16="http://schemas.microsoft.com/office/drawing/2014/main" id="{5B4EF7D4-9C9B-4837-9FB8-85FDAF6A800B}"/>
+                <a16:creationId xmlns:a16="http://schemas.microsoft.com/office/drawing/2014/main" id="{249DF411-6FCF-4047-9A67-402A78CAB618}"/>
               </a:ext>
             </a:extLst>
           </p:cNvPr>
@@ -17063,7 +17221,7 @@
           <p:cNvPr id="94" name="feature-3">
             <a:extLst xmlns:a="http://schemas.openxmlformats.org/drawingml/2006/main">
               <a:ext uri="{FF2B5EF4-FFF2-40B4-BE49-F238E27FC236}">
-                <a16:creationId xmlns:a16="http://schemas.microsoft.com/office/drawing/2014/main" id="{075DDCC7-57FC-4C18-866B-84FB46DA26AF}"/>
+                <a16:creationId xmlns:a16="http://schemas.microsoft.com/office/drawing/2014/main" id="{C56AA7B1-E9BF-4AF6-B52B-0ACE950A4217}"/>
               </a:ext>
             </a:extLst>
           </p:cNvPr>
@@ -17221,7 +17379,7 @@
           <p:cNvPr id="95" name="feature-body-3">
             <a:extLst xmlns:a="http://schemas.openxmlformats.org/drawingml/2006/main">
               <a:ext uri="{FF2B5EF4-FFF2-40B4-BE49-F238E27FC236}">
-                <a16:creationId xmlns:a16="http://schemas.microsoft.com/office/drawing/2014/main" id="{E2C63F9B-1DFD-4AE0-B1C9-F15E88208E47}"/>
+                <a16:creationId xmlns:a16="http://schemas.microsoft.com/office/drawing/2014/main" id="{DEB06E65-8343-4F9F-8AD4-E8BDD7F20BF0}"/>
               </a:ext>
             </a:extLst>
           </p:cNvPr>
@@ -17379,7 +17537,7 @@
           <p:cNvPr id="96" name="feature-4">
             <a:extLst xmlns:a="http://schemas.openxmlformats.org/drawingml/2006/main">
               <a:ext uri="{FF2B5EF4-FFF2-40B4-BE49-F238E27FC236}">
-                <a16:creationId xmlns:a16="http://schemas.microsoft.com/office/drawing/2014/main" id="{C6DBD3B9-AC1E-4B0F-A3CA-ABE9F1461F83}"/>
+                <a16:creationId xmlns:a16="http://schemas.microsoft.com/office/drawing/2014/main" id="{15F7217A-27AA-4376-819B-3E5EE2508941}"/>
               </a:ext>
             </a:extLst>
           </p:cNvPr>
@@ -17537,7 +17695,7 @@
           <p:cNvPr id="97" name="feature-body-4">
             <a:extLst xmlns:a="http://schemas.openxmlformats.org/drawingml/2006/main">
               <a:ext uri="{FF2B5EF4-FFF2-40B4-BE49-F238E27FC236}">
-                <a16:creationId xmlns:a16="http://schemas.microsoft.com/office/drawing/2014/main" id="{1AF49ED1-D673-4936-AE92-486A59D34935}"/>
+                <a16:creationId xmlns:a16="http://schemas.microsoft.com/office/drawing/2014/main" id="{B4C3D4FD-0C90-4C04-90B2-DD563E6AE631}"/>
               </a:ext>
             </a:extLst>
           </p:cNvPr>
@@ -17695,7 +17853,7 @@
           <p:cNvPr id="98" name="feature-5">
             <a:extLst xmlns:a="http://schemas.openxmlformats.org/drawingml/2006/main">
               <a:ext uri="{FF2B5EF4-FFF2-40B4-BE49-F238E27FC236}">
-                <a16:creationId xmlns:a16="http://schemas.microsoft.com/office/drawing/2014/main" id="{B7C43989-BD4A-4D5D-AFE3-AFAEDBA1D7E0}"/>
+                <a16:creationId xmlns:a16="http://schemas.microsoft.com/office/drawing/2014/main" id="{FAB71CAA-498F-41D2-8316-F04F5139811F}"/>
               </a:ext>
             </a:extLst>
           </p:cNvPr>
@@ -17853,7 +18011,7 @@
           <p:cNvPr id="99" name="feature-body-5">
             <a:extLst xmlns:a="http://schemas.openxmlformats.org/drawingml/2006/main">
               <a:ext uri="{FF2B5EF4-FFF2-40B4-BE49-F238E27FC236}">
-                <a16:creationId xmlns:a16="http://schemas.microsoft.com/office/drawing/2014/main" id="{6329F17D-DF0C-4064-A08C-491DB638AAF9}"/>
+                <a16:creationId xmlns:a16="http://schemas.microsoft.com/office/drawing/2014/main" id="{AFC9E2B7-97A4-4F97-8FA3-7C7E5CB75288}"/>
               </a:ext>
             </a:extLst>
           </p:cNvPr>
@@ -18011,7 +18169,7 @@
           <p:cNvPr id="100" name="readiness">
             <a:extLst xmlns:a="http://schemas.openxmlformats.org/drawingml/2006/main">
               <a:ext uri="{FF2B5EF4-FFF2-40B4-BE49-F238E27FC236}">
-                <a16:creationId xmlns:a16="http://schemas.microsoft.com/office/drawing/2014/main" id="{BC84B06B-BEE1-4F46-A6F8-5278B64C8D82}"/>
+                <a16:creationId xmlns:a16="http://schemas.microsoft.com/office/drawing/2014/main" id="{A8325637-6A26-463D-ACFC-03CD022E09F0}"/>
               </a:ext>
             </a:extLst>
           </p:cNvPr>
@@ -18022,8 +18180,8 @@
         </p:nvSpPr>
         <p:spPr>
           <a:xfrm xmlns:a="http://schemas.openxmlformats.org/drawingml/2006/main">
-            <a:off x="495300" y="4667250"/>
-            <a:ext cx="8153400" cy="238125"/>
+            <a:off x="495300" y="4562475"/>
+            <a:ext cx="8153400" cy="342900"/>
           </a:xfrm>
           <a:prstGeom xmlns:a="http://schemas.openxmlformats.org/drawingml/2006/main" prst="rect">
             <a:avLst/>
@@ -18039,7 +18197,7 @@
           </a:bodyPr>
           <a:lstStyle xmlns:a="http://schemas.openxmlformats.org/drawingml/2006/main">
             <a:defPPr>
-              <a:defRPr sz="975">
+              <a:defRPr sz="938">
                 <a:solidFill>
                   <a:srgbClr val="555555"/>
                 </a:solidFill>
@@ -18049,7 +18207,7 @@
               </a:defRPr>
             </a:defPPr>
             <a:lvl1pPr>
-              <a:defRPr sz="975">
+              <a:defRPr sz="938">
                 <a:solidFill>
                   <a:srgbClr val="555555"/>
                 </a:solidFill>
@@ -18059,7 +18217,7 @@
               </a:defRPr>
             </a:lvl1pPr>
             <a:lvl2pPr>
-              <a:defRPr sz="975">
+              <a:defRPr sz="938">
                 <a:solidFill>
                   <a:srgbClr val="555555"/>
                 </a:solidFill>
@@ -18069,7 +18227,7 @@
               </a:defRPr>
             </a:lvl2pPr>
             <a:lvl3pPr>
-              <a:defRPr sz="975">
+              <a:defRPr sz="938">
                 <a:solidFill>
                   <a:srgbClr val="555555"/>
                 </a:solidFill>
@@ -18079,7 +18237,7 @@
               </a:defRPr>
             </a:lvl3pPr>
             <a:lvl4pPr>
-              <a:defRPr sz="975">
+              <a:defRPr sz="938">
                 <a:solidFill>
                   <a:srgbClr val="555555"/>
                 </a:solidFill>
@@ -18089,7 +18247,7 @@
               </a:defRPr>
             </a:lvl4pPr>
             <a:lvl5pPr>
-              <a:defRPr sz="975">
+              <a:defRPr sz="938">
                 <a:solidFill>
                   <a:srgbClr val="555555"/>
                 </a:solidFill>
@@ -18099,7 +18257,7 @@
               </a:defRPr>
             </a:lvl5pPr>
             <a:lvl6pPr>
-              <a:defRPr sz="975">
+              <a:defRPr sz="938">
                 <a:solidFill>
                   <a:srgbClr val="555555"/>
                 </a:solidFill>
@@ -18109,7 +18267,7 @@
               </a:defRPr>
             </a:lvl6pPr>
             <a:lvl7pPr>
-              <a:defRPr sz="975">
+              <a:defRPr sz="938">
                 <a:solidFill>
                   <a:srgbClr val="555555"/>
                 </a:solidFill>
@@ -18119,7 +18277,7 @@
               </a:defRPr>
             </a:lvl7pPr>
             <a:lvl8pPr>
-              <a:defRPr sz="975">
+              <a:defRPr sz="938">
                 <a:solidFill>
                   <a:srgbClr val="555555"/>
                 </a:solidFill>
@@ -18129,7 +18287,7 @@
               </a:defRPr>
             </a:lvl8pPr>
             <a:lvl9pPr>
-              <a:defRPr sz="975">
+              <a:defRPr sz="938">
                 <a:solidFill>
                   <a:srgbClr val="555555"/>
                 </a:solidFill>
@@ -18141,7 +18299,7 @@
           </a:lstStyle>
           <a:p xmlns:a="http://schemas.openxmlformats.org/drawingml/2006/main">
             <a:pPr>
-              <a:defRPr sz="975">
+              <a:defRPr sz="938">
                 <a:solidFill>
                   <a:srgbClr val="555555"/>
                 </a:solidFill>
@@ -18151,7 +18309,7 @@
               </a:defRPr>
             </a:pPr>
             <a:r>
-              <a:rPr sz="975">
+              <a:rPr sz="938">
                 <a:solidFill>
                   <a:srgbClr val="555555"/>
                 </a:solidFill>
@@ -18159,7 +18317,30 @@
                 <a:ea typeface="Google Sans Flex"/>
                 <a:cs typeface="Google Sans Flex"/>
               </a:rPr>
-              <a:t>Local source implemented and checked; cloud work deferred by owner. Browser review pending.</a:t>
+              <a:t>Public Vercel device-only demonstration is accessible.</a:t>
+            </a:r>
+          </a:p>
+          <a:p xmlns:a="http://schemas.openxmlformats.org/drawingml/2006/main">
+            <a:pPr>
+              <a:defRPr sz="938">
+                <a:solidFill>
+                  <a:srgbClr val="555555"/>
+                </a:solidFill>
+                <a:latin typeface="Google Sans Flex"/>
+                <a:ea typeface="Google Sans Flex"/>
+                <a:cs typeface="Google Sans Flex"/>
+              </a:defRPr>
+            </a:pPr>
+            <a:r>
+              <a:rPr sz="938">
+                <a:solidFill>
+                  <a:srgbClr val="555555"/>
+                </a:solidFill>
+                <a:latin typeface="Google Sans Flex"/>
+                <a:ea typeface="Google Sans Flex"/>
+                <a:cs typeface="Google Sans Flex"/>
+              </a:rPr>
+              <a:t>Connected source is implemented; live Google Cloud integration remains unverified.</a:t>
             </a:r>
           </a:p>
         </p:txBody>
@@ -18167,7 +18348,7 @@
     </p:spTree>
     <p:extLst>
       <p:ext uri="{BB962C8B-B14F-4D97-AF65-F5344CB8AC3E}">
-        <p14:creationId xmlns:p14="http://schemas.microsoft.com/office/powerpoint/2010/main" val="650651304"/>
+        <p14:creationId xmlns:p14="http://schemas.microsoft.com/office/powerpoint/2010/main" val="1546846499"/>
       </p:ext>
     </p:extLst>
   </p:cSld>
@@ -18191,7 +18372,7 @@
           <p:cNvPr id="92" name="Google Shape;92;p18">
             <a:extLst xmlns:a="http://schemas.openxmlformats.org/drawingml/2006/main">
               <a:ext uri="{FF2B5EF4-FFF2-40B4-BE49-F238E27FC236}">
-                <a16:creationId xmlns:a16="http://schemas.microsoft.com/office/drawing/2014/main" id="{05B9A685-0A29-45EB-83A6-CE564F539F03}"/>
+                <a16:creationId xmlns:a16="http://schemas.microsoft.com/office/drawing/2014/main" id="{CF80D4FB-079D-42F2-8152-B16840ACE25E}"/>
               </a:ext>
             </a:extLst>
           </p:cNvPr>
@@ -18201,7 +18382,7 @@
           <p:nvPr/>
         </p:nvPicPr>
         <p:blipFill rotWithShape="1">
-          <a:blip xmlns:r="http://schemas.openxmlformats.org/officeDocument/2006/relationships" xmlns:a="http://schemas.openxmlformats.org/drawingml/2006/main" r:embed="R984a0d6ac547442f">
+          <a:blip xmlns:r="http://schemas.openxmlformats.org/officeDocument/2006/relationships" xmlns:a="http://schemas.openxmlformats.org/drawingml/2006/main" r:embed="Rcbb871fbc7bc43b9">
             <a:alphaModFix/>
           </a:blip>
           <a:srcRect xmlns:a="http://schemas.openxmlformats.org/drawingml/2006/main" l="0" t="0" r="0" b="98001"/>
@@ -18225,7 +18406,7 @@
           <p:cNvPr id="93" name="Google Shape;93;p18">
             <a:extLst xmlns:a="http://schemas.openxmlformats.org/drawingml/2006/main">
               <a:ext uri="{FF2B5EF4-FFF2-40B4-BE49-F238E27FC236}">
-                <a16:creationId xmlns:a16="http://schemas.microsoft.com/office/drawing/2014/main" id="{633BA815-D2A5-4F39-A8AC-433A0A84ED38}"/>
+                <a16:creationId xmlns:a16="http://schemas.microsoft.com/office/drawing/2014/main" id="{35D032E7-EC33-4099-A2CC-F0B8C35EECFB}"/>
               </a:ext>
             </a:extLst>
           </p:cNvPr>
@@ -18235,7 +18416,7 @@
           <p:nvPr/>
         </p:nvPicPr>
         <p:blipFill>
-          <a:blip xmlns:r="http://schemas.openxmlformats.org/officeDocument/2006/relationships" xmlns:a="http://schemas.openxmlformats.org/drawingml/2006/main" r:embed="Rcceb2f17bb0c42fd">
+          <a:blip xmlns:r="http://schemas.openxmlformats.org/officeDocument/2006/relationships" xmlns:a="http://schemas.openxmlformats.org/drawingml/2006/main" r:embed="Ra1e145442d5c4543">
             <a:alphaModFix/>
           </a:blip>
           <a:stretch xmlns:a="http://schemas.openxmlformats.org/drawingml/2006/main">
@@ -18260,7 +18441,7 @@
           <p:cNvPr id="94" name="Google Shape;94;p18">
             <a:extLst xmlns:a="http://schemas.openxmlformats.org/drawingml/2006/main">
               <a:ext uri="{FF2B5EF4-FFF2-40B4-BE49-F238E27FC236}">
-                <a16:creationId xmlns:a16="http://schemas.microsoft.com/office/drawing/2014/main" id="{D2919AB1-4A5B-4347-9863-31295DBEEDEA}"/>
+                <a16:creationId xmlns:a16="http://schemas.microsoft.com/office/drawing/2014/main" id="{9395FE70-1C8B-4885-B8C3-3F4A9E4DEAFC}"/>
               </a:ext>
             </a:extLst>
           </p:cNvPr>
@@ -18311,7 +18492,7 @@
           <p:cNvPr id="95" name="Google Shape;95;p18">
             <a:extLst xmlns:a="http://schemas.openxmlformats.org/drawingml/2006/main">
               <a:ext uri="{FF2B5EF4-FFF2-40B4-BE49-F238E27FC236}">
-                <a16:creationId xmlns:a16="http://schemas.microsoft.com/office/drawing/2014/main" id="{332BFF04-993E-4C53-815B-56AE33E59DC0}"/>
+                <a16:creationId xmlns:a16="http://schemas.microsoft.com/office/drawing/2014/main" id="{BEAC9B32-8571-4E72-AB58-E4E830988647}"/>
               </a:ext>
             </a:extLst>
           </p:cNvPr>
@@ -18369,7 +18550,7 @@
           <p:cNvPr id="96" name="step-0">
             <a:extLst xmlns:a="http://schemas.openxmlformats.org/drawingml/2006/main">
               <a:ext uri="{FF2B5EF4-FFF2-40B4-BE49-F238E27FC236}">
-                <a16:creationId xmlns:a16="http://schemas.microsoft.com/office/drawing/2014/main" id="{99105A7A-BCD6-4174-8818-D28743AA4665}"/>
+                <a16:creationId xmlns:a16="http://schemas.microsoft.com/office/drawing/2014/main" id="{CF203001-5EF8-4DC7-8515-22380C39E4C4}"/>
               </a:ext>
             </a:extLst>
           </p:cNvPr>
@@ -18401,7 +18582,7 @@
           <p:cNvPr id="97" name="step-head-0">
             <a:extLst xmlns:a="http://schemas.openxmlformats.org/drawingml/2006/main">
               <a:ext uri="{FF2B5EF4-FFF2-40B4-BE49-F238E27FC236}">
-                <a16:creationId xmlns:a16="http://schemas.microsoft.com/office/drawing/2014/main" id="{8DCCBC17-68B1-4639-B51F-5A65E6D8ED81}"/>
+                <a16:creationId xmlns:a16="http://schemas.microsoft.com/office/drawing/2014/main" id="{B90D9D28-BA14-44D5-BC2D-A96A57DEBA54}"/>
               </a:ext>
             </a:extLst>
           </p:cNvPr>
@@ -18559,7 +18740,7 @@
           <p:cNvPr id="98" name="step-copy-0">
             <a:extLst xmlns:a="http://schemas.openxmlformats.org/drawingml/2006/main">
               <a:ext uri="{FF2B5EF4-FFF2-40B4-BE49-F238E27FC236}">
-                <a16:creationId xmlns:a16="http://schemas.microsoft.com/office/drawing/2014/main" id="{B27DE875-587A-4843-8360-9505BD7EC75A}"/>
+                <a16:creationId xmlns:a16="http://schemas.microsoft.com/office/drawing/2014/main" id="{09533905-FE61-44BF-8683-0B7D98DEA11C}"/>
               </a:ext>
             </a:extLst>
           </p:cNvPr>
@@ -18740,7 +18921,7 @@
           <p:cNvPr id="99" name="">
             <a:extLst xmlns:a="http://schemas.openxmlformats.org/drawingml/2006/main">
               <a:ext uri="{FF2B5EF4-FFF2-40B4-BE49-F238E27FC236}">
-                <a16:creationId xmlns:a16="http://schemas.microsoft.com/office/drawing/2014/main" id="{7E26F254-5E68-4C88-92D0-33F709850BA5}"/>
+                <a16:creationId xmlns:a16="http://schemas.microsoft.com/office/drawing/2014/main" id="{0B38299E-C725-4324-BEFE-F0634FCEAB81}"/>
               </a:ext>
             </a:extLst>
           </p:cNvPr>
@@ -18772,7 +18953,7 @@
           <p:cNvPr id="100" name="step-1">
             <a:extLst xmlns:a="http://schemas.openxmlformats.org/drawingml/2006/main">
               <a:ext uri="{FF2B5EF4-FFF2-40B4-BE49-F238E27FC236}">
-                <a16:creationId xmlns:a16="http://schemas.microsoft.com/office/drawing/2014/main" id="{35FAAD66-5CBC-4508-A5A3-56471E5E4FCE}"/>
+                <a16:creationId xmlns:a16="http://schemas.microsoft.com/office/drawing/2014/main" id="{8EFBE524-DBAA-4BB0-AF90-6EBA492A1FB2}"/>
               </a:ext>
             </a:extLst>
           </p:cNvPr>
@@ -18804,7 +18985,7 @@
           <p:cNvPr id="101" name="step-head-1">
             <a:extLst xmlns:a="http://schemas.openxmlformats.org/drawingml/2006/main">
               <a:ext uri="{FF2B5EF4-FFF2-40B4-BE49-F238E27FC236}">
-                <a16:creationId xmlns:a16="http://schemas.microsoft.com/office/drawing/2014/main" id="{BEA24CC0-A1C6-4058-B612-25E28D07AB40}"/>
+                <a16:creationId xmlns:a16="http://schemas.microsoft.com/office/drawing/2014/main" id="{B870AF6F-B953-45C5-AC4F-CEE054FAF70A}"/>
               </a:ext>
             </a:extLst>
           </p:cNvPr>
@@ -18962,7 +19143,7 @@
           <p:cNvPr id="102" name="step-copy-1">
             <a:extLst xmlns:a="http://schemas.openxmlformats.org/drawingml/2006/main">
               <a:ext uri="{FF2B5EF4-FFF2-40B4-BE49-F238E27FC236}">
-                <a16:creationId xmlns:a16="http://schemas.microsoft.com/office/drawing/2014/main" id="{8EF3FF66-E45C-4AC2-91F9-4C957E97B783}"/>
+                <a16:creationId xmlns:a16="http://schemas.microsoft.com/office/drawing/2014/main" id="{1544E2EA-25A0-4760-A027-23C0B0DFAAF2}"/>
               </a:ext>
             </a:extLst>
           </p:cNvPr>
@@ -19143,7 +19324,7 @@
           <p:cNvPr id="103" name="">
             <a:extLst xmlns:a="http://schemas.openxmlformats.org/drawingml/2006/main">
               <a:ext uri="{FF2B5EF4-FFF2-40B4-BE49-F238E27FC236}">
-                <a16:creationId xmlns:a16="http://schemas.microsoft.com/office/drawing/2014/main" id="{2620941E-5165-4A32-947A-A337DAE271F1}"/>
+                <a16:creationId xmlns:a16="http://schemas.microsoft.com/office/drawing/2014/main" id="{026B1763-E80E-4C01-A49D-213777C99908}"/>
               </a:ext>
             </a:extLst>
           </p:cNvPr>
@@ -19175,7 +19356,7 @@
           <p:cNvPr id="104" name="step-2">
             <a:extLst xmlns:a="http://schemas.openxmlformats.org/drawingml/2006/main">
               <a:ext uri="{FF2B5EF4-FFF2-40B4-BE49-F238E27FC236}">
-                <a16:creationId xmlns:a16="http://schemas.microsoft.com/office/drawing/2014/main" id="{426E5268-D239-4875-BDAD-337F45E1518A}"/>
+                <a16:creationId xmlns:a16="http://schemas.microsoft.com/office/drawing/2014/main" id="{1FF1BC5B-B19B-4B0B-89BD-47E37694C9FA}"/>
               </a:ext>
             </a:extLst>
           </p:cNvPr>
@@ -19207,7 +19388,7 @@
           <p:cNvPr id="105" name="step-head-2">
             <a:extLst xmlns:a="http://schemas.openxmlformats.org/drawingml/2006/main">
               <a:ext uri="{FF2B5EF4-FFF2-40B4-BE49-F238E27FC236}">
-                <a16:creationId xmlns:a16="http://schemas.microsoft.com/office/drawing/2014/main" id="{AFEEEB21-7628-49EB-BBB3-6D7BD22C13A1}"/>
+                <a16:creationId xmlns:a16="http://schemas.microsoft.com/office/drawing/2014/main" id="{BA749D68-625F-4F92-B468-9D1C905EDB11}"/>
               </a:ext>
             </a:extLst>
           </p:cNvPr>
@@ -19365,7 +19546,7 @@
           <p:cNvPr id="106" name="step-copy-2">
             <a:extLst xmlns:a="http://schemas.openxmlformats.org/drawingml/2006/main">
               <a:ext uri="{FF2B5EF4-FFF2-40B4-BE49-F238E27FC236}">
-                <a16:creationId xmlns:a16="http://schemas.microsoft.com/office/drawing/2014/main" id="{BEDC997D-98C9-495B-AA03-39B31F462927}"/>
+                <a16:creationId xmlns:a16="http://schemas.microsoft.com/office/drawing/2014/main" id="{06EB580F-DC16-40CF-B1F7-7D3A0CE3AF2A}"/>
               </a:ext>
             </a:extLst>
           </p:cNvPr>
@@ -19546,7 +19727,7 @@
           <p:cNvPr id="107" name="">
             <a:extLst xmlns:a="http://schemas.openxmlformats.org/drawingml/2006/main">
               <a:ext uri="{FF2B5EF4-FFF2-40B4-BE49-F238E27FC236}">
-                <a16:creationId xmlns:a16="http://schemas.microsoft.com/office/drawing/2014/main" id="{7E07E016-DC41-444F-A0AF-F80D0E7BAE10}"/>
+                <a16:creationId xmlns:a16="http://schemas.microsoft.com/office/drawing/2014/main" id="{E74202E7-661C-441E-9915-1D146B93778B}"/>
               </a:ext>
             </a:extLst>
           </p:cNvPr>
@@ -19578,7 +19759,7 @@
           <p:cNvPr id="108" name="step-3">
             <a:extLst xmlns:a="http://schemas.openxmlformats.org/drawingml/2006/main">
               <a:ext uri="{FF2B5EF4-FFF2-40B4-BE49-F238E27FC236}">
-                <a16:creationId xmlns:a16="http://schemas.microsoft.com/office/drawing/2014/main" id="{CECAB457-7C0D-4D11-9274-0A9C67DA8074}"/>
+                <a16:creationId xmlns:a16="http://schemas.microsoft.com/office/drawing/2014/main" id="{F8AE5AFB-3C82-4818-BBC6-28D8B8E1B47F}"/>
               </a:ext>
             </a:extLst>
           </p:cNvPr>
@@ -19610,7 +19791,7 @@
           <p:cNvPr id="109" name="step-head-3">
             <a:extLst xmlns:a="http://schemas.openxmlformats.org/drawingml/2006/main">
               <a:ext uri="{FF2B5EF4-FFF2-40B4-BE49-F238E27FC236}">
-                <a16:creationId xmlns:a16="http://schemas.microsoft.com/office/drawing/2014/main" id="{EF3BA800-D0D7-4D94-BEB5-6FC9CA8D1CC2}"/>
+                <a16:creationId xmlns:a16="http://schemas.microsoft.com/office/drawing/2014/main" id="{D9D7A448-5548-47E0-AA8C-8DDBCC520B56}"/>
               </a:ext>
             </a:extLst>
           </p:cNvPr>
@@ -19768,7 +19949,7 @@
           <p:cNvPr id="110" name="step-copy-3">
             <a:extLst xmlns:a="http://schemas.openxmlformats.org/drawingml/2006/main">
               <a:ext uri="{FF2B5EF4-FFF2-40B4-BE49-F238E27FC236}">
-                <a16:creationId xmlns:a16="http://schemas.microsoft.com/office/drawing/2014/main" id="{19B9DF5C-B251-4327-9915-2DC9A48DD089}"/>
+                <a16:creationId xmlns:a16="http://schemas.microsoft.com/office/drawing/2014/main" id="{ECED4423-0B98-453A-979C-6314602D64AD}"/>
               </a:ext>
             </a:extLst>
           </p:cNvPr>
@@ -19949,7 +20130,7 @@
           <p:cNvPr id="111" name="">
             <a:extLst xmlns:a="http://schemas.openxmlformats.org/drawingml/2006/main">
               <a:ext uri="{FF2B5EF4-FFF2-40B4-BE49-F238E27FC236}">
-                <a16:creationId xmlns:a16="http://schemas.microsoft.com/office/drawing/2014/main" id="{46FA0D78-65F5-4B7C-A398-B264280BE090}"/>
+                <a16:creationId xmlns:a16="http://schemas.microsoft.com/office/drawing/2014/main" id="{8C21D5DB-749F-477B-8908-A83156D86B82}"/>
               </a:ext>
             </a:extLst>
           </p:cNvPr>
@@ -19981,7 +20162,7 @@
           <p:cNvPr id="112" name="step-4">
             <a:extLst xmlns:a="http://schemas.openxmlformats.org/drawingml/2006/main">
               <a:ext uri="{FF2B5EF4-FFF2-40B4-BE49-F238E27FC236}">
-                <a16:creationId xmlns:a16="http://schemas.microsoft.com/office/drawing/2014/main" id="{349C9441-76F5-4FF8-81B0-78CEB1548FC8}"/>
+                <a16:creationId xmlns:a16="http://schemas.microsoft.com/office/drawing/2014/main" id="{F117F0D5-7C62-4E8E-A9F5-5B26522E342E}"/>
               </a:ext>
             </a:extLst>
           </p:cNvPr>
@@ -20013,7 +20194,7 @@
           <p:cNvPr id="113" name="step-head-4">
             <a:extLst xmlns:a="http://schemas.openxmlformats.org/drawingml/2006/main">
               <a:ext uri="{FF2B5EF4-FFF2-40B4-BE49-F238E27FC236}">
-                <a16:creationId xmlns:a16="http://schemas.microsoft.com/office/drawing/2014/main" id="{62E352AD-F85A-4EE8-987C-5E4BC04DED73}"/>
+                <a16:creationId xmlns:a16="http://schemas.microsoft.com/office/drawing/2014/main" id="{E5E9C5A1-6846-4EDC-A293-FB865AA5D038}"/>
               </a:ext>
             </a:extLst>
           </p:cNvPr>
@@ -20171,7 +20352,7 @@
           <p:cNvPr id="114" name="step-copy-4">
             <a:extLst xmlns:a="http://schemas.openxmlformats.org/drawingml/2006/main">
               <a:ext uri="{FF2B5EF4-FFF2-40B4-BE49-F238E27FC236}">
-                <a16:creationId xmlns:a16="http://schemas.microsoft.com/office/drawing/2014/main" id="{985564B0-501E-4B4D-A717-265EE808C704}"/>
+                <a16:creationId xmlns:a16="http://schemas.microsoft.com/office/drawing/2014/main" id="{3845DD61-3C4F-478F-B1F6-A36F78AD9497}"/>
               </a:ext>
             </a:extLst>
           </p:cNvPr>
@@ -20352,7 +20533,7 @@
           <p:cNvPr id="115" name="hold-rule">
             <a:extLst xmlns:a="http://schemas.openxmlformats.org/drawingml/2006/main">
               <a:ext uri="{FF2B5EF4-FFF2-40B4-BE49-F238E27FC236}">
-                <a16:creationId xmlns:a16="http://schemas.microsoft.com/office/drawing/2014/main" id="{E93F6319-960F-428D-9BD1-AE186DB07C38}"/>
+                <a16:creationId xmlns:a16="http://schemas.microsoft.com/office/drawing/2014/main" id="{2DE9D220-D98C-43DE-918A-3EEC85219471}"/>
               </a:ext>
             </a:extLst>
           </p:cNvPr>
@@ -20510,7 +20691,7 @@
           <p:cNvPr id="116" name="quorum-rule">
             <a:extLst xmlns:a="http://schemas.openxmlformats.org/drawingml/2006/main">
               <a:ext uri="{FF2B5EF4-FFF2-40B4-BE49-F238E27FC236}">
-                <a16:creationId xmlns:a16="http://schemas.microsoft.com/office/drawing/2014/main" id="{11D5F190-EFE6-4087-B9C0-9530FECAF307}"/>
+                <a16:creationId xmlns:a16="http://schemas.microsoft.com/office/drawing/2014/main" id="{F676E33E-9DE9-4F13-AE8F-1956A2A296DF}"/>
               </a:ext>
             </a:extLst>
           </p:cNvPr>
@@ -20666,7 +20847,7 @@
     </p:spTree>
     <p:extLst>
       <p:ext uri="{BB962C8B-B14F-4D97-AF65-F5344CB8AC3E}">
-        <p14:creationId xmlns:p14="http://schemas.microsoft.com/office/powerpoint/2010/main" val="405901794"/>
+        <p14:creationId xmlns:p14="http://schemas.microsoft.com/office/powerpoint/2010/main" val="1274281182"/>
       </p:ext>
     </p:extLst>
   </p:cSld>
@@ -20690,7 +20871,7 @@
           <p:cNvPr id="100" name="Google Shape;100;p19">
             <a:extLst xmlns:a="http://schemas.openxmlformats.org/drawingml/2006/main">
               <a:ext uri="{FF2B5EF4-FFF2-40B4-BE49-F238E27FC236}">
-                <a16:creationId xmlns:a16="http://schemas.microsoft.com/office/drawing/2014/main" id="{83B99EE0-2BC9-4DFB-81F3-C7C5C52A8A9D}"/>
+                <a16:creationId xmlns:a16="http://schemas.microsoft.com/office/drawing/2014/main" id="{DFCC676B-5A9A-4A8D-B113-C014B9D1A014}"/>
               </a:ext>
             </a:extLst>
           </p:cNvPr>
@@ -20700,7 +20881,7 @@
           <p:nvPr/>
         </p:nvPicPr>
         <p:blipFill rotWithShape="1">
-          <a:blip xmlns:r="http://schemas.openxmlformats.org/officeDocument/2006/relationships" xmlns:a="http://schemas.openxmlformats.org/drawingml/2006/main" r:embed="Rfcbfeb4b97bf4a90">
+          <a:blip xmlns:r="http://schemas.openxmlformats.org/officeDocument/2006/relationships" xmlns:a="http://schemas.openxmlformats.org/drawingml/2006/main" r:embed="R1fedb11586284cfb">
             <a:alphaModFix/>
           </a:blip>
           <a:srcRect xmlns:a="http://schemas.openxmlformats.org/drawingml/2006/main" l="0" t="0" r="0" b="98001"/>
@@ -20724,7 +20905,7 @@
           <p:cNvPr id="101" name="Google Shape;101;p19">
             <a:extLst xmlns:a="http://schemas.openxmlformats.org/drawingml/2006/main">
               <a:ext uri="{FF2B5EF4-FFF2-40B4-BE49-F238E27FC236}">
-                <a16:creationId xmlns:a16="http://schemas.microsoft.com/office/drawing/2014/main" id="{FFB6E6F6-315B-4082-8FCB-3DB4025D8BAF}"/>
+                <a16:creationId xmlns:a16="http://schemas.microsoft.com/office/drawing/2014/main" id="{7328CE37-3BA5-4A3D-8CEF-9BEFF0A8FB43}"/>
               </a:ext>
             </a:extLst>
           </p:cNvPr>
@@ -20734,7 +20915,7 @@
           <p:nvPr/>
         </p:nvPicPr>
         <p:blipFill>
-          <a:blip xmlns:r="http://schemas.openxmlformats.org/officeDocument/2006/relationships" xmlns:a="http://schemas.openxmlformats.org/drawingml/2006/main" r:embed="Rcd86176705744c3e">
+          <a:blip xmlns:r="http://schemas.openxmlformats.org/officeDocument/2006/relationships" xmlns:a="http://schemas.openxmlformats.org/drawingml/2006/main" r:embed="Rd42f40a4db61473b">
             <a:alphaModFix/>
           </a:blip>
           <a:stretch xmlns:a="http://schemas.openxmlformats.org/drawingml/2006/main">
@@ -20759,7 +20940,7 @@
           <p:cNvPr id="102" name="Google Shape;102;p19">
             <a:extLst xmlns:a="http://schemas.openxmlformats.org/drawingml/2006/main">
               <a:ext uri="{FF2B5EF4-FFF2-40B4-BE49-F238E27FC236}">
-                <a16:creationId xmlns:a16="http://schemas.microsoft.com/office/drawing/2014/main" id="{AC3CD9F1-9A6C-4C06-9DD5-F6664D52B7B7}"/>
+                <a16:creationId xmlns:a16="http://schemas.microsoft.com/office/drawing/2014/main" id="{4C6DC2F5-5615-4F88-9077-5A7E8135E2BB}"/>
               </a:ext>
             </a:extLst>
           </p:cNvPr>
@@ -20810,7 +20991,7 @@
           <p:cNvPr id="103" name="Google Shape;103;p19">
             <a:extLst xmlns:a="http://schemas.openxmlformats.org/drawingml/2006/main">
               <a:ext uri="{FF2B5EF4-FFF2-40B4-BE49-F238E27FC236}">
-                <a16:creationId xmlns:a16="http://schemas.microsoft.com/office/drawing/2014/main" id="{52CB2A0B-BBB9-4656-B506-633C6EC4ADDD}"/>
+                <a16:creationId xmlns:a16="http://schemas.microsoft.com/office/drawing/2014/main" id="{575F18A8-E208-4BAD-B3BD-393B1D45BCD7}"/>
               </a:ext>
             </a:extLst>
           </p:cNvPr>
@@ -20868,7 +21049,7 @@
           <p:cNvPr id="104" name="">
             <a:extLst xmlns:a="http://schemas.openxmlformats.org/drawingml/2006/main">
               <a:ext uri="{FF2B5EF4-FFF2-40B4-BE49-F238E27FC236}">
-                <a16:creationId xmlns:a16="http://schemas.microsoft.com/office/drawing/2014/main" id="{2670C884-5289-4CB9-A2F2-2CE756621374}"/>
+                <a16:creationId xmlns:a16="http://schemas.microsoft.com/office/drawing/2014/main" id="{536C59FA-A01E-4646-A66B-6B6EF7FE6760}"/>
               </a:ext>
             </a:extLst>
           </p:cNvPr>
@@ -20878,7 +21059,7 @@
           <p:nvPr/>
         </p:nvPicPr>
         <p:blipFill>
-          <a:blip xmlns:r="http://schemas.openxmlformats.org/officeDocument/2006/relationships" xmlns:a="http://schemas.openxmlformats.org/drawingml/2006/main" r:embed="R00ef8abbad38475b"/>
+          <a:blip xmlns:r="http://schemas.openxmlformats.org/officeDocument/2006/relationships" xmlns:a="http://schemas.openxmlformats.org/drawingml/2006/main" r:embed="R86f7dc07d7154857"/>
           <a:stretch xmlns:a="http://schemas.openxmlformats.org/drawingml/2006/main"/>
         </p:blipFill>
         <p:spPr>
@@ -20896,7 +21077,7 @@
           <p:cNvPr id="105" name="wireframe-label">
             <a:extLst xmlns:a="http://schemas.openxmlformats.org/drawingml/2006/main">
               <a:ext uri="{FF2B5EF4-FFF2-40B4-BE49-F238E27FC236}">
-                <a16:creationId xmlns:a16="http://schemas.microsoft.com/office/drawing/2014/main" id="{C96AAC62-C540-465D-B1F5-A50A5E369910}"/>
+                <a16:creationId xmlns:a16="http://schemas.microsoft.com/office/drawing/2014/main" id="{3FA9B5BF-4AFD-4106-99A7-9920406196DE}"/>
               </a:ext>
             </a:extLst>
           </p:cNvPr>
@@ -21054,7 +21235,7 @@
           <p:cNvPr id="106" name="ledger-label">
             <a:extLst xmlns:a="http://schemas.openxmlformats.org/drawingml/2006/main">
               <a:ext uri="{FF2B5EF4-FFF2-40B4-BE49-F238E27FC236}">
-                <a16:creationId xmlns:a16="http://schemas.microsoft.com/office/drawing/2014/main" id="{80E975DA-BCA2-4651-9DB8-EBFDF86EBADF}"/>
+                <a16:creationId xmlns:a16="http://schemas.microsoft.com/office/drawing/2014/main" id="{3817581D-40A7-45D9-919D-059C23DDF407}"/>
               </a:ext>
             </a:extLst>
           </p:cNvPr>
@@ -21212,7 +21393,7 @@
           <p:cNvPr id="107" name="claims">
             <a:extLst xmlns:a="http://schemas.openxmlformats.org/drawingml/2006/main">
               <a:ext uri="{FF2B5EF4-FFF2-40B4-BE49-F238E27FC236}">
-                <a16:creationId xmlns:a16="http://schemas.microsoft.com/office/drawing/2014/main" id="{394460AE-E099-4526-A824-061AE4BC5A61}"/>
+                <a16:creationId xmlns:a16="http://schemas.microsoft.com/office/drawing/2014/main" id="{E5722BF7-3BAE-4AAF-9A27-856879C20642}"/>
               </a:ext>
             </a:extLst>
           </p:cNvPr>
@@ -21370,7 +21551,7 @@
           <p:cNvPr id="108" name="verified">
             <a:extLst xmlns:a="http://schemas.openxmlformats.org/drawingml/2006/main">
               <a:ext uri="{FF2B5EF4-FFF2-40B4-BE49-F238E27FC236}">
-                <a16:creationId xmlns:a16="http://schemas.microsoft.com/office/drawing/2014/main" id="{00F54960-39BC-46B1-8DCB-3E760CFE3074}"/>
+                <a16:creationId xmlns:a16="http://schemas.microsoft.com/office/drawing/2014/main" id="{D9E713BC-6840-466D-841E-3BDBAFBEDC3B}"/>
               </a:ext>
             </a:extLst>
           </p:cNvPr>
@@ -21528,7 +21709,7 @@
           <p:cNvPr id="109" name="claims-label">
             <a:extLst xmlns:a="http://schemas.openxmlformats.org/drawingml/2006/main">
               <a:ext uri="{FF2B5EF4-FFF2-40B4-BE49-F238E27FC236}">
-                <a16:creationId xmlns:a16="http://schemas.microsoft.com/office/drawing/2014/main" id="{5213B846-2B7E-410A-B88B-D84FBFB60C86}"/>
+                <a16:creationId xmlns:a16="http://schemas.microsoft.com/office/drawing/2014/main" id="{E3D6F53C-7702-46D6-A234-63774419562A}"/>
               </a:ext>
             </a:extLst>
           </p:cNvPr>
@@ -21686,7 +21867,7 @@
           <p:cNvPr id="110" name="verified-label">
             <a:extLst xmlns:a="http://schemas.openxmlformats.org/drawingml/2006/main">
               <a:ext uri="{FF2B5EF4-FFF2-40B4-BE49-F238E27FC236}">
-                <a16:creationId xmlns:a16="http://schemas.microsoft.com/office/drawing/2014/main" id="{D595228E-7BFB-4FB5-AA69-FF89C24250BD}"/>
+                <a16:creationId xmlns:a16="http://schemas.microsoft.com/office/drawing/2014/main" id="{AD72C444-F0FE-4DAA-A92A-E9485F279240}"/>
               </a:ext>
             </a:extLst>
           </p:cNvPr>
@@ -21844,7 +22025,7 @@
           <p:cNvPr id="111" name="claims-bar">
             <a:extLst xmlns:a="http://schemas.openxmlformats.org/drawingml/2006/main">
               <a:ext uri="{FF2B5EF4-FFF2-40B4-BE49-F238E27FC236}">
-                <a16:creationId xmlns:a16="http://schemas.microsoft.com/office/drawing/2014/main" id="{476F2869-53C2-4BC1-871E-1C272A26F5B7}"/>
+                <a16:creationId xmlns:a16="http://schemas.microsoft.com/office/drawing/2014/main" id="{33620A74-F10A-4FC8-9826-01551A9C6E97}"/>
               </a:ext>
             </a:extLst>
           </p:cNvPr>
@@ -21876,7 +22057,7 @@
           <p:cNvPr id="112" name="verified-bar">
             <a:extLst xmlns:a="http://schemas.openxmlformats.org/drawingml/2006/main">
               <a:ext uri="{FF2B5EF4-FFF2-40B4-BE49-F238E27FC236}">
-                <a16:creationId xmlns:a16="http://schemas.microsoft.com/office/drawing/2014/main" id="{054E8343-0BC0-40CC-8645-68FEC8513D99}"/>
+                <a16:creationId xmlns:a16="http://schemas.microsoft.com/office/drawing/2014/main" id="{1AF5C3EB-50F2-4125-ADB5-BD8752225F20}"/>
               </a:ext>
             </a:extLst>
           </p:cNvPr>
@@ -21908,7 +22089,7 @@
           <p:cNvPr id="113" name="mock-notice">
             <a:extLst xmlns:a="http://schemas.openxmlformats.org/drawingml/2006/main">
               <a:ext uri="{FF2B5EF4-FFF2-40B4-BE49-F238E27FC236}">
-                <a16:creationId xmlns:a16="http://schemas.microsoft.com/office/drawing/2014/main" id="{20845BC1-3206-493F-972D-F933463575B4}"/>
+                <a16:creationId xmlns:a16="http://schemas.microsoft.com/office/drawing/2014/main" id="{85993C6A-2FC3-42EB-9A2A-1C47706697E8}"/>
               </a:ext>
             </a:extLst>
           </p:cNvPr>
@@ -22110,7 +22291,7 @@
     </p:spTree>
     <p:extLst>
       <p:ext uri="{BB962C8B-B14F-4D97-AF65-F5344CB8AC3E}">
-        <p14:creationId xmlns:p14="http://schemas.microsoft.com/office/powerpoint/2010/main" val="2057153159"/>
+        <p14:creationId xmlns:p14="http://schemas.microsoft.com/office/powerpoint/2010/main" val="682134654"/>
       </p:ext>
     </p:extLst>
   </p:cSld>
@@ -22134,7 +22315,7 @@
           <p:cNvPr id="108" name="Google Shape;108;p20">
             <a:extLst xmlns:a="http://schemas.openxmlformats.org/drawingml/2006/main">
               <a:ext uri="{FF2B5EF4-FFF2-40B4-BE49-F238E27FC236}">
-                <a16:creationId xmlns:a16="http://schemas.microsoft.com/office/drawing/2014/main" id="{B1D2E035-8F30-4917-B785-29F3269B7F2D}"/>
+                <a16:creationId xmlns:a16="http://schemas.microsoft.com/office/drawing/2014/main" id="{0EF576D0-D601-4CEA-9FE4-43945D7A5DA6}"/>
               </a:ext>
             </a:extLst>
           </p:cNvPr>
@@ -22144,7 +22325,7 @@
           <p:nvPr/>
         </p:nvPicPr>
         <p:blipFill rotWithShape="1">
-          <a:blip xmlns:r="http://schemas.openxmlformats.org/officeDocument/2006/relationships" xmlns:a="http://schemas.openxmlformats.org/drawingml/2006/main" r:embed="R41b0766d29c64c52">
+          <a:blip xmlns:r="http://schemas.openxmlformats.org/officeDocument/2006/relationships" xmlns:a="http://schemas.openxmlformats.org/drawingml/2006/main" r:embed="R127357aab55f40b1">
             <a:alphaModFix/>
           </a:blip>
           <a:srcRect xmlns:a="http://schemas.openxmlformats.org/drawingml/2006/main" l="0" t="0" r="0" b="98001"/>
@@ -22168,7 +22349,7 @@
           <p:cNvPr id="109" name="Google Shape;109;p20">
             <a:extLst xmlns:a="http://schemas.openxmlformats.org/drawingml/2006/main">
               <a:ext uri="{FF2B5EF4-FFF2-40B4-BE49-F238E27FC236}">
-                <a16:creationId xmlns:a16="http://schemas.microsoft.com/office/drawing/2014/main" id="{D0296AEE-3991-4631-AA94-5ABB3CF22932}"/>
+                <a16:creationId xmlns:a16="http://schemas.microsoft.com/office/drawing/2014/main" id="{3268EDCF-52F9-414B-8B86-C7A889F67FA1}"/>
               </a:ext>
             </a:extLst>
           </p:cNvPr>
@@ -22178,7 +22359,7 @@
           <p:nvPr/>
         </p:nvPicPr>
         <p:blipFill>
-          <a:blip xmlns:r="http://schemas.openxmlformats.org/officeDocument/2006/relationships" xmlns:a="http://schemas.openxmlformats.org/drawingml/2006/main" r:embed="Rc79388a329064a36">
+          <a:blip xmlns:r="http://schemas.openxmlformats.org/officeDocument/2006/relationships" xmlns:a="http://schemas.openxmlformats.org/drawingml/2006/main" r:embed="R3f09fe187fe44a81">
             <a:alphaModFix/>
           </a:blip>
           <a:stretch xmlns:a="http://schemas.openxmlformats.org/drawingml/2006/main">
@@ -22203,7 +22384,7 @@
           <p:cNvPr id="110" name="Google Shape;110;p20">
             <a:extLst xmlns:a="http://schemas.openxmlformats.org/drawingml/2006/main">
               <a:ext uri="{FF2B5EF4-FFF2-40B4-BE49-F238E27FC236}">
-                <a16:creationId xmlns:a16="http://schemas.microsoft.com/office/drawing/2014/main" id="{33AA3392-7F59-4D09-A114-001B52C3825F}"/>
+                <a16:creationId xmlns:a16="http://schemas.microsoft.com/office/drawing/2014/main" id="{4121A351-0BD1-40BA-A05B-CD3A5A8F293E}"/>
               </a:ext>
             </a:extLst>
           </p:cNvPr>
@@ -22254,7 +22435,7 @@
           <p:cNvPr id="111" name="Google Shape;111;p20">
             <a:extLst xmlns:a="http://schemas.openxmlformats.org/drawingml/2006/main">
               <a:ext uri="{FF2B5EF4-FFF2-40B4-BE49-F238E27FC236}">
-                <a16:creationId xmlns:a16="http://schemas.microsoft.com/office/drawing/2014/main" id="{14F617F4-9AE8-4B71-8056-22D6F4104C30}"/>
+                <a16:creationId xmlns:a16="http://schemas.microsoft.com/office/drawing/2014/main" id="{54CAB5C2-1C77-4230-9EDE-C1A3FE4ADCE4}"/>
               </a:ext>
             </a:extLst>
           </p:cNvPr>
@@ -22312,7 +22493,7 @@
           <p:cNvPr id="112" name="browser">
             <a:extLst xmlns:a="http://schemas.openxmlformats.org/drawingml/2006/main">
               <a:ext uri="{FF2B5EF4-FFF2-40B4-BE49-F238E27FC236}">
-                <a16:creationId xmlns:a16="http://schemas.microsoft.com/office/drawing/2014/main" id="{F1D83A37-49F1-4183-A2B9-EBBBCAFE17CE}"/>
+                <a16:creationId xmlns:a16="http://schemas.microsoft.com/office/drawing/2014/main" id="{1B169691-CCFA-4294-B71B-E7BFDFB2118B}"/>
               </a:ext>
             </a:extLst>
           </p:cNvPr>
@@ -22344,7 +22525,7 @@
           <p:cNvPr id="113" name="browser-label">
             <a:extLst xmlns:a="http://schemas.openxmlformats.org/drawingml/2006/main">
               <a:ext uri="{FF2B5EF4-FFF2-40B4-BE49-F238E27FC236}">
-                <a16:creationId xmlns:a16="http://schemas.microsoft.com/office/drawing/2014/main" id="{E8D5762A-7878-4ADF-A334-65F0C932D92B}"/>
+                <a16:creationId xmlns:a16="http://schemas.microsoft.com/office/drawing/2014/main" id="{9387F85F-D47A-460B-8E4D-8A807E56B48B}"/>
               </a:ext>
             </a:extLst>
           </p:cNvPr>
@@ -22502,7 +22683,7 @@
           <p:cNvPr id="114" name="browser-sub">
             <a:extLst xmlns:a="http://schemas.openxmlformats.org/drawingml/2006/main">
               <a:ext uri="{FF2B5EF4-FFF2-40B4-BE49-F238E27FC236}">
-                <a16:creationId xmlns:a16="http://schemas.microsoft.com/office/drawing/2014/main" id="{BAD84B4A-3AE9-4D03-B2DA-235E2423EC7C}"/>
+                <a16:creationId xmlns:a16="http://schemas.microsoft.com/office/drawing/2014/main" id="{CEE3E55A-2533-4C88-A53C-60385D592FC3}"/>
               </a:ext>
             </a:extLst>
           </p:cNvPr>
@@ -22660,7 +22841,7 @@
           <p:cNvPr id="115" name="api">
             <a:extLst xmlns:a="http://schemas.openxmlformats.org/drawingml/2006/main">
               <a:ext uri="{FF2B5EF4-FFF2-40B4-BE49-F238E27FC236}">
-                <a16:creationId xmlns:a16="http://schemas.microsoft.com/office/drawing/2014/main" id="{307E0402-97F5-49E0-AE3E-990866A3AECE}"/>
+                <a16:creationId xmlns:a16="http://schemas.microsoft.com/office/drawing/2014/main" id="{EFFD64F3-CB14-48F4-B602-B889239C8EBF}"/>
               </a:ext>
             </a:extLst>
           </p:cNvPr>
@@ -22692,7 +22873,7 @@
           <p:cNvPr id="116" name="api-label">
             <a:extLst xmlns:a="http://schemas.openxmlformats.org/drawingml/2006/main">
               <a:ext uri="{FF2B5EF4-FFF2-40B4-BE49-F238E27FC236}">
-                <a16:creationId xmlns:a16="http://schemas.microsoft.com/office/drawing/2014/main" id="{3D81EB1A-B895-435B-8CA5-B8E9B4003D05}"/>
+                <a16:creationId xmlns:a16="http://schemas.microsoft.com/office/drawing/2014/main" id="{2E923124-E00D-40BB-8305-9283EEE13C72}"/>
               </a:ext>
             </a:extLst>
           </p:cNvPr>
@@ -22850,7 +23031,7 @@
           <p:cNvPr id="117" name="api-sub">
             <a:extLst xmlns:a="http://schemas.openxmlformats.org/drawingml/2006/main">
               <a:ext uri="{FF2B5EF4-FFF2-40B4-BE49-F238E27FC236}">
-                <a16:creationId xmlns:a16="http://schemas.microsoft.com/office/drawing/2014/main" id="{86A576AA-0409-4FCF-B9E9-C7BB18E6F0FD}"/>
+                <a16:creationId xmlns:a16="http://schemas.microsoft.com/office/drawing/2014/main" id="{C3E02FC7-F57F-44FB-BD13-4B1770215BDB}"/>
               </a:ext>
             </a:extLst>
           </p:cNvPr>
@@ -23008,7 +23189,7 @@
           <p:cNvPr id="118" name="data">
             <a:extLst xmlns:a="http://schemas.openxmlformats.org/drawingml/2006/main">
               <a:ext uri="{FF2B5EF4-FFF2-40B4-BE49-F238E27FC236}">
-                <a16:creationId xmlns:a16="http://schemas.microsoft.com/office/drawing/2014/main" id="{FACF0958-51B5-4E56-AC70-6A2DD55AD071}"/>
+                <a16:creationId xmlns:a16="http://schemas.microsoft.com/office/drawing/2014/main" id="{9F84BD00-6A0B-461F-8FD8-6DCAAC8DC913}"/>
               </a:ext>
             </a:extLst>
           </p:cNvPr>
@@ -23040,7 +23221,7 @@
           <p:cNvPr id="119" name="data-label">
             <a:extLst xmlns:a="http://schemas.openxmlformats.org/drawingml/2006/main">
               <a:ext uri="{FF2B5EF4-FFF2-40B4-BE49-F238E27FC236}">
-                <a16:creationId xmlns:a16="http://schemas.microsoft.com/office/drawing/2014/main" id="{AEC5E49C-59CC-44D4-B6F1-29824C23ECBA}"/>
+                <a16:creationId xmlns:a16="http://schemas.microsoft.com/office/drawing/2014/main" id="{5B7D0BE1-A322-4BAB-91AD-B422CD6DA0C1}"/>
               </a:ext>
             </a:extLst>
           </p:cNvPr>
@@ -23198,7 +23379,7 @@
           <p:cNvPr id="120" name="data-sub">
             <a:extLst xmlns:a="http://schemas.openxmlformats.org/drawingml/2006/main">
               <a:ext uri="{FF2B5EF4-FFF2-40B4-BE49-F238E27FC236}">
-                <a16:creationId xmlns:a16="http://schemas.microsoft.com/office/drawing/2014/main" id="{1268D6AF-E542-4AC1-B8A8-14561CE10930}"/>
+                <a16:creationId xmlns:a16="http://schemas.microsoft.com/office/drawing/2014/main" id="{E0AB68DB-D5F0-4823-A1BA-711216AA4D98}"/>
               </a:ext>
             </a:extLst>
           </p:cNvPr>
@@ -23356,7 +23537,7 @@
           <p:cNvPr id="121" name="">
             <a:extLst xmlns:a="http://schemas.openxmlformats.org/drawingml/2006/main">
               <a:ext uri="{FF2B5EF4-FFF2-40B4-BE49-F238E27FC236}">
-                <a16:creationId xmlns:a16="http://schemas.microsoft.com/office/drawing/2014/main" id="{A4CA78B7-8D28-4A82-A9F2-F6ACF2D17E9B}"/>
+                <a16:creationId xmlns:a16="http://schemas.microsoft.com/office/drawing/2014/main" id="{D5013B7C-B133-4C73-9EC5-B4C6D7CB9C77}"/>
               </a:ext>
             </a:extLst>
           </p:cNvPr>
@@ -23388,7 +23569,7 @@
           <p:cNvPr id="122" name="">
             <a:extLst xmlns:a="http://schemas.openxmlformats.org/drawingml/2006/main">
               <a:ext uri="{FF2B5EF4-FFF2-40B4-BE49-F238E27FC236}">
-                <a16:creationId xmlns:a16="http://schemas.microsoft.com/office/drawing/2014/main" id="{1A3247FC-1808-4731-97F4-B8D041076C92}"/>
+                <a16:creationId xmlns:a16="http://schemas.microsoft.com/office/drawing/2014/main" id="{5D53D66A-7B23-48EE-85B3-9C2413B0F196}"/>
               </a:ext>
             </a:extLst>
           </p:cNvPr>
@@ -23420,7 +23601,7 @@
           <p:cNvPr id="123" name="identity">
             <a:extLst xmlns:a="http://schemas.openxmlformats.org/drawingml/2006/main">
               <a:ext uri="{FF2B5EF4-FFF2-40B4-BE49-F238E27FC236}">
-                <a16:creationId xmlns:a16="http://schemas.microsoft.com/office/drawing/2014/main" id="{D876A52B-ED05-4B7A-AAB8-25884477AB93}"/>
+                <a16:creationId xmlns:a16="http://schemas.microsoft.com/office/drawing/2014/main" id="{34DB2FF2-064E-4DA6-B10C-0C9142758F28}"/>
               </a:ext>
             </a:extLst>
           </p:cNvPr>
@@ -23452,7 +23633,7 @@
           <p:cNvPr id="124" name="identity-label">
             <a:extLst xmlns:a="http://schemas.openxmlformats.org/drawingml/2006/main">
               <a:ext uri="{FF2B5EF4-FFF2-40B4-BE49-F238E27FC236}">
-                <a16:creationId xmlns:a16="http://schemas.microsoft.com/office/drawing/2014/main" id="{13AFDE17-2A1C-4EB2-87B0-790A648F0600}"/>
+                <a16:creationId xmlns:a16="http://schemas.microsoft.com/office/drawing/2014/main" id="{65B97A97-7CFC-4413-99C6-447968B0BB56}"/>
               </a:ext>
             </a:extLst>
           </p:cNvPr>
@@ -23610,7 +23791,7 @@
           <p:cNvPr id="125" name="identity-sub">
             <a:extLst xmlns:a="http://schemas.openxmlformats.org/drawingml/2006/main">
               <a:ext uri="{FF2B5EF4-FFF2-40B4-BE49-F238E27FC236}">
-                <a16:creationId xmlns:a16="http://schemas.microsoft.com/office/drawing/2014/main" id="{16CE0760-8F4A-4CF7-8B8F-F1EEFB9AD3E8}"/>
+                <a16:creationId xmlns:a16="http://schemas.microsoft.com/office/drawing/2014/main" id="{D0216503-3641-430C-AC93-30EDE7C968FE}"/>
               </a:ext>
             </a:extLst>
           </p:cNvPr>
@@ -23768,7 +23949,7 @@
           <p:cNvPr id="126" name="ai">
             <a:extLst xmlns:a="http://schemas.openxmlformats.org/drawingml/2006/main">
               <a:ext uri="{FF2B5EF4-FFF2-40B4-BE49-F238E27FC236}">
-                <a16:creationId xmlns:a16="http://schemas.microsoft.com/office/drawing/2014/main" id="{E626D956-70AD-4EF1-B815-BD0F95551F17}"/>
+                <a16:creationId xmlns:a16="http://schemas.microsoft.com/office/drawing/2014/main" id="{99D2CD80-EAB2-406F-958C-4B8E0D44A68A}"/>
               </a:ext>
             </a:extLst>
           </p:cNvPr>
@@ -23800,7 +23981,7 @@
           <p:cNvPr id="127" name="ai-label">
             <a:extLst xmlns:a="http://schemas.openxmlformats.org/drawingml/2006/main">
               <a:ext uri="{FF2B5EF4-FFF2-40B4-BE49-F238E27FC236}">
-                <a16:creationId xmlns:a16="http://schemas.microsoft.com/office/drawing/2014/main" id="{F6ECDBD6-A0D0-4734-9B9B-D19E30068C47}"/>
+                <a16:creationId xmlns:a16="http://schemas.microsoft.com/office/drawing/2014/main" id="{4072CC2A-C32E-4D2E-B9B3-3812263D0B68}"/>
               </a:ext>
             </a:extLst>
           </p:cNvPr>
@@ -23958,7 +24139,7 @@
           <p:cNvPr id="128" name="ai-sub">
             <a:extLst xmlns:a="http://schemas.openxmlformats.org/drawingml/2006/main">
               <a:ext uri="{FF2B5EF4-FFF2-40B4-BE49-F238E27FC236}">
-                <a16:creationId xmlns:a16="http://schemas.microsoft.com/office/drawing/2014/main" id="{1A61C442-CDA6-41F9-8EBE-9D7FC22403D1}"/>
+                <a16:creationId xmlns:a16="http://schemas.microsoft.com/office/drawing/2014/main" id="{0FC65709-6C23-4956-94C9-94F561C25C43}"/>
               </a:ext>
             </a:extLst>
           </p:cNvPr>
@@ -24116,7 +24297,7 @@
           <p:cNvPr id="129" name="core">
             <a:extLst xmlns:a="http://schemas.openxmlformats.org/drawingml/2006/main">
               <a:ext uri="{FF2B5EF4-FFF2-40B4-BE49-F238E27FC236}">
-                <a16:creationId xmlns:a16="http://schemas.microsoft.com/office/drawing/2014/main" id="{5720ED9C-CF2D-4009-867B-E1DAA481A2C7}"/>
+                <a16:creationId xmlns:a16="http://schemas.microsoft.com/office/drawing/2014/main" id="{A1797110-52B3-4B2F-B95D-825232A6E9E2}"/>
               </a:ext>
             </a:extLst>
           </p:cNvPr>
@@ -24148,7 +24329,7 @@
           <p:cNvPr id="130" name="core-label">
             <a:extLst xmlns:a="http://schemas.openxmlformats.org/drawingml/2006/main">
               <a:ext uri="{FF2B5EF4-FFF2-40B4-BE49-F238E27FC236}">
-                <a16:creationId xmlns:a16="http://schemas.microsoft.com/office/drawing/2014/main" id="{C02C9BC3-FCCC-481C-807D-59D59D8B775C}"/>
+                <a16:creationId xmlns:a16="http://schemas.microsoft.com/office/drawing/2014/main" id="{B6EAE53C-A378-4CE0-B9F1-3049D608D86D}"/>
               </a:ext>
             </a:extLst>
           </p:cNvPr>
@@ -24306,7 +24487,7 @@
           <p:cNvPr id="131" name="core-sub">
             <a:extLst xmlns:a="http://schemas.openxmlformats.org/drawingml/2006/main">
               <a:ext uri="{FF2B5EF4-FFF2-40B4-BE49-F238E27FC236}">
-                <a16:creationId xmlns:a16="http://schemas.microsoft.com/office/drawing/2014/main" id="{8AF97325-EB80-4234-93DF-07C3255F7B2F}"/>
+                <a16:creationId xmlns:a16="http://schemas.microsoft.com/office/drawing/2014/main" id="{036EBD7B-5939-4683-A2CA-7A26E255D97F}"/>
               </a:ext>
             </a:extLst>
           </p:cNvPr>
@@ -24464,7 +24645,7 @@
           <p:cNvPr id="132" name="">
             <a:extLst xmlns:a="http://schemas.openxmlformats.org/drawingml/2006/main">
               <a:ext uri="{FF2B5EF4-FFF2-40B4-BE49-F238E27FC236}">
-                <a16:creationId xmlns:a16="http://schemas.microsoft.com/office/drawing/2014/main" id="{BB8EED01-14F8-4B2A-9A20-136523BFC460}"/>
+                <a16:creationId xmlns:a16="http://schemas.microsoft.com/office/drawing/2014/main" id="{F2A089AB-5FE5-4ABD-BF3B-3A7CF2F18653}"/>
               </a:ext>
             </a:extLst>
           </p:cNvPr>
@@ -24496,7 +24677,7 @@
           <p:cNvPr id="133" name="">
             <a:extLst xmlns:a="http://schemas.openxmlformats.org/drawingml/2006/main">
               <a:ext uri="{FF2B5EF4-FFF2-40B4-BE49-F238E27FC236}">
-                <a16:creationId xmlns:a16="http://schemas.microsoft.com/office/drawing/2014/main" id="{B7A0CC76-6584-4EFB-93CD-7B9EAE561A20}"/>
+                <a16:creationId xmlns:a16="http://schemas.microsoft.com/office/drawing/2014/main" id="{5D45BC80-B068-4873-A7C1-35F5974AFA6A}"/>
               </a:ext>
             </a:extLst>
           </p:cNvPr>
@@ -24528,7 +24709,7 @@
           <p:cNvPr id="134" name="architecture-note">
             <a:extLst xmlns:a="http://schemas.openxmlformats.org/drawingml/2006/main">
               <a:ext uri="{FF2B5EF4-FFF2-40B4-BE49-F238E27FC236}">
-                <a16:creationId xmlns:a16="http://schemas.microsoft.com/office/drawing/2014/main" id="{0EC1F130-0159-474A-B732-3EB5EEE8D60F}"/>
+                <a16:creationId xmlns:a16="http://schemas.microsoft.com/office/drawing/2014/main" id="{68D6F710-AB4E-4480-996E-D5C34581A7A1}"/>
               </a:ext>
             </a:extLst>
           </p:cNvPr>
@@ -24684,7 +24865,7 @@
     </p:spTree>
     <p:extLst>
       <p:ext uri="{BB962C8B-B14F-4D97-AF65-F5344CB8AC3E}">
-        <p14:creationId xmlns:p14="http://schemas.microsoft.com/office/powerpoint/2010/main" val="1723022087"/>
+        <p14:creationId xmlns:p14="http://schemas.microsoft.com/office/powerpoint/2010/main" val="1066052537"/>
       </p:ext>
     </p:extLst>
   </p:cSld>
@@ -24708,7 +24889,7 @@
           <p:cNvPr id="116" name="Google Shape;116;p21">
             <a:extLst xmlns:a="http://schemas.openxmlformats.org/drawingml/2006/main">
               <a:ext uri="{FF2B5EF4-FFF2-40B4-BE49-F238E27FC236}">
-                <a16:creationId xmlns:a16="http://schemas.microsoft.com/office/drawing/2014/main" id="{840A1EA4-6708-482D-81C4-B5134D7DFD8C}"/>
+                <a16:creationId xmlns:a16="http://schemas.microsoft.com/office/drawing/2014/main" id="{74560A73-29E2-4521-A561-A87650646F52}"/>
               </a:ext>
             </a:extLst>
           </p:cNvPr>
@@ -24718,7 +24899,7 @@
           <p:nvPr/>
         </p:nvPicPr>
         <p:blipFill rotWithShape="1">
-          <a:blip xmlns:r="http://schemas.openxmlformats.org/officeDocument/2006/relationships" xmlns:a="http://schemas.openxmlformats.org/drawingml/2006/main" r:embed="Re37345d17f4342b5">
+          <a:blip xmlns:r="http://schemas.openxmlformats.org/officeDocument/2006/relationships" xmlns:a="http://schemas.openxmlformats.org/drawingml/2006/main" r:embed="R429f578eae9c403c">
             <a:alphaModFix/>
           </a:blip>
           <a:srcRect xmlns:a="http://schemas.openxmlformats.org/drawingml/2006/main" l="0" t="0" r="0" b="98001"/>
@@ -24742,7 +24923,7 @@
           <p:cNvPr id="117" name="Google Shape;117;p21">
             <a:extLst xmlns:a="http://schemas.openxmlformats.org/drawingml/2006/main">
               <a:ext uri="{FF2B5EF4-FFF2-40B4-BE49-F238E27FC236}">
-                <a16:creationId xmlns:a16="http://schemas.microsoft.com/office/drawing/2014/main" id="{991CC613-8101-4968-B2B2-A86844808E87}"/>
+                <a16:creationId xmlns:a16="http://schemas.microsoft.com/office/drawing/2014/main" id="{6BB6F0E4-753D-483D-BEBB-1C223C1FB547}"/>
               </a:ext>
             </a:extLst>
           </p:cNvPr>
@@ -24752,7 +24933,7 @@
           <p:nvPr/>
         </p:nvPicPr>
         <p:blipFill>
-          <a:blip xmlns:r="http://schemas.openxmlformats.org/officeDocument/2006/relationships" xmlns:a="http://schemas.openxmlformats.org/drawingml/2006/main" r:embed="R3a41610fc2694bdf">
+          <a:blip xmlns:r="http://schemas.openxmlformats.org/officeDocument/2006/relationships" xmlns:a="http://schemas.openxmlformats.org/drawingml/2006/main" r:embed="Reb525b169f2c401a">
             <a:alphaModFix/>
           </a:blip>
           <a:stretch xmlns:a="http://schemas.openxmlformats.org/drawingml/2006/main">
@@ -24777,7 +24958,7 @@
           <p:cNvPr id="118" name="Google Shape;118;p21">
             <a:extLst xmlns:a="http://schemas.openxmlformats.org/drawingml/2006/main">
               <a:ext uri="{FF2B5EF4-FFF2-40B4-BE49-F238E27FC236}">
-                <a16:creationId xmlns:a16="http://schemas.microsoft.com/office/drawing/2014/main" id="{8DC7F20E-FE0C-4DB7-9305-9C7FDD16291F}"/>
+                <a16:creationId xmlns:a16="http://schemas.microsoft.com/office/drawing/2014/main" id="{F414A483-B210-4DC8-AC7B-6E03C39664B1}"/>
               </a:ext>
             </a:extLst>
           </p:cNvPr>
@@ -24828,7 +25009,7 @@
           <p:cNvPr id="119" name="Google Shape;119;p21">
             <a:extLst xmlns:a="http://schemas.openxmlformats.org/drawingml/2006/main">
               <a:ext uri="{FF2B5EF4-FFF2-40B4-BE49-F238E27FC236}">
-                <a16:creationId xmlns:a16="http://schemas.microsoft.com/office/drawing/2014/main" id="{9544B0C1-4DA6-49C4-B9FA-4CDDD039B0DA}"/>
+                <a16:creationId xmlns:a16="http://schemas.microsoft.com/office/drawing/2014/main" id="{5FF7A927-72DB-4766-A9FC-8264B7131ED7}"/>
               </a:ext>
             </a:extLst>
           </p:cNvPr>
@@ -24886,7 +25067,7 @@
           <p:cNvPr id="120" name="tech-a-0">
             <a:extLst xmlns:a="http://schemas.openxmlformats.org/drawingml/2006/main">
               <a:ext uri="{FF2B5EF4-FFF2-40B4-BE49-F238E27FC236}">
-                <a16:creationId xmlns:a16="http://schemas.microsoft.com/office/drawing/2014/main" id="{12413AC3-0A24-4B33-ADBA-960EC6ADC54E}"/>
+                <a16:creationId xmlns:a16="http://schemas.microsoft.com/office/drawing/2014/main" id="{4D9159B4-EC59-43B6-917F-1B29D750B6B2}"/>
               </a:ext>
             </a:extLst>
           </p:cNvPr>
@@ -25044,7 +25225,7 @@
           <p:cNvPr id="121" name="tech-b-0">
             <a:extLst xmlns:a="http://schemas.openxmlformats.org/drawingml/2006/main">
               <a:ext uri="{FF2B5EF4-FFF2-40B4-BE49-F238E27FC236}">
-                <a16:creationId xmlns:a16="http://schemas.microsoft.com/office/drawing/2014/main" id="{D256E9CC-FE85-44FB-9CF4-60128FA112B9}"/>
+                <a16:creationId xmlns:a16="http://schemas.microsoft.com/office/drawing/2014/main" id="{B63918D8-2287-43ED-A7C5-F64396660345}"/>
               </a:ext>
             </a:extLst>
           </p:cNvPr>
@@ -25202,7 +25383,7 @@
           <p:cNvPr id="122" name="tech-line-0">
             <a:extLst xmlns:a="http://schemas.openxmlformats.org/drawingml/2006/main">
               <a:ext uri="{FF2B5EF4-FFF2-40B4-BE49-F238E27FC236}">
-                <a16:creationId xmlns:a16="http://schemas.microsoft.com/office/drawing/2014/main" id="{F531E05D-8949-43D9-BC09-34C07170E1A1}"/>
+                <a16:creationId xmlns:a16="http://schemas.microsoft.com/office/drawing/2014/main" id="{94A65C83-DD09-406F-97EC-4743F052A4C6}"/>
               </a:ext>
             </a:extLst>
           </p:cNvPr>
@@ -25234,7 +25415,7 @@
           <p:cNvPr id="123" name="tech-a-1">
             <a:extLst xmlns:a="http://schemas.openxmlformats.org/drawingml/2006/main">
               <a:ext uri="{FF2B5EF4-FFF2-40B4-BE49-F238E27FC236}">
-                <a16:creationId xmlns:a16="http://schemas.microsoft.com/office/drawing/2014/main" id="{A17EAB4B-51DC-4A5D-94A1-25A03E6ABA0B}"/>
+                <a16:creationId xmlns:a16="http://schemas.microsoft.com/office/drawing/2014/main" id="{489CC8E4-9398-4C74-ABD3-CDAC32B32040}"/>
               </a:ext>
             </a:extLst>
           </p:cNvPr>
@@ -25392,7 +25573,7 @@
           <p:cNvPr id="124" name="tech-b-1">
             <a:extLst xmlns:a="http://schemas.openxmlformats.org/drawingml/2006/main">
               <a:ext uri="{FF2B5EF4-FFF2-40B4-BE49-F238E27FC236}">
-                <a16:creationId xmlns:a16="http://schemas.microsoft.com/office/drawing/2014/main" id="{7F43E727-B2A3-4F72-AC3A-B30AFFC1CED9}"/>
+                <a16:creationId xmlns:a16="http://schemas.microsoft.com/office/drawing/2014/main" id="{F3097206-70AB-4D1B-BE6B-8B97C1239234}"/>
               </a:ext>
             </a:extLst>
           </p:cNvPr>
@@ -25550,7 +25731,7 @@
           <p:cNvPr id="125" name="tech-line-1">
             <a:extLst xmlns:a="http://schemas.openxmlformats.org/drawingml/2006/main">
               <a:ext uri="{FF2B5EF4-FFF2-40B4-BE49-F238E27FC236}">
-                <a16:creationId xmlns:a16="http://schemas.microsoft.com/office/drawing/2014/main" id="{75E6553F-9CF9-47AF-A1DC-D44E46C7EA6D}"/>
+                <a16:creationId xmlns:a16="http://schemas.microsoft.com/office/drawing/2014/main" id="{793BAC89-A5B0-45AC-B2C3-88E0336CB7E2}"/>
               </a:ext>
             </a:extLst>
           </p:cNvPr>
@@ -25582,7 +25763,7 @@
           <p:cNvPr id="126" name="tech-a-2">
             <a:extLst xmlns:a="http://schemas.openxmlformats.org/drawingml/2006/main">
               <a:ext uri="{FF2B5EF4-FFF2-40B4-BE49-F238E27FC236}">
-                <a16:creationId xmlns:a16="http://schemas.microsoft.com/office/drawing/2014/main" id="{66F0A325-823E-4D8E-BD74-2B15E3411AAD}"/>
+                <a16:creationId xmlns:a16="http://schemas.microsoft.com/office/drawing/2014/main" id="{E8B6A6F4-CE2A-4EAC-89DF-A25C0726905F}"/>
               </a:ext>
             </a:extLst>
           </p:cNvPr>
@@ -25740,7 +25921,7 @@
           <p:cNvPr id="127" name="tech-b-2">
             <a:extLst xmlns:a="http://schemas.openxmlformats.org/drawingml/2006/main">
               <a:ext uri="{FF2B5EF4-FFF2-40B4-BE49-F238E27FC236}">
-                <a16:creationId xmlns:a16="http://schemas.microsoft.com/office/drawing/2014/main" id="{D8F6A6C2-C990-4CE0-9718-CA84614B03D6}"/>
+                <a16:creationId xmlns:a16="http://schemas.microsoft.com/office/drawing/2014/main" id="{D15329A0-5780-4C34-B8AA-04D8FE52B1A9}"/>
               </a:ext>
             </a:extLst>
           </p:cNvPr>
@@ -25898,7 +26079,7 @@
           <p:cNvPr id="128" name="tech-line-2">
             <a:extLst xmlns:a="http://schemas.openxmlformats.org/drawingml/2006/main">
               <a:ext uri="{FF2B5EF4-FFF2-40B4-BE49-F238E27FC236}">
-                <a16:creationId xmlns:a16="http://schemas.microsoft.com/office/drawing/2014/main" id="{1600381F-C345-4A3B-980B-09439C464A4F}"/>
+                <a16:creationId xmlns:a16="http://schemas.microsoft.com/office/drawing/2014/main" id="{DA768DE6-2A30-43C9-93B2-30494569690F}"/>
               </a:ext>
             </a:extLst>
           </p:cNvPr>
@@ -25930,7 +26111,7 @@
           <p:cNvPr id="129" name="tech-a-3">
             <a:extLst xmlns:a="http://schemas.openxmlformats.org/drawingml/2006/main">
               <a:ext uri="{FF2B5EF4-FFF2-40B4-BE49-F238E27FC236}">
-                <a16:creationId xmlns:a16="http://schemas.microsoft.com/office/drawing/2014/main" id="{D5283C6D-E2C6-4F48-88F1-3F2EE6EACCAF}"/>
+                <a16:creationId xmlns:a16="http://schemas.microsoft.com/office/drawing/2014/main" id="{7207DD82-ACB3-4E46-BD66-FFE9C1917917}"/>
               </a:ext>
             </a:extLst>
           </p:cNvPr>
@@ -26088,7 +26269,7 @@
           <p:cNvPr id="130" name="tech-b-3">
             <a:extLst xmlns:a="http://schemas.openxmlformats.org/drawingml/2006/main">
               <a:ext uri="{FF2B5EF4-FFF2-40B4-BE49-F238E27FC236}">
-                <a16:creationId xmlns:a16="http://schemas.microsoft.com/office/drawing/2014/main" id="{6B4B45AA-95F9-4D2D-9F73-0EC0D1449879}"/>
+                <a16:creationId xmlns:a16="http://schemas.microsoft.com/office/drawing/2014/main" id="{AE6DD89A-36FA-4F41-9B54-15C5611C3DE2}"/>
               </a:ext>
             </a:extLst>
           </p:cNvPr>
@@ -26246,7 +26427,7 @@
           <p:cNvPr id="131" name="tech-line-3">
             <a:extLst xmlns:a="http://schemas.openxmlformats.org/drawingml/2006/main">
               <a:ext uri="{FF2B5EF4-FFF2-40B4-BE49-F238E27FC236}">
-                <a16:creationId xmlns:a16="http://schemas.microsoft.com/office/drawing/2014/main" id="{FDAFD855-6AC9-42DB-B719-9F037839C700}"/>
+                <a16:creationId xmlns:a16="http://schemas.microsoft.com/office/drawing/2014/main" id="{26853F4A-6566-4676-8CD3-6E021E567F47}"/>
               </a:ext>
             </a:extLst>
           </p:cNvPr>
@@ -26278,7 +26459,7 @@
           <p:cNvPr id="132" name="tech-a-4">
             <a:extLst xmlns:a="http://schemas.openxmlformats.org/drawingml/2006/main">
               <a:ext uri="{FF2B5EF4-FFF2-40B4-BE49-F238E27FC236}">
-                <a16:creationId xmlns:a16="http://schemas.microsoft.com/office/drawing/2014/main" id="{5B6CA4A4-AE96-44D0-8820-17D8EAE8DDEF}"/>
+                <a16:creationId xmlns:a16="http://schemas.microsoft.com/office/drawing/2014/main" id="{C4539B61-50C9-4271-B80D-F8878C34C88A}"/>
               </a:ext>
             </a:extLst>
           </p:cNvPr>
@@ -26436,7 +26617,7 @@
           <p:cNvPr id="133" name="tech-b-4">
             <a:extLst xmlns:a="http://schemas.openxmlformats.org/drawingml/2006/main">
               <a:ext uri="{FF2B5EF4-FFF2-40B4-BE49-F238E27FC236}">
-                <a16:creationId xmlns:a16="http://schemas.microsoft.com/office/drawing/2014/main" id="{9BC9F30A-EBD4-42C9-987A-CB445F1A6F8C}"/>
+                <a16:creationId xmlns:a16="http://schemas.microsoft.com/office/drawing/2014/main" id="{C2F12302-4B89-46CC-B709-0598CAB553E8}"/>
               </a:ext>
             </a:extLst>
           </p:cNvPr>
@@ -26594,7 +26775,7 @@
           <p:cNvPr id="134" name="tech-line-4">
             <a:extLst xmlns:a="http://schemas.openxmlformats.org/drawingml/2006/main">
               <a:ext uri="{FF2B5EF4-FFF2-40B4-BE49-F238E27FC236}">
-                <a16:creationId xmlns:a16="http://schemas.microsoft.com/office/drawing/2014/main" id="{F19E458A-891E-4F43-AB61-F1B9CDE42361}"/>
+                <a16:creationId xmlns:a16="http://schemas.microsoft.com/office/drawing/2014/main" id="{E1C724B4-7BD8-44AE-B105-738282C82DE4}"/>
               </a:ext>
             </a:extLst>
           </p:cNvPr>
@@ -26626,7 +26807,7 @@
           <p:cNvPr id="135" name="tech-a-5">
             <a:extLst xmlns:a="http://schemas.openxmlformats.org/drawingml/2006/main">
               <a:ext uri="{FF2B5EF4-FFF2-40B4-BE49-F238E27FC236}">
-                <a16:creationId xmlns:a16="http://schemas.microsoft.com/office/drawing/2014/main" id="{1998467C-4AFE-4D9B-90D0-631732E9E409}"/>
+                <a16:creationId xmlns:a16="http://schemas.microsoft.com/office/drawing/2014/main" id="{3D2CFFAA-2374-4503-8AB0-CC270E38E187}"/>
               </a:ext>
             </a:extLst>
           </p:cNvPr>
@@ -26784,7 +26965,7 @@
           <p:cNvPr id="136" name="tech-b-5">
             <a:extLst xmlns:a="http://schemas.openxmlformats.org/drawingml/2006/main">
               <a:ext uri="{FF2B5EF4-FFF2-40B4-BE49-F238E27FC236}">
-                <a16:creationId xmlns:a16="http://schemas.microsoft.com/office/drawing/2014/main" id="{777F7BA7-F6D2-412A-9F6F-6099F8F1305F}"/>
+                <a16:creationId xmlns:a16="http://schemas.microsoft.com/office/drawing/2014/main" id="{D324777B-9CD6-4595-BDA2-4EEC56020ECC}"/>
               </a:ext>
             </a:extLst>
           </p:cNvPr>
@@ -26940,7 +27121,7 @@
     </p:spTree>
     <p:extLst>
       <p:ext uri="{BB962C8B-B14F-4D97-AF65-F5344CB8AC3E}">
-        <p14:creationId xmlns:p14="http://schemas.microsoft.com/office/powerpoint/2010/main" val="1621338360"/>
+        <p14:creationId xmlns:p14="http://schemas.microsoft.com/office/powerpoint/2010/main" val="1425137542"/>
       </p:ext>
     </p:extLst>
   </p:cSld>
@@ -26964,7 +27145,7 @@
           <p:cNvPr id="124" name="Google Shape;124;p22">
             <a:extLst xmlns:a="http://schemas.openxmlformats.org/drawingml/2006/main">
               <a:ext uri="{FF2B5EF4-FFF2-40B4-BE49-F238E27FC236}">
-                <a16:creationId xmlns:a16="http://schemas.microsoft.com/office/drawing/2014/main" id="{ADE9B8C4-97C3-465C-BF0D-A6FA7A591A22}"/>
+                <a16:creationId xmlns:a16="http://schemas.microsoft.com/office/drawing/2014/main" id="{2CC67496-3C94-4FFA-B716-E8A708AE6732}"/>
               </a:ext>
             </a:extLst>
           </p:cNvPr>
@@ -26974,7 +27155,7 @@
           <p:nvPr/>
         </p:nvPicPr>
         <p:blipFill rotWithShape="1">
-          <a:blip xmlns:r="http://schemas.openxmlformats.org/officeDocument/2006/relationships" xmlns:a="http://schemas.openxmlformats.org/drawingml/2006/main" r:embed="Rf1bf1cdc70594900">
+          <a:blip xmlns:r="http://schemas.openxmlformats.org/officeDocument/2006/relationships" xmlns:a="http://schemas.openxmlformats.org/drawingml/2006/main" r:embed="R60d41d90f1e34f87">
             <a:alphaModFix/>
           </a:blip>
           <a:srcRect xmlns:a="http://schemas.openxmlformats.org/drawingml/2006/main" l="0" t="0" r="0" b="98001"/>
@@ -26998,7 +27179,7 @@
           <p:cNvPr id="125" name="Google Shape;125;p22">
             <a:extLst xmlns:a="http://schemas.openxmlformats.org/drawingml/2006/main">
               <a:ext uri="{FF2B5EF4-FFF2-40B4-BE49-F238E27FC236}">
-                <a16:creationId xmlns:a16="http://schemas.microsoft.com/office/drawing/2014/main" id="{F9773AE4-D524-4CCC-8E5B-A9C0BF742641}"/>
+                <a16:creationId xmlns:a16="http://schemas.microsoft.com/office/drawing/2014/main" id="{2F073B78-37A4-4407-8142-14DE9D0AEE3B}"/>
               </a:ext>
             </a:extLst>
           </p:cNvPr>
@@ -27008,7 +27189,7 @@
           <p:nvPr/>
         </p:nvPicPr>
         <p:blipFill>
-          <a:blip xmlns:r="http://schemas.openxmlformats.org/officeDocument/2006/relationships" xmlns:a="http://schemas.openxmlformats.org/drawingml/2006/main" r:embed="Redd5cb363c804dd3">
+          <a:blip xmlns:r="http://schemas.openxmlformats.org/officeDocument/2006/relationships" xmlns:a="http://schemas.openxmlformats.org/drawingml/2006/main" r:embed="Rc9eda1a325394824">
             <a:alphaModFix/>
           </a:blip>
           <a:stretch xmlns:a="http://schemas.openxmlformats.org/drawingml/2006/main">
@@ -27033,7 +27214,7 @@
           <p:cNvPr id="126" name="Google Shape;126;p22">
             <a:extLst xmlns:a="http://schemas.openxmlformats.org/drawingml/2006/main">
               <a:ext uri="{FF2B5EF4-FFF2-40B4-BE49-F238E27FC236}">
-                <a16:creationId xmlns:a16="http://schemas.microsoft.com/office/drawing/2014/main" id="{D27B2985-1909-49EF-9BD7-BF424C412875}"/>
+                <a16:creationId xmlns:a16="http://schemas.microsoft.com/office/drawing/2014/main" id="{4CCA0B93-C241-475D-B81D-F53CD40C373C}"/>
               </a:ext>
             </a:extLst>
           </p:cNvPr>
@@ -27084,7 +27265,7 @@
           <p:cNvPr id="127" name="Google Shape;127;p22">
             <a:extLst xmlns:a="http://schemas.openxmlformats.org/drawingml/2006/main">
               <a:ext uri="{FF2B5EF4-FFF2-40B4-BE49-F238E27FC236}">
-                <a16:creationId xmlns:a16="http://schemas.microsoft.com/office/drawing/2014/main" id="{5BB17EB8-C3D6-436C-9E0D-12EECA924C05}"/>
+                <a16:creationId xmlns:a16="http://schemas.microsoft.com/office/drawing/2014/main" id="{ECB0BE0E-23E7-47C6-A2D1-C56F0789F53A}"/>
               </a:ext>
             </a:extLst>
           </p:cNvPr>
@@ -27142,7 +27323,7 @@
           <p:cNvPr id="128" name="cost-head">
             <a:extLst xmlns:a="http://schemas.openxmlformats.org/drawingml/2006/main">
               <a:ext uri="{FF2B5EF4-FFF2-40B4-BE49-F238E27FC236}">
-                <a16:creationId xmlns:a16="http://schemas.microsoft.com/office/drawing/2014/main" id="{15A01AA1-12E6-4D1B-B8DD-E45578E937EF}"/>
+                <a16:creationId xmlns:a16="http://schemas.microsoft.com/office/drawing/2014/main" id="{44606BE2-130D-4492-B639-61BFDBAC2900}"/>
               </a:ext>
             </a:extLst>
           </p:cNvPr>
@@ -27300,7 +27481,7 @@
           <p:cNvPr id="129" name="cost-label-0">
             <a:extLst xmlns:a="http://schemas.openxmlformats.org/drawingml/2006/main">
               <a:ext uri="{FF2B5EF4-FFF2-40B4-BE49-F238E27FC236}">
-                <a16:creationId xmlns:a16="http://schemas.microsoft.com/office/drawing/2014/main" id="{9C7F33BF-548A-4FAD-9605-A0055E64FAFB}"/>
+                <a16:creationId xmlns:a16="http://schemas.microsoft.com/office/drawing/2014/main" id="{99C4D3DB-A06A-404E-8911-57E9E823D902}"/>
               </a:ext>
             </a:extLst>
           </p:cNvPr>
@@ -27458,7 +27639,7 @@
           <p:cNvPr id="130" name="cost-copy-0">
             <a:extLst xmlns:a="http://schemas.openxmlformats.org/drawingml/2006/main">
               <a:ext uri="{FF2B5EF4-FFF2-40B4-BE49-F238E27FC236}">
-                <a16:creationId xmlns:a16="http://schemas.microsoft.com/office/drawing/2014/main" id="{1B11D9B1-11F1-4A27-B16F-ECA84A0F2939}"/>
+                <a16:creationId xmlns:a16="http://schemas.microsoft.com/office/drawing/2014/main" id="{C6C3D1B2-6D95-4FB6-A82F-0809ACDB7E41}"/>
               </a:ext>
             </a:extLst>
           </p:cNvPr>
@@ -27616,7 +27797,7 @@
           <p:cNvPr id="131" name="cost-label-1">
             <a:extLst xmlns:a="http://schemas.openxmlformats.org/drawingml/2006/main">
               <a:ext uri="{FF2B5EF4-FFF2-40B4-BE49-F238E27FC236}">
-                <a16:creationId xmlns:a16="http://schemas.microsoft.com/office/drawing/2014/main" id="{6912BBA4-B522-4422-8284-CC148F3C49E6}"/>
+                <a16:creationId xmlns:a16="http://schemas.microsoft.com/office/drawing/2014/main" id="{E689D6A6-ECEA-4294-8792-30298B53A878}"/>
               </a:ext>
             </a:extLst>
           </p:cNvPr>
@@ -27774,7 +27955,7 @@
           <p:cNvPr id="132" name="cost-copy-1">
             <a:extLst xmlns:a="http://schemas.openxmlformats.org/drawingml/2006/main">
               <a:ext uri="{FF2B5EF4-FFF2-40B4-BE49-F238E27FC236}">
-                <a16:creationId xmlns:a16="http://schemas.microsoft.com/office/drawing/2014/main" id="{25FECFA2-5DD9-4A39-9302-4C1EACE89FD6}"/>
+                <a16:creationId xmlns:a16="http://schemas.microsoft.com/office/drawing/2014/main" id="{885F31E0-FE40-4530-9057-B002FB1086C8}"/>
               </a:ext>
             </a:extLst>
           </p:cNvPr>
@@ -27932,7 +28113,7 @@
           <p:cNvPr id="133" name="cost-label-2">
             <a:extLst xmlns:a="http://schemas.openxmlformats.org/drawingml/2006/main">
               <a:ext uri="{FF2B5EF4-FFF2-40B4-BE49-F238E27FC236}">
-                <a16:creationId xmlns:a16="http://schemas.microsoft.com/office/drawing/2014/main" id="{DD173F26-C7C6-4562-AA55-6BA19070D984}"/>
+                <a16:creationId xmlns:a16="http://schemas.microsoft.com/office/drawing/2014/main" id="{15C6C96A-26D8-4D12-AFFD-6CDF639CAB9B}"/>
               </a:ext>
             </a:extLst>
           </p:cNvPr>
@@ -28090,7 +28271,7 @@
           <p:cNvPr id="134" name="cost-copy-2">
             <a:extLst xmlns:a="http://schemas.openxmlformats.org/drawingml/2006/main">
               <a:ext uri="{FF2B5EF4-FFF2-40B4-BE49-F238E27FC236}">
-                <a16:creationId xmlns:a16="http://schemas.microsoft.com/office/drawing/2014/main" id="{ACCEE5B8-D32F-4B58-BF0E-1F949C950AF8}"/>
+                <a16:creationId xmlns:a16="http://schemas.microsoft.com/office/drawing/2014/main" id="{91FA992D-4CC8-4AA7-B606-BD643523EF93}"/>
               </a:ext>
             </a:extLst>
           </p:cNvPr>
@@ -28248,7 +28429,7 @@
           <p:cNvPr id="135" name="cost-label-3">
             <a:extLst xmlns:a="http://schemas.openxmlformats.org/drawingml/2006/main">
               <a:ext uri="{FF2B5EF4-FFF2-40B4-BE49-F238E27FC236}">
-                <a16:creationId xmlns:a16="http://schemas.microsoft.com/office/drawing/2014/main" id="{8F9E35ED-974A-40D3-AE18-05CF23338848}"/>
+                <a16:creationId xmlns:a16="http://schemas.microsoft.com/office/drawing/2014/main" id="{16AE197F-9791-4991-A9BC-1343ADA66E7F}"/>
               </a:ext>
             </a:extLst>
           </p:cNvPr>
@@ -28406,7 +28587,7 @@
           <p:cNvPr id="136" name="cost-copy-3">
             <a:extLst xmlns:a="http://schemas.openxmlformats.org/drawingml/2006/main">
               <a:ext uri="{FF2B5EF4-FFF2-40B4-BE49-F238E27FC236}">
-                <a16:creationId xmlns:a16="http://schemas.microsoft.com/office/drawing/2014/main" id="{0928748E-E3F5-409D-9F1F-836202F37B6C}"/>
+                <a16:creationId xmlns:a16="http://schemas.microsoft.com/office/drawing/2014/main" id="{74789944-D1D2-4C86-A715-F147326B1AE1}"/>
               </a:ext>
             </a:extLst>
           </p:cNvPr>
@@ -28564,7 +28745,7 @@
           <p:cNvPr id="137" name="cost-plan">
             <a:extLst xmlns:a="http://schemas.openxmlformats.org/drawingml/2006/main">
               <a:ext uri="{FF2B5EF4-FFF2-40B4-BE49-F238E27FC236}">
-                <a16:creationId xmlns:a16="http://schemas.microsoft.com/office/drawing/2014/main" id="{7F66F860-8069-40F9-92F6-D03CE0FF473B}"/>
+                <a16:creationId xmlns:a16="http://schemas.microsoft.com/office/drawing/2014/main" id="{D618A40C-3096-4C71-9962-EA19A22EF675}"/>
               </a:ext>
             </a:extLst>
           </p:cNvPr>
@@ -28720,7 +28901,7 @@
     </p:spTree>
     <p:extLst>
       <p:ext uri="{BB962C8B-B14F-4D97-AF65-F5344CB8AC3E}">
-        <p14:creationId xmlns:p14="http://schemas.microsoft.com/office/powerpoint/2010/main" val="2139831282"/>
+        <p14:creationId xmlns:p14="http://schemas.microsoft.com/office/powerpoint/2010/main" val="1001309857"/>
       </p:ext>
     </p:extLst>
   </p:cSld>

</xml_diff>